<commit_message>
Draft halfway done - Matt
</commit_message>
<xml_diff>
--- a/presentation.pptx
+++ b/presentation.pptx
@@ -5,25 +5,24 @@
     <p:sldMasterId id="2147483686" r:id="rId4"/>
   </p:sldMasterIdLst>
   <p:notesMasterIdLst>
-    <p:notesMasterId r:id="rId18"/>
+    <p:notesMasterId r:id="rId17"/>
   </p:notesMasterIdLst>
   <p:handoutMasterIdLst>
-    <p:handoutMasterId r:id="rId19"/>
+    <p:handoutMasterId r:id="rId18"/>
   </p:handoutMasterIdLst>
   <p:sldIdLst>
     <p:sldId id="315" r:id="rId5"/>
     <p:sldId id="266" r:id="rId6"/>
-    <p:sldId id="314" r:id="rId7"/>
-    <p:sldId id="271" r:id="rId8"/>
-    <p:sldId id="309" r:id="rId9"/>
-    <p:sldId id="256" r:id="rId10"/>
-    <p:sldId id="312" r:id="rId11"/>
-    <p:sldId id="305" r:id="rId12"/>
-    <p:sldId id="310" r:id="rId13"/>
-    <p:sldId id="316" r:id="rId14"/>
-    <p:sldId id="313" r:id="rId15"/>
-    <p:sldId id="300" r:id="rId16"/>
-    <p:sldId id="295" r:id="rId17"/>
+    <p:sldId id="312" r:id="rId7"/>
+    <p:sldId id="309" r:id="rId8"/>
+    <p:sldId id="314" r:id="rId9"/>
+    <p:sldId id="305" r:id="rId10"/>
+    <p:sldId id="271" r:id="rId11"/>
+    <p:sldId id="310" r:id="rId12"/>
+    <p:sldId id="316" r:id="rId13"/>
+    <p:sldId id="313" r:id="rId14"/>
+    <p:sldId id="300" r:id="rId15"/>
+    <p:sldId id="295" r:id="rId16"/>
   </p:sldIdLst>
   <p:sldSz cx="12192000" cy="6858000"/>
   <p:notesSz cx="6858000" cy="9144000"/>
@@ -123,6 +122,26 @@
     </a:lvl9pPr>
   </p:defaultTextStyle>
   <p:extLst>
+    <p:ext uri="{521415D9-36F7-43E2-AB2F-B90AF26B5E84}">
+      <p14:sectionLst xmlns:p14="http://schemas.microsoft.com/office/powerpoint/2010/main">
+        <p14:section name="Default Section" id="{09200206-63A0-4E29-BBD4-435698AC31B1}">
+          <p14:sldIdLst>
+            <p14:sldId id="315"/>
+            <p14:sldId id="266"/>
+            <p14:sldId id="312"/>
+            <p14:sldId id="309"/>
+            <p14:sldId id="314"/>
+            <p14:sldId id="305"/>
+            <p14:sldId id="271"/>
+            <p14:sldId id="310"/>
+            <p14:sldId id="316"/>
+            <p14:sldId id="313"/>
+            <p14:sldId id="300"/>
+            <p14:sldId id="295"/>
+          </p14:sldIdLst>
+        </p14:section>
+      </p14:sectionLst>
+    </p:ext>
     <p:ext uri="{EFAFB233-063F-42B5-8137-9DF3F51BA10A}">
       <p15:sldGuideLst xmlns:p15="http://schemas.microsoft.com/office/powerpoint/2012/main"/>
     </p:ext>
@@ -234,7 +253,7 @@
           <a:p>
             <a:fld id="{367A1AC4-3AE8-4F87-AAED-904EC6054702}" type="datetimeFigureOut">
               <a:rPr lang="en-US" smtClean="0"/>
-              <a:t>4/24/2025</a:t>
+              <a:t>4/26/2025</a:t>
             </a:fld>
             <a:endParaRPr lang="en-US" dirty="0"/>
           </a:p>
@@ -411,7 +430,7 @@
           <a:p>
             <a:fld id="{C5556653-6123-4FE4-861F-5F9583BF59B0}" type="datetimeFigureOut">
               <a:rPr lang="en-US" smtClean="0"/>
-              <a:t>4/24/2025</a:t>
+              <a:t>4/26/2025</a:t>
             </a:fld>
             <a:endParaRPr lang="en-US" dirty="0"/>
           </a:p>
@@ -836,7 +855,7 @@
     </p:spTree>
     <p:extLst>
       <p:ext uri="{BB962C8B-B14F-4D97-AF65-F5344CB8AC3E}">
-        <p14:creationId xmlns:p14="http://schemas.microsoft.com/office/powerpoint/2010/main" val="601518118"/>
+        <p14:creationId xmlns:p14="http://schemas.microsoft.com/office/powerpoint/2010/main" val="3986912794"/>
       </p:ext>
     </p:extLst>
   </p:cSld>
@@ -920,7 +939,7 @@
     </p:spTree>
     <p:extLst>
       <p:ext uri="{BB962C8B-B14F-4D97-AF65-F5344CB8AC3E}">
-        <p14:creationId xmlns:p14="http://schemas.microsoft.com/office/powerpoint/2010/main" val="3986912794"/>
+        <p14:creationId xmlns:p14="http://schemas.microsoft.com/office/powerpoint/2010/main" val="2125366021"/>
       </p:ext>
     </p:extLst>
   </p:cSld>
@@ -974,90 +993,6 @@
           <a:bodyPr/>
           <a:lstStyle/>
           <a:p>
-            <a:endParaRPr lang="en-US" dirty="0"/>
-          </a:p>
-        </p:txBody>
-      </p:sp>
-      <p:sp>
-        <p:nvSpPr>
-          <p:cNvPr id="4" name="Slide Number Placeholder 3"/>
-          <p:cNvSpPr>
-            <a:spLocks noGrp="1"/>
-          </p:cNvSpPr>
-          <p:nvPr>
-            <p:ph type="sldNum" sz="quarter" idx="5"/>
-          </p:nvPr>
-        </p:nvSpPr>
-        <p:spPr/>
-        <p:txBody>
-          <a:bodyPr/>
-          <a:lstStyle/>
-          <a:p>
-            <a:fld id="{54EEB602-95FC-483A-B12D-216A7AD7EA24}" type="slidenum">
-              <a:rPr lang="en-US" smtClean="0"/>
-              <a:t>12</a:t>
-            </a:fld>
-            <a:endParaRPr lang="en-US" dirty="0"/>
-          </a:p>
-        </p:txBody>
-      </p:sp>
-    </p:spTree>
-    <p:extLst>
-      <p:ext uri="{BB962C8B-B14F-4D97-AF65-F5344CB8AC3E}">
-        <p14:creationId xmlns:p14="http://schemas.microsoft.com/office/powerpoint/2010/main" val="2125366021"/>
-      </p:ext>
-    </p:extLst>
-  </p:cSld>
-  <p:clrMapOvr>
-    <a:masterClrMapping/>
-  </p:clrMapOvr>
-</p:notes>
-</file>
-
-<file path=ppt/notesSlides/notesSlide13.xml><?xml version="1.0" encoding="utf-8"?>
-<p:notes xmlns:a="http://schemas.openxmlformats.org/drawingml/2006/main" xmlns:r="http://schemas.openxmlformats.org/officeDocument/2006/relationships" xmlns:p="http://schemas.openxmlformats.org/presentationml/2006/main">
-  <p:cSld>
-    <p:spTree>
-      <p:nvGrpSpPr>
-        <p:cNvPr id="1" name=""/>
-        <p:cNvGrpSpPr/>
-        <p:nvPr/>
-      </p:nvGrpSpPr>
-      <p:grpSpPr>
-        <a:xfrm>
-          <a:off x="0" y="0"/>
-          <a:ext cx="0" cy="0"/>
-          <a:chOff x="0" y="0"/>
-          <a:chExt cx="0" cy="0"/>
-        </a:xfrm>
-      </p:grpSpPr>
-      <p:sp>
-        <p:nvSpPr>
-          <p:cNvPr id="2" name="Slide Image Placeholder 1"/>
-          <p:cNvSpPr>
-            <a:spLocks noGrp="1" noRot="1" noChangeAspect="1"/>
-          </p:cNvSpPr>
-          <p:nvPr>
-            <p:ph type="sldImg"/>
-          </p:nvPr>
-        </p:nvSpPr>
-        <p:spPr/>
-      </p:sp>
-      <p:sp>
-        <p:nvSpPr>
-          <p:cNvPr id="3" name="Notes Placeholder 2"/>
-          <p:cNvSpPr>
-            <a:spLocks noGrp="1"/>
-          </p:cNvSpPr>
-          <p:nvPr>
-            <p:ph type="body" idx="1"/>
-          </p:nvPr>
-        </p:nvSpPr>
-        <p:spPr/>
-        <p:txBody>
-          <a:bodyPr/>
-          <a:lstStyle/>
-          <a:p>
             <a:pPr marL="0" marR="0" lvl="0" indent="0" algn="l" defTabSz="914400" rtl="0" eaLnBrk="1" fontAlgn="auto" latinLnBrk="0" hangingPunct="1">
               <a:lnSpc>
                 <a:spcPct val="100000"/>
@@ -1096,7 +1031,7 @@
           <a:p>
             <a:fld id="{F07F282E-55F5-4803-B60F-09BA4600E538}" type="slidenum">
               <a:rPr lang="en-US" smtClean="0"/>
-              <a:t>13</a:t>
+              <a:t>12</a:t>
             </a:fld>
             <a:endParaRPr lang="en-US" dirty="0"/>
           </a:p>
@@ -1290,7 +1225,7 @@
     </p:spTree>
     <p:extLst>
       <p:ext uri="{BB962C8B-B14F-4D97-AF65-F5344CB8AC3E}">
-        <p14:creationId xmlns:p14="http://schemas.microsoft.com/office/powerpoint/2010/main" val="3743899043"/>
+        <p14:creationId xmlns:p14="http://schemas.microsoft.com/office/powerpoint/2010/main" val="3572555010"/>
       </p:ext>
     </p:extLst>
   </p:cSld>
@@ -1344,23 +1279,6 @@
           <a:bodyPr/>
           <a:lstStyle/>
           <a:p>
-            <a:pPr marL="0" marR="0" lvl="0" indent="0" algn="l" defTabSz="914400" rtl="0" eaLnBrk="1" fontAlgn="auto" latinLnBrk="0" hangingPunct="1">
-              <a:lnSpc>
-                <a:spcPct val="100000"/>
-              </a:lnSpc>
-              <a:spcBef>
-                <a:spcPts val="0"/>
-              </a:spcBef>
-              <a:spcAft>
-                <a:spcPts val="0"/>
-              </a:spcAft>
-              <a:buClrTx/>
-              <a:buSzTx/>
-              <a:buFontTx/>
-              <a:buNone/>
-              <a:tabLst/>
-              <a:defRPr/>
-            </a:pPr>
             <a:endParaRPr lang="en-US" dirty="0"/>
           </a:p>
         </p:txBody>
@@ -1380,7 +1298,7 @@
           <a:bodyPr/>
           <a:lstStyle/>
           <a:p>
-            <a:fld id="{F07F282E-55F5-4803-B60F-09BA4600E538}" type="slidenum">
+            <a:fld id="{54EEB602-95FC-483A-B12D-216A7AD7EA24}" type="slidenum">
               <a:rPr lang="en-US" smtClean="0"/>
               <a:t>4</a:t>
             </a:fld>
@@ -1391,7 +1309,7 @@
     </p:spTree>
     <p:extLst>
       <p:ext uri="{BB962C8B-B14F-4D97-AF65-F5344CB8AC3E}">
-        <p14:creationId xmlns:p14="http://schemas.microsoft.com/office/powerpoint/2010/main" val="4200283822"/>
+        <p14:creationId xmlns:p14="http://schemas.microsoft.com/office/powerpoint/2010/main" val="2191268297"/>
       </p:ext>
     </p:extLst>
   </p:cSld>
@@ -1475,7 +1393,7 @@
     </p:spTree>
     <p:extLst>
       <p:ext uri="{BB962C8B-B14F-4D97-AF65-F5344CB8AC3E}">
-        <p14:creationId xmlns:p14="http://schemas.microsoft.com/office/powerpoint/2010/main" val="2191268297"/>
+        <p14:creationId xmlns:p14="http://schemas.microsoft.com/office/powerpoint/2010/main" val="3743899043"/>
       </p:ext>
     </p:extLst>
   </p:cSld>
@@ -1559,7 +1477,7 @@
     </p:spTree>
     <p:extLst>
       <p:ext uri="{BB962C8B-B14F-4D97-AF65-F5344CB8AC3E}">
-        <p14:creationId xmlns:p14="http://schemas.microsoft.com/office/powerpoint/2010/main" val="303174507"/>
+        <p14:creationId xmlns:p14="http://schemas.microsoft.com/office/powerpoint/2010/main" val="2714327902"/>
       </p:ext>
     </p:extLst>
   </p:cSld>
@@ -1613,6 +1531,23 @@
           <a:bodyPr/>
           <a:lstStyle/>
           <a:p>
+            <a:pPr marL="0" marR="0" lvl="0" indent="0" algn="l" defTabSz="914400" rtl="0" eaLnBrk="1" fontAlgn="auto" latinLnBrk="0" hangingPunct="1">
+              <a:lnSpc>
+                <a:spcPct val="100000"/>
+              </a:lnSpc>
+              <a:spcBef>
+                <a:spcPts val="0"/>
+              </a:spcBef>
+              <a:spcAft>
+                <a:spcPts val="0"/>
+              </a:spcAft>
+              <a:buClrTx/>
+              <a:buSzTx/>
+              <a:buFontTx/>
+              <a:buNone/>
+              <a:tabLst/>
+              <a:defRPr/>
+            </a:pPr>
             <a:endParaRPr lang="en-US" dirty="0"/>
           </a:p>
         </p:txBody>
@@ -1632,7 +1567,7 @@
           <a:bodyPr/>
           <a:lstStyle/>
           <a:p>
-            <a:fld id="{54EEB602-95FC-483A-B12D-216A7AD7EA24}" type="slidenum">
+            <a:fld id="{F07F282E-55F5-4803-B60F-09BA4600E538}" type="slidenum">
               <a:rPr lang="en-US" smtClean="0"/>
               <a:t>7</a:t>
             </a:fld>
@@ -1643,7 +1578,7 @@
     </p:spTree>
     <p:extLst>
       <p:ext uri="{BB962C8B-B14F-4D97-AF65-F5344CB8AC3E}">
-        <p14:creationId xmlns:p14="http://schemas.microsoft.com/office/powerpoint/2010/main" val="3572555010"/>
+        <p14:creationId xmlns:p14="http://schemas.microsoft.com/office/powerpoint/2010/main" val="4200283822"/>
       </p:ext>
     </p:extLst>
   </p:cSld>
@@ -1727,7 +1662,7 @@
     </p:spTree>
     <p:extLst>
       <p:ext uri="{BB962C8B-B14F-4D97-AF65-F5344CB8AC3E}">
-        <p14:creationId xmlns:p14="http://schemas.microsoft.com/office/powerpoint/2010/main" val="2714327902"/>
+        <p14:creationId xmlns:p14="http://schemas.microsoft.com/office/powerpoint/2010/main" val="2221603058"/>
       </p:ext>
     </p:extLst>
   </p:cSld>
@@ -1811,7 +1746,7 @@
     </p:spTree>
     <p:extLst>
       <p:ext uri="{BB962C8B-B14F-4D97-AF65-F5344CB8AC3E}">
-        <p14:creationId xmlns:p14="http://schemas.microsoft.com/office/powerpoint/2010/main" val="2221603058"/>
+        <p14:creationId xmlns:p14="http://schemas.microsoft.com/office/powerpoint/2010/main" val="601518118"/>
       </p:ext>
     </p:extLst>
   </p:cSld>
@@ -5049,513 +4984,6 @@
 
 <file path=ppt/slideLayouts/slideLayout16.xml><?xml version="1.0" encoding="utf-8"?>
 <p:sldLayout xmlns:a="http://schemas.openxmlformats.org/drawingml/2006/main" xmlns:r="http://schemas.openxmlformats.org/officeDocument/2006/relationships" xmlns:p="http://schemas.openxmlformats.org/presentationml/2006/main" showMasterSp="0" userDrawn="1">
-  <p:cSld name="Title + Subtitle">
-    <p:spTree>
-      <p:nvGrpSpPr>
-        <p:cNvPr id="1" name=""/>
-        <p:cNvGrpSpPr/>
-        <p:nvPr/>
-      </p:nvGrpSpPr>
-      <p:grpSpPr>
-        <a:xfrm>
-          <a:off x="0" y="0"/>
-          <a:ext cx="0" cy="0"/>
-          <a:chOff x="0" y="0"/>
-          <a:chExt cx="0" cy="0"/>
-        </a:xfrm>
-      </p:grpSpPr>
-      <p:sp useBgFill="1">
-        <p:nvSpPr>
-          <p:cNvPr id="52" name="Rectangle 51">
-            <a:extLst>
-              <a:ext uri="{FF2B5EF4-FFF2-40B4-BE49-F238E27FC236}">
-                <a16:creationId xmlns:a16="http://schemas.microsoft.com/office/drawing/2014/main" id="{EA8D8870-8337-4ABD-9EA6-3D5AAB7E42D9}"/>
-              </a:ext>
-              <a:ext uri="{C183D7F6-B498-43B3-948B-1728B52AA6E4}">
-                <adec:decorative xmlns:adec="http://schemas.microsoft.com/office/drawing/2017/decorative" val="1"/>
-              </a:ext>
-            </a:extLst>
-          </p:cNvPr>
-          <p:cNvSpPr/>
-          <p:nvPr userDrawn="1"/>
-        </p:nvSpPr>
-        <p:spPr>
-          <a:xfrm flipH="1">
-            <a:off x="0" y="0"/>
-            <a:ext cx="12192001" cy="6858000"/>
-          </a:xfrm>
-          <a:prstGeom prst="rect">
-            <a:avLst/>
-          </a:prstGeom>
-          <a:ln>
-            <a:noFill/>
-          </a:ln>
-        </p:spPr>
-        <p:style>
-          <a:lnRef idx="2">
-            <a:schemeClr val="accent1">
-              <a:shade val="50000"/>
-            </a:schemeClr>
-          </a:lnRef>
-          <a:fillRef idx="1">
-            <a:schemeClr val="accent1"/>
-          </a:fillRef>
-          <a:effectRef idx="0">
-            <a:schemeClr val="accent1"/>
-          </a:effectRef>
-          <a:fontRef idx="minor">
-            <a:schemeClr val="lt1"/>
-          </a:fontRef>
-        </p:style>
-        <p:txBody>
-          <a:bodyPr rtlCol="0" anchor="ctr"/>
-          <a:lstStyle/>
-          <a:p>
-            <a:pPr algn="ctr"/>
-            <a:endParaRPr lang="en-US" dirty="0"/>
-          </a:p>
-        </p:txBody>
-      </p:sp>
-      <p:sp>
-        <p:nvSpPr>
-          <p:cNvPr id="53" name="Rectangle 52">
-            <a:extLst>
-              <a:ext uri="{FF2B5EF4-FFF2-40B4-BE49-F238E27FC236}">
-                <a16:creationId xmlns:a16="http://schemas.microsoft.com/office/drawing/2014/main" id="{BAC3B2DB-2CCA-4BD4-8D63-98257049E273}"/>
-              </a:ext>
-              <a:ext uri="{C183D7F6-B498-43B3-948B-1728B52AA6E4}">
-                <adec:decorative xmlns:adec="http://schemas.microsoft.com/office/drawing/2017/decorative" val="1"/>
-              </a:ext>
-            </a:extLst>
-          </p:cNvPr>
-          <p:cNvSpPr/>
-          <p:nvPr userDrawn="1"/>
-        </p:nvSpPr>
-        <p:spPr>
-          <a:xfrm>
-            <a:off x="0" y="825689"/>
-            <a:ext cx="12192000" cy="5201731"/>
-          </a:xfrm>
-          <a:prstGeom prst="rect">
-            <a:avLst/>
-          </a:prstGeom>
-          <a:solidFill>
-            <a:schemeClr val="tx2"/>
-          </a:solidFill>
-          <a:ln>
-            <a:noFill/>
-          </a:ln>
-        </p:spPr>
-        <p:style>
-          <a:lnRef idx="2">
-            <a:schemeClr val="accent1">
-              <a:shade val="50000"/>
-            </a:schemeClr>
-          </a:lnRef>
-          <a:fillRef idx="1">
-            <a:schemeClr val="accent1"/>
-          </a:fillRef>
-          <a:effectRef idx="0">
-            <a:schemeClr val="accent1"/>
-          </a:effectRef>
-          <a:fontRef idx="minor">
-            <a:schemeClr val="lt1"/>
-          </a:fontRef>
-        </p:style>
-        <p:txBody>
-          <a:bodyPr rtlCol="0" anchor="ctr"/>
-          <a:lstStyle/>
-          <a:p>
-            <a:pPr algn="ctr"/>
-            <a:endParaRPr lang="en-US" dirty="0"/>
-          </a:p>
-        </p:txBody>
-      </p:sp>
-      <p:sp>
-        <p:nvSpPr>
-          <p:cNvPr id="54" name="Title 1">
-            <a:extLst>
-              <a:ext uri="{FF2B5EF4-FFF2-40B4-BE49-F238E27FC236}">
-                <a16:creationId xmlns:a16="http://schemas.microsoft.com/office/drawing/2014/main" id="{324DAAC3-FA37-4838-A298-327679F99F8A}"/>
-              </a:ext>
-            </a:extLst>
-          </p:cNvPr>
-          <p:cNvSpPr>
-            <a:spLocks noGrp="1"/>
-          </p:cNvSpPr>
-          <p:nvPr>
-            <p:ph type="ctrTitle" hasCustomPrompt="1"/>
-          </p:nvPr>
-        </p:nvSpPr>
-        <p:spPr>
-          <a:xfrm>
-            <a:off x="1386628" y="1034477"/>
-            <a:ext cx="9380431" cy="2614551"/>
-          </a:xfrm>
-        </p:spPr>
-        <p:txBody>
-          <a:bodyPr anchor="b" anchorCtr="0">
-            <a:noAutofit/>
-          </a:bodyPr>
-          <a:lstStyle>
-            <a:lvl1pPr algn="l">
-              <a:lnSpc>
-                <a:spcPct val="100000"/>
-              </a:lnSpc>
-              <a:defRPr sz="4800" cap="all" baseline="0">
-                <a:solidFill>
-                  <a:schemeClr val="bg1"/>
-                </a:solidFill>
-              </a:defRPr>
-            </a:lvl1pPr>
-          </a:lstStyle>
-          <a:p>
-            <a:r>
-              <a:rPr lang="en-US" sz="4400" dirty="0">
-                <a:solidFill>
-                  <a:schemeClr val="bg1"/>
-                </a:solidFill>
-              </a:rPr>
-              <a:t>CLICK TO ADD TITLE</a:t>
-            </a:r>
-          </a:p>
-        </p:txBody>
-      </p:sp>
-      <p:sp>
-        <p:nvSpPr>
-          <p:cNvPr id="56" name="Rectangle 55">
-            <a:extLst>
-              <a:ext uri="{FF2B5EF4-FFF2-40B4-BE49-F238E27FC236}">
-                <a16:creationId xmlns:a16="http://schemas.microsoft.com/office/drawing/2014/main" id="{FB792E4C-AD3B-4E88-8540-E75759746368}"/>
-              </a:ext>
-              <a:ext uri="{C183D7F6-B498-43B3-948B-1728B52AA6E4}">
-                <adec:decorative xmlns:adec="http://schemas.microsoft.com/office/drawing/2017/decorative" val="1"/>
-              </a:ext>
-            </a:extLst>
-          </p:cNvPr>
-          <p:cNvSpPr/>
-          <p:nvPr userDrawn="1"/>
-        </p:nvSpPr>
-        <p:spPr>
-          <a:xfrm>
-            <a:off x="-1" y="889696"/>
-            <a:ext cx="1070775" cy="5077717"/>
-          </a:xfrm>
-          <a:prstGeom prst="rect">
-            <a:avLst/>
-          </a:prstGeom>
-          <a:solidFill>
-            <a:schemeClr val="accent1"/>
-          </a:solidFill>
-          <a:ln>
-            <a:noFill/>
-          </a:ln>
-        </p:spPr>
-        <p:style>
-          <a:lnRef idx="2">
-            <a:schemeClr val="accent1">
-              <a:shade val="50000"/>
-            </a:schemeClr>
-          </a:lnRef>
-          <a:fillRef idx="1">
-            <a:schemeClr val="accent1"/>
-          </a:fillRef>
-          <a:effectRef idx="0">
-            <a:schemeClr val="accent1"/>
-          </a:effectRef>
-          <a:fontRef idx="minor">
-            <a:schemeClr val="lt1"/>
-          </a:fontRef>
-        </p:style>
-        <p:txBody>
-          <a:bodyPr rtlCol="0" anchor="ctr"/>
-          <a:lstStyle/>
-          <a:p>
-            <a:pPr algn="ctr"/>
-            <a:endParaRPr lang="en-US" dirty="0"/>
-          </a:p>
-        </p:txBody>
-      </p:sp>
-      <p:sp>
-        <p:nvSpPr>
-          <p:cNvPr id="57" name="Rectangle 56">
-            <a:extLst>
-              <a:ext uri="{FF2B5EF4-FFF2-40B4-BE49-F238E27FC236}">
-                <a16:creationId xmlns:a16="http://schemas.microsoft.com/office/drawing/2014/main" id="{6A32632F-9ED1-4328-BBE3-B4E014156A29}"/>
-              </a:ext>
-              <a:ext uri="{C183D7F6-B498-43B3-948B-1728B52AA6E4}">
-                <adec:decorative xmlns:adec="http://schemas.microsoft.com/office/drawing/2017/decorative" val="1"/>
-              </a:ext>
-            </a:extLst>
-          </p:cNvPr>
-          <p:cNvSpPr/>
-          <p:nvPr userDrawn="1"/>
-        </p:nvSpPr>
-        <p:spPr>
-          <a:xfrm rot="5400000">
-            <a:off x="-2365125" y="3396997"/>
-            <a:ext cx="6858002" cy="64008"/>
-          </a:xfrm>
-          <a:prstGeom prst="rect">
-            <a:avLst/>
-          </a:prstGeom>
-          <a:solidFill>
-            <a:schemeClr val="tx2"/>
-          </a:solidFill>
-          <a:ln>
-            <a:noFill/>
-          </a:ln>
-        </p:spPr>
-        <p:style>
-          <a:lnRef idx="2">
-            <a:schemeClr val="accent1">
-              <a:shade val="50000"/>
-            </a:schemeClr>
-          </a:lnRef>
-          <a:fillRef idx="1">
-            <a:schemeClr val="accent1"/>
-          </a:fillRef>
-          <a:effectRef idx="0">
-            <a:schemeClr val="accent1"/>
-          </a:effectRef>
-          <a:fontRef idx="minor">
-            <a:schemeClr val="lt1"/>
-          </a:fontRef>
-        </p:style>
-        <p:txBody>
-          <a:bodyPr rtlCol="0" anchor="ctr"/>
-          <a:lstStyle/>
-          <a:p>
-            <a:pPr algn="ctr"/>
-            <a:endParaRPr lang="en-US" dirty="0"/>
-          </a:p>
-        </p:txBody>
-      </p:sp>
-      <p:sp>
-        <p:nvSpPr>
-          <p:cNvPr id="59" name="Rectangle 58">
-            <a:extLst>
-              <a:ext uri="{FF2B5EF4-FFF2-40B4-BE49-F238E27FC236}">
-                <a16:creationId xmlns:a16="http://schemas.microsoft.com/office/drawing/2014/main" id="{EA124D3C-01E3-4B96-BDF0-54851D1739D0}"/>
-              </a:ext>
-              <a:ext uri="{C183D7F6-B498-43B3-948B-1728B52AA6E4}">
-                <adec:decorative xmlns:adec="http://schemas.microsoft.com/office/drawing/2017/decorative" val="1"/>
-              </a:ext>
-            </a:extLst>
-          </p:cNvPr>
-          <p:cNvSpPr/>
-          <p:nvPr userDrawn="1"/>
-        </p:nvSpPr>
-        <p:spPr>
-          <a:xfrm rot="5400000">
-            <a:off x="7658511" y="3396997"/>
-            <a:ext cx="6858002" cy="64008"/>
-          </a:xfrm>
-          <a:prstGeom prst="rect">
-            <a:avLst/>
-          </a:prstGeom>
-          <a:solidFill>
-            <a:schemeClr val="tx2"/>
-          </a:solidFill>
-          <a:ln>
-            <a:noFill/>
-          </a:ln>
-        </p:spPr>
-        <p:style>
-          <a:lnRef idx="2">
-            <a:schemeClr val="accent1">
-              <a:shade val="50000"/>
-            </a:schemeClr>
-          </a:lnRef>
-          <a:fillRef idx="1">
-            <a:schemeClr val="accent1"/>
-          </a:fillRef>
-          <a:effectRef idx="0">
-            <a:schemeClr val="accent1"/>
-          </a:effectRef>
-          <a:fontRef idx="minor">
-            <a:schemeClr val="lt1"/>
-          </a:fontRef>
-        </p:style>
-        <p:txBody>
-          <a:bodyPr rtlCol="0" anchor="ctr"/>
-          <a:lstStyle/>
-          <a:p>
-            <a:pPr algn="ctr"/>
-            <a:endParaRPr lang="en-US" dirty="0"/>
-          </a:p>
-        </p:txBody>
-      </p:sp>
-      <p:sp>
-        <p:nvSpPr>
-          <p:cNvPr id="3" name="Rectangle 2">
-            <a:extLst>
-              <a:ext uri="{FF2B5EF4-FFF2-40B4-BE49-F238E27FC236}">
-                <a16:creationId xmlns:a16="http://schemas.microsoft.com/office/drawing/2014/main" id="{167A64FF-37A7-4837-8033-CBEA22697ECA}"/>
-              </a:ext>
-              <a:ext uri="{C183D7F6-B498-43B3-948B-1728B52AA6E4}">
-                <adec:decorative xmlns:adec="http://schemas.microsoft.com/office/drawing/2017/decorative" val="1"/>
-              </a:ext>
-            </a:extLst>
-          </p:cNvPr>
-          <p:cNvSpPr/>
-          <p:nvPr userDrawn="1"/>
-        </p:nvSpPr>
-        <p:spPr>
-          <a:xfrm>
-            <a:off x="11119516" y="896046"/>
-            <a:ext cx="1070775" cy="5077717"/>
-          </a:xfrm>
-          <a:prstGeom prst="rect">
-            <a:avLst/>
-          </a:prstGeom>
-          <a:solidFill>
-            <a:schemeClr val="accent1"/>
-          </a:solidFill>
-          <a:ln>
-            <a:noFill/>
-          </a:ln>
-        </p:spPr>
-        <p:style>
-          <a:lnRef idx="2">
-            <a:schemeClr val="accent1">
-              <a:shade val="50000"/>
-            </a:schemeClr>
-          </a:lnRef>
-          <a:fillRef idx="1">
-            <a:schemeClr val="accent1"/>
-          </a:fillRef>
-          <a:effectRef idx="0">
-            <a:schemeClr val="accent1"/>
-          </a:effectRef>
-          <a:fontRef idx="minor">
-            <a:schemeClr val="lt1"/>
-          </a:fontRef>
-        </p:style>
-        <p:txBody>
-          <a:bodyPr rtlCol="0" anchor="ctr"/>
-          <a:lstStyle/>
-          <a:p>
-            <a:pPr algn="ctr"/>
-            <a:endParaRPr lang="en-US" dirty="0"/>
-          </a:p>
-        </p:txBody>
-      </p:sp>
-      <p:sp>
-        <p:nvSpPr>
-          <p:cNvPr id="5" name="Text Placeholder 4">
-            <a:extLst>
-              <a:ext uri="{FF2B5EF4-FFF2-40B4-BE49-F238E27FC236}">
-                <a16:creationId xmlns:a16="http://schemas.microsoft.com/office/drawing/2014/main" id="{EF94ADB5-E70F-B672-CBEB-D8194AEA79D5}"/>
-              </a:ext>
-            </a:extLst>
-          </p:cNvPr>
-          <p:cNvSpPr>
-            <a:spLocks noGrp="1"/>
-          </p:cNvSpPr>
-          <p:nvPr>
-            <p:ph type="body" sz="quarter" idx="10" hasCustomPrompt="1"/>
-          </p:nvPr>
-        </p:nvSpPr>
-        <p:spPr>
-          <a:xfrm>
-            <a:off x="1386177" y="3649028"/>
-            <a:ext cx="9380431" cy="2164715"/>
-          </a:xfrm>
-        </p:spPr>
-        <p:txBody>
-          <a:bodyPr anchor="t"/>
-          <a:lstStyle>
-            <a:lvl1pPr marL="0" indent="0">
-              <a:lnSpc>
-                <a:spcPct val="125000"/>
-              </a:lnSpc>
-              <a:buNone/>
-              <a:defRPr lang="en-US" sz="2400" b="0" kern="1200" spc="150" baseline="0" dirty="0" smtClean="0">
-                <a:solidFill>
-                  <a:schemeClr val="bg1"/>
-                </a:solidFill>
-                <a:latin typeface="+mn-lt"/>
-                <a:ea typeface="+mn-ea"/>
-                <a:cs typeface="+mn-cs"/>
-              </a:defRPr>
-            </a:lvl1pPr>
-            <a:lvl2pPr>
-              <a:defRPr lang="en-US" sz="2400" b="0" kern="1200" spc="150" baseline="0" dirty="0" smtClean="0">
-                <a:solidFill>
-                  <a:schemeClr val="bg1"/>
-                </a:solidFill>
-                <a:latin typeface="+mn-lt"/>
-                <a:ea typeface="+mn-ea"/>
-                <a:cs typeface="+mn-cs"/>
-              </a:defRPr>
-            </a:lvl2pPr>
-            <a:lvl3pPr>
-              <a:defRPr lang="en-US" sz="2400" b="0" kern="1200" spc="150" baseline="0" dirty="0" smtClean="0">
-                <a:solidFill>
-                  <a:schemeClr val="bg1"/>
-                </a:solidFill>
-                <a:latin typeface="+mn-lt"/>
-                <a:ea typeface="+mn-ea"/>
-                <a:cs typeface="+mn-cs"/>
-              </a:defRPr>
-            </a:lvl3pPr>
-            <a:lvl4pPr>
-              <a:defRPr lang="en-US" sz="2400" b="0" kern="1200" spc="150" baseline="0" dirty="0" smtClean="0">
-                <a:solidFill>
-                  <a:schemeClr val="bg1"/>
-                </a:solidFill>
-                <a:latin typeface="+mn-lt"/>
-                <a:ea typeface="+mn-ea"/>
-                <a:cs typeface="+mn-cs"/>
-              </a:defRPr>
-            </a:lvl4pPr>
-            <a:lvl5pPr>
-              <a:defRPr lang="en-US" sz="2400" b="0" kern="1200" spc="150" baseline="0" dirty="0">
-                <a:solidFill>
-                  <a:schemeClr val="bg1"/>
-                </a:solidFill>
-                <a:latin typeface="+mn-lt"/>
-                <a:ea typeface="+mn-ea"/>
-                <a:cs typeface="+mn-cs"/>
-              </a:defRPr>
-            </a:lvl5pPr>
-          </a:lstStyle>
-          <a:p>
-            <a:pPr lvl="0"/>
-            <a:r>
-              <a:rPr lang="en-US" dirty="0"/>
-              <a:t>Click to add text</a:t>
-            </a:r>
-          </a:p>
-        </p:txBody>
-      </p:sp>
-    </p:spTree>
-    <p:extLst>
-      <p:ext uri="{BB962C8B-B14F-4D97-AF65-F5344CB8AC3E}">
-        <p14:creationId xmlns:p14="http://schemas.microsoft.com/office/powerpoint/2010/main" val="1935738827"/>
-      </p:ext>
-    </p:extLst>
-  </p:cSld>
-  <p:clrMapOvr>
-    <a:masterClrMapping/>
-  </p:clrMapOvr>
-  <p:extLst>
-    <p:ext uri="{DCECCB84-F9BA-43D5-87BE-67443E8EF086}">
-      <p15:sldGuideLst xmlns:p15="http://schemas.microsoft.com/office/powerpoint/2012/main">
-        <p15:guide id="1" orient="horz" pos="4056">
-          <p15:clr>
-            <a:srgbClr val="FBAE40"/>
-          </p15:clr>
-        </p15:guide>
-      </p15:sldGuideLst>
-    </p:ext>
-  </p:extLst>
-</p:sldLayout>
-</file>
-
-<file path=ppt/slideLayouts/slideLayout17.xml><?xml version="1.0" encoding="utf-8"?>
-<p:sldLayout xmlns:a="http://schemas.openxmlformats.org/drawingml/2006/main" xmlns:r="http://schemas.openxmlformats.org/officeDocument/2006/relationships" xmlns:p="http://schemas.openxmlformats.org/presentationml/2006/main" showMasterSp="0" userDrawn="1">
   <p:cSld name="Title and 2 Content 3">
     <p:spTree>
       <p:nvGrpSpPr>
@@ -6239,7 +5667,7 @@
 </p:sldLayout>
 </file>
 
-<file path=ppt/slideLayouts/slideLayout18.xml><?xml version="1.0" encoding="utf-8"?>
+<file path=ppt/slideLayouts/slideLayout17.xml><?xml version="1.0" encoding="utf-8"?>
 <p:sldLayout xmlns:a="http://schemas.openxmlformats.org/drawingml/2006/main" xmlns:r="http://schemas.openxmlformats.org/officeDocument/2006/relationships" xmlns:p="http://schemas.openxmlformats.org/presentationml/2006/main" userDrawn="1">
   <p:cSld name="Two Content 2">
     <p:spTree>
@@ -6925,7 +6353,7 @@
 </p:sldLayout>
 </file>
 
-<file path=ppt/slideLayouts/slideLayout19.xml><?xml version="1.0" encoding="utf-8"?>
+<file path=ppt/slideLayouts/slideLayout18.xml><?xml version="1.0" encoding="utf-8"?>
 <p:sldLayout xmlns:a="http://schemas.openxmlformats.org/drawingml/2006/main" xmlns:r="http://schemas.openxmlformats.org/officeDocument/2006/relationships" xmlns:p="http://schemas.openxmlformats.org/presentationml/2006/main" userDrawn="1">
   <p:cSld name="Content 2">
     <p:spTree>
@@ -7671,183 +7099,7 @@
 </p:sldLayout>
 </file>
 
-<file path=ppt/slideLayouts/slideLayout2.xml><?xml version="1.0" encoding="utf-8"?>
-<p:sldLayout xmlns:a="http://schemas.openxmlformats.org/drawingml/2006/main" xmlns:r="http://schemas.openxmlformats.org/officeDocument/2006/relationships" xmlns:p="http://schemas.openxmlformats.org/presentationml/2006/main" type="obj" preserve="1">
-  <p:cSld name="Title and Content">
-    <p:spTree>
-      <p:nvGrpSpPr>
-        <p:cNvPr id="1" name=""/>
-        <p:cNvGrpSpPr/>
-        <p:nvPr/>
-      </p:nvGrpSpPr>
-      <p:grpSpPr>
-        <a:xfrm>
-          <a:off x="0" y="0"/>
-          <a:ext cx="0" cy="0"/>
-          <a:chOff x="0" y="0"/>
-          <a:chExt cx="0" cy="0"/>
-        </a:xfrm>
-      </p:grpSpPr>
-      <p:sp>
-        <p:nvSpPr>
-          <p:cNvPr id="2" name="Title 1"/>
-          <p:cNvSpPr>
-            <a:spLocks noGrp="1"/>
-          </p:cNvSpPr>
-          <p:nvPr>
-            <p:ph type="title"/>
-          </p:nvPr>
-        </p:nvSpPr>
-        <p:spPr/>
-        <p:txBody>
-          <a:bodyPr/>
-          <a:lstStyle/>
-          <a:p>
-            <a:r>
-              <a:rPr lang="en-US"/>
-              <a:t>Click to edit Master title style</a:t>
-            </a:r>
-            <a:endParaRPr lang="en-US" dirty="0"/>
-          </a:p>
-        </p:txBody>
-      </p:sp>
-      <p:sp>
-        <p:nvSpPr>
-          <p:cNvPr id="3" name="Content Placeholder 2"/>
-          <p:cNvSpPr>
-            <a:spLocks noGrp="1"/>
-          </p:cNvSpPr>
-          <p:nvPr>
-            <p:ph idx="1"/>
-          </p:nvPr>
-        </p:nvSpPr>
-        <p:spPr/>
-        <p:txBody>
-          <a:bodyPr/>
-          <a:lstStyle/>
-          <a:p>
-            <a:pPr lvl="0"/>
-            <a:r>
-              <a:rPr lang="en-US"/>
-              <a:t>Click to edit Master text styles</a:t>
-            </a:r>
-          </a:p>
-          <a:p>
-            <a:pPr lvl="1"/>
-            <a:r>
-              <a:rPr lang="en-US"/>
-              <a:t>Second level</a:t>
-            </a:r>
-          </a:p>
-          <a:p>
-            <a:pPr lvl="2"/>
-            <a:r>
-              <a:rPr lang="en-US"/>
-              <a:t>Third level</a:t>
-            </a:r>
-          </a:p>
-          <a:p>
-            <a:pPr lvl="3"/>
-            <a:r>
-              <a:rPr lang="en-US"/>
-              <a:t>Fourth level</a:t>
-            </a:r>
-          </a:p>
-          <a:p>
-            <a:pPr lvl="4"/>
-            <a:r>
-              <a:rPr lang="en-US"/>
-              <a:t>Fifth level</a:t>
-            </a:r>
-            <a:endParaRPr lang="en-US" dirty="0"/>
-          </a:p>
-        </p:txBody>
-      </p:sp>
-      <p:sp>
-        <p:nvSpPr>
-          <p:cNvPr id="4" name="Date Placeholder 3"/>
-          <p:cNvSpPr>
-            <a:spLocks noGrp="1"/>
-          </p:cNvSpPr>
-          <p:nvPr>
-            <p:ph type="dt" sz="half" idx="10"/>
-          </p:nvPr>
-        </p:nvSpPr>
-        <p:spPr/>
-        <p:txBody>
-          <a:bodyPr/>
-          <a:lstStyle/>
-          <a:p>
-            <a:r>
-              <a:rPr lang="en-US"/>
-              <a:t>9/8/20XX</a:t>
-            </a:r>
-            <a:endParaRPr lang="en-US" dirty="0"/>
-          </a:p>
-        </p:txBody>
-      </p:sp>
-      <p:sp>
-        <p:nvSpPr>
-          <p:cNvPr id="5" name="Footer Placeholder 4"/>
-          <p:cNvSpPr>
-            <a:spLocks noGrp="1"/>
-          </p:cNvSpPr>
-          <p:nvPr>
-            <p:ph type="ftr" sz="quarter" idx="11"/>
-          </p:nvPr>
-        </p:nvSpPr>
-        <p:spPr/>
-        <p:txBody>
-          <a:bodyPr/>
-          <a:lstStyle/>
-          <a:p>
-            <a:r>
-              <a:rPr lang="en-US"/>
-              <a:t>Presentation Title</a:t>
-            </a:r>
-            <a:endParaRPr lang="en-US" dirty="0"/>
-          </a:p>
-        </p:txBody>
-      </p:sp>
-      <p:sp>
-        <p:nvSpPr>
-          <p:cNvPr id="6" name="Slide Number Placeholder 5"/>
-          <p:cNvSpPr>
-            <a:spLocks noGrp="1"/>
-          </p:cNvSpPr>
-          <p:nvPr>
-            <p:ph type="sldNum" sz="quarter" idx="12"/>
-          </p:nvPr>
-        </p:nvSpPr>
-        <p:spPr/>
-        <p:txBody>
-          <a:bodyPr/>
-          <a:lstStyle/>
-          <a:p>
-            <a:fld id="{FAEF9944-A4F6-4C59-AEBD-678D6480B8EA}" type="slidenum">
-              <a:rPr lang="en-US" smtClean="0"/>
-              <a:pPr/>
-              <a:t>‹#›</a:t>
-            </a:fld>
-            <a:endParaRPr lang="en-US" dirty="0"/>
-          </a:p>
-        </p:txBody>
-      </p:sp>
-    </p:spTree>
-    <p:extLst>
-      <p:ext uri="{BB962C8B-B14F-4D97-AF65-F5344CB8AC3E}">
-        <p14:creationId xmlns:p14="http://schemas.microsoft.com/office/powerpoint/2010/main" val="2120849448"/>
-      </p:ext>
-    </p:extLst>
-  </p:cSld>
-  <p:clrMapOvr>
-    <a:masterClrMapping/>
-  </p:clrMapOvr>
-  <p:hf sldNum="0" hdr="0" ftr="0" dt="0"/>
-</p:sldLayout>
-</file>
-
-<file path=ppt/slideLayouts/slideLayout20.xml><?xml version="1.0" encoding="utf-8"?>
+<file path=ppt/slideLayouts/slideLayout19.xml><?xml version="1.0" encoding="utf-8"?>
 <p:sldLayout xmlns:a="http://schemas.openxmlformats.org/drawingml/2006/main" xmlns:r="http://schemas.openxmlformats.org/officeDocument/2006/relationships" xmlns:p="http://schemas.openxmlformats.org/presentationml/2006/main" showMasterSp="0" userDrawn="1">
   <p:cSld name="1_Title and 2 Content 3">
     <p:spTree>
@@ -8464,7 +7716,183 @@
 </p:sldLayout>
 </file>
 
-<file path=ppt/slideLayouts/slideLayout21.xml><?xml version="1.0" encoding="utf-8"?>
+<file path=ppt/slideLayouts/slideLayout2.xml><?xml version="1.0" encoding="utf-8"?>
+<p:sldLayout xmlns:a="http://schemas.openxmlformats.org/drawingml/2006/main" xmlns:r="http://schemas.openxmlformats.org/officeDocument/2006/relationships" xmlns:p="http://schemas.openxmlformats.org/presentationml/2006/main" type="obj" preserve="1">
+  <p:cSld name="Title and Content">
+    <p:spTree>
+      <p:nvGrpSpPr>
+        <p:cNvPr id="1" name=""/>
+        <p:cNvGrpSpPr/>
+        <p:nvPr/>
+      </p:nvGrpSpPr>
+      <p:grpSpPr>
+        <a:xfrm>
+          <a:off x="0" y="0"/>
+          <a:ext cx="0" cy="0"/>
+          <a:chOff x="0" y="0"/>
+          <a:chExt cx="0" cy="0"/>
+        </a:xfrm>
+      </p:grpSpPr>
+      <p:sp>
+        <p:nvSpPr>
+          <p:cNvPr id="2" name="Title 1"/>
+          <p:cNvSpPr>
+            <a:spLocks noGrp="1"/>
+          </p:cNvSpPr>
+          <p:nvPr>
+            <p:ph type="title"/>
+          </p:nvPr>
+        </p:nvSpPr>
+        <p:spPr/>
+        <p:txBody>
+          <a:bodyPr/>
+          <a:lstStyle/>
+          <a:p>
+            <a:r>
+              <a:rPr lang="en-US"/>
+              <a:t>Click to edit Master title style</a:t>
+            </a:r>
+            <a:endParaRPr lang="en-US" dirty="0"/>
+          </a:p>
+        </p:txBody>
+      </p:sp>
+      <p:sp>
+        <p:nvSpPr>
+          <p:cNvPr id="3" name="Content Placeholder 2"/>
+          <p:cNvSpPr>
+            <a:spLocks noGrp="1"/>
+          </p:cNvSpPr>
+          <p:nvPr>
+            <p:ph idx="1"/>
+          </p:nvPr>
+        </p:nvSpPr>
+        <p:spPr/>
+        <p:txBody>
+          <a:bodyPr/>
+          <a:lstStyle/>
+          <a:p>
+            <a:pPr lvl="0"/>
+            <a:r>
+              <a:rPr lang="en-US"/>
+              <a:t>Click to edit Master text styles</a:t>
+            </a:r>
+          </a:p>
+          <a:p>
+            <a:pPr lvl="1"/>
+            <a:r>
+              <a:rPr lang="en-US"/>
+              <a:t>Second level</a:t>
+            </a:r>
+          </a:p>
+          <a:p>
+            <a:pPr lvl="2"/>
+            <a:r>
+              <a:rPr lang="en-US"/>
+              <a:t>Third level</a:t>
+            </a:r>
+          </a:p>
+          <a:p>
+            <a:pPr lvl="3"/>
+            <a:r>
+              <a:rPr lang="en-US"/>
+              <a:t>Fourth level</a:t>
+            </a:r>
+          </a:p>
+          <a:p>
+            <a:pPr lvl="4"/>
+            <a:r>
+              <a:rPr lang="en-US"/>
+              <a:t>Fifth level</a:t>
+            </a:r>
+            <a:endParaRPr lang="en-US" dirty="0"/>
+          </a:p>
+        </p:txBody>
+      </p:sp>
+      <p:sp>
+        <p:nvSpPr>
+          <p:cNvPr id="4" name="Date Placeholder 3"/>
+          <p:cNvSpPr>
+            <a:spLocks noGrp="1"/>
+          </p:cNvSpPr>
+          <p:nvPr>
+            <p:ph type="dt" sz="half" idx="10"/>
+          </p:nvPr>
+        </p:nvSpPr>
+        <p:spPr/>
+        <p:txBody>
+          <a:bodyPr/>
+          <a:lstStyle/>
+          <a:p>
+            <a:r>
+              <a:rPr lang="en-US"/>
+              <a:t>9/8/20XX</a:t>
+            </a:r>
+            <a:endParaRPr lang="en-US" dirty="0"/>
+          </a:p>
+        </p:txBody>
+      </p:sp>
+      <p:sp>
+        <p:nvSpPr>
+          <p:cNvPr id="5" name="Footer Placeholder 4"/>
+          <p:cNvSpPr>
+            <a:spLocks noGrp="1"/>
+          </p:cNvSpPr>
+          <p:nvPr>
+            <p:ph type="ftr" sz="quarter" idx="11"/>
+          </p:nvPr>
+        </p:nvSpPr>
+        <p:spPr/>
+        <p:txBody>
+          <a:bodyPr/>
+          <a:lstStyle/>
+          <a:p>
+            <a:r>
+              <a:rPr lang="en-US"/>
+              <a:t>Presentation Title</a:t>
+            </a:r>
+            <a:endParaRPr lang="en-US" dirty="0"/>
+          </a:p>
+        </p:txBody>
+      </p:sp>
+      <p:sp>
+        <p:nvSpPr>
+          <p:cNvPr id="6" name="Slide Number Placeholder 5"/>
+          <p:cNvSpPr>
+            <a:spLocks noGrp="1"/>
+          </p:cNvSpPr>
+          <p:nvPr>
+            <p:ph type="sldNum" sz="quarter" idx="12"/>
+          </p:nvPr>
+        </p:nvSpPr>
+        <p:spPr/>
+        <p:txBody>
+          <a:bodyPr/>
+          <a:lstStyle/>
+          <a:p>
+            <a:fld id="{FAEF9944-A4F6-4C59-AEBD-678D6480B8EA}" type="slidenum">
+              <a:rPr lang="en-US" smtClean="0"/>
+              <a:pPr/>
+              <a:t>‹#›</a:t>
+            </a:fld>
+            <a:endParaRPr lang="en-US" dirty="0"/>
+          </a:p>
+        </p:txBody>
+      </p:sp>
+    </p:spTree>
+    <p:extLst>
+      <p:ext uri="{BB962C8B-B14F-4D97-AF65-F5344CB8AC3E}">
+        <p14:creationId xmlns:p14="http://schemas.microsoft.com/office/powerpoint/2010/main" val="2120849448"/>
+      </p:ext>
+    </p:extLst>
+  </p:cSld>
+  <p:clrMapOvr>
+    <a:masterClrMapping/>
+  </p:clrMapOvr>
+  <p:hf sldNum="0" hdr="0" ftr="0" dt="0"/>
+</p:sldLayout>
+</file>
+
+<file path=ppt/slideLayouts/slideLayout20.xml><?xml version="1.0" encoding="utf-8"?>
 <p:sldLayout xmlns:a="http://schemas.openxmlformats.org/drawingml/2006/main" xmlns:r="http://schemas.openxmlformats.org/officeDocument/2006/relationships" xmlns:p="http://schemas.openxmlformats.org/presentationml/2006/main" userDrawn="1">
   <p:cSld name="Two Content 3">
     <p:spTree>
@@ -9249,7 +8677,7 @@
 </p:sldLayout>
 </file>
 
-<file path=ppt/slideLayouts/slideLayout22.xml><?xml version="1.0" encoding="utf-8"?>
+<file path=ppt/slideLayouts/slideLayout21.xml><?xml version="1.0" encoding="utf-8"?>
 <p:sldLayout xmlns:a="http://schemas.openxmlformats.org/drawingml/2006/main" xmlns:r="http://schemas.openxmlformats.org/officeDocument/2006/relationships" xmlns:p="http://schemas.openxmlformats.org/presentationml/2006/main" userDrawn="1">
   <p:cSld name="Table">
     <p:spTree>
@@ -9751,7 +9179,7 @@
 </p:sldLayout>
 </file>
 
-<file path=ppt/slideLayouts/slideLayout23.xml><?xml version="1.0" encoding="utf-8"?>
+<file path=ppt/slideLayouts/slideLayout22.xml><?xml version="1.0" encoding="utf-8"?>
 <p:sldLayout xmlns:a="http://schemas.openxmlformats.org/drawingml/2006/main" xmlns:r="http://schemas.openxmlformats.org/officeDocument/2006/relationships" xmlns:p="http://schemas.openxmlformats.org/presentationml/2006/main" userDrawn="1">
   <p:cSld name="Content 1">
     <p:spTree>
@@ -10490,7 +9918,7 @@
 </p:sldLayout>
 </file>
 
-<file path=ppt/slideLayouts/slideLayout24.xml><?xml version="1.0" encoding="utf-8"?>
+<file path=ppt/slideLayouts/slideLayout23.xml><?xml version="1.0" encoding="utf-8"?>
 <p:sldLayout xmlns:a="http://schemas.openxmlformats.org/drawingml/2006/main" xmlns:r="http://schemas.openxmlformats.org/officeDocument/2006/relationships" xmlns:p="http://schemas.openxmlformats.org/presentationml/2006/main" showMasterSp="0" preserve="1" userDrawn="1">
   <p:cSld name="1_Title Only">
     <p:spTree>
@@ -12216,7 +11644,7 @@
           <a:p>
             <a:fld id="{005CD215-1C45-48A0-8534-39FFE8A7C95A}" type="datetime1">
               <a:rPr lang="en-US" smtClean="0"/>
-              <a:t>4/24/2025</a:t>
+              <a:t>4/26/2025</a:t>
             </a:fld>
             <a:endParaRPr lang="en-US" dirty="0"/>
           </a:p>
@@ -14052,15 +13480,14 @@
     <p:sldLayoutId id="2147483699" r:id="rId13"/>
     <p:sldLayoutId id="2147483700" r:id="rId14"/>
     <p:sldLayoutId id="2147483701" r:id="rId15"/>
-    <p:sldLayoutId id="2147483702" r:id="rId16"/>
-    <p:sldLayoutId id="2147483703" r:id="rId17"/>
-    <p:sldLayoutId id="2147483704" r:id="rId18"/>
-    <p:sldLayoutId id="2147483705" r:id="rId19"/>
-    <p:sldLayoutId id="2147483706" r:id="rId20"/>
-    <p:sldLayoutId id="2147483707" r:id="rId21"/>
-    <p:sldLayoutId id="2147483708" r:id="rId22"/>
-    <p:sldLayoutId id="2147483709" r:id="rId23"/>
-    <p:sldLayoutId id="2147483682" r:id="rId24"/>
+    <p:sldLayoutId id="2147483703" r:id="rId16"/>
+    <p:sldLayoutId id="2147483704" r:id="rId17"/>
+    <p:sldLayoutId id="2147483705" r:id="rId18"/>
+    <p:sldLayoutId id="2147483706" r:id="rId19"/>
+    <p:sldLayoutId id="2147483707" r:id="rId20"/>
+    <p:sldLayoutId id="2147483708" r:id="rId21"/>
+    <p:sldLayoutId id="2147483709" r:id="rId22"/>
+    <p:sldLayoutId id="2147483682" r:id="rId23"/>
   </p:sldLayoutIdLst>
   <p:hf sldNum="0" hdr="0" ftr="0" dt="0"/>
   <p:txStyles>
@@ -14579,7 +14006,7 @@
           <a:p>
             <a:r>
               <a:rPr lang="en-US" dirty="0"/>
-              <a:t>Dynamic delivery</a:t>
+              <a:t>Results and Evaluation</a:t>
             </a:r>
           </a:p>
         </p:txBody>
@@ -14608,382 +14035,57 @@
           <a:lstStyle/>
           <a:p>
             <a:r>
-              <a:rPr lang="en-US" dirty="0"/>
-              <a:t>Learn to infuse energy into your delivery to leave a lasting impression</a:t>
-            </a:r>
-          </a:p>
-          <a:p>
-            <a:r>
-              <a:rPr lang="en-US" dirty="0"/>
-              <a:t>One of the goals of effective communication is to motivate your audience</a:t>
-            </a:r>
-          </a:p>
-        </p:txBody>
-      </p:sp>
-      <p:graphicFrame>
-        <p:nvGraphicFramePr>
-          <p:cNvPr id="11" name="Content Placeholder 10">
-            <a:extLst>
-              <a:ext uri="{FF2B5EF4-FFF2-40B4-BE49-F238E27FC236}">
-                <a16:creationId xmlns:a16="http://schemas.microsoft.com/office/drawing/2014/main" id="{453CE196-36B9-5361-5120-20DF8B3B5581}"/>
-              </a:ext>
-            </a:extLst>
-          </p:cNvPr>
-          <p:cNvGraphicFramePr>
-            <a:graphicFrameLocks noGrp="1"/>
-          </p:cNvGraphicFramePr>
-          <p:nvPr>
-            <p:ph type="tbl" sz="quarter" idx="15"/>
-            <p:extLst>
-              <p:ext uri="{D42A27DB-BD31-4B8C-83A1-F6EECF244321}">
-                <p14:modId xmlns:p14="http://schemas.microsoft.com/office/powerpoint/2010/main" val="2347872384"/>
-              </p:ext>
-            </p:extLst>
-          </p:nvPr>
-        </p:nvGraphicFramePr>
-        <p:xfrm>
-          <a:off x="5075238" y="461963"/>
-          <a:ext cx="6473825" cy="3867150"/>
-        </p:xfrm>
-        <a:graphic>
-          <a:graphicData uri="http://schemas.openxmlformats.org/drawingml/2006/table">
-            <a:tbl>
-              <a:tblPr firstRow="1" bandRow="1">
-                <a:tableStyleId>{8A107856-5554-42FB-B03E-39F5DBC370BA}</a:tableStyleId>
-              </a:tblPr>
-              <a:tblGrid>
-                <a:gridCol w="2038538">
-                  <a:extLst>
-                    <a:ext uri="{9D8B030D-6E8A-4147-A177-3AD203B41FA5}">
-                      <a16:colId xmlns:a16="http://schemas.microsoft.com/office/drawing/2014/main" val="1123561819"/>
-                    </a:ext>
-                  </a:extLst>
-                </a:gridCol>
-                <a:gridCol w="2097154">
-                  <a:extLst>
-                    <a:ext uri="{9D8B030D-6E8A-4147-A177-3AD203B41FA5}">
-                      <a16:colId xmlns:a16="http://schemas.microsoft.com/office/drawing/2014/main" val="1296588374"/>
-                    </a:ext>
-                  </a:extLst>
-                </a:gridCol>
-                <a:gridCol w="1178835">
-                  <a:extLst>
-                    <a:ext uri="{9D8B030D-6E8A-4147-A177-3AD203B41FA5}">
-                      <a16:colId xmlns:a16="http://schemas.microsoft.com/office/drawing/2014/main" val="1285016582"/>
-                    </a:ext>
-                  </a:extLst>
-                </a:gridCol>
-                <a:gridCol w="1159296">
-                  <a:extLst>
-                    <a:ext uri="{9D8B030D-6E8A-4147-A177-3AD203B41FA5}">
-                      <a16:colId xmlns:a16="http://schemas.microsoft.com/office/drawing/2014/main" val="4218447726"/>
-                    </a:ext>
-                  </a:extLst>
-                </a:gridCol>
-              </a:tblGrid>
-              <a:tr h="477078">
-                <a:tc>
-                  <a:txBody>
-                    <a:bodyPr/>
-                    <a:lstStyle/>
-                    <a:p>
-                      <a:r>
-                        <a:rPr lang="en-US" dirty="0"/>
-                        <a:t>Metric</a:t>
-                      </a:r>
-                    </a:p>
-                  </a:txBody>
-                  <a:tcPr marT="91440" anchor="ctr"/>
-                </a:tc>
-                <a:tc>
-                  <a:txBody>
-                    <a:bodyPr/>
-                    <a:lstStyle/>
-                    <a:p>
-                      <a:r>
-                        <a:rPr lang="en-US" dirty="0"/>
-                        <a:t>Measurement</a:t>
-                      </a:r>
-                    </a:p>
-                  </a:txBody>
-                  <a:tcPr marT="91440" anchor="ctr"/>
-                </a:tc>
-                <a:tc>
-                  <a:txBody>
-                    <a:bodyPr/>
-                    <a:lstStyle/>
-                    <a:p>
-                      <a:r>
-                        <a:rPr lang="en-US" dirty="0"/>
-                        <a:t>Target</a:t>
-                      </a:r>
-                    </a:p>
-                  </a:txBody>
-                  <a:tcPr marT="91440" anchor="ctr"/>
-                </a:tc>
-                <a:tc>
-                  <a:txBody>
-                    <a:bodyPr/>
-                    <a:lstStyle/>
-                    <a:p>
-                      <a:r>
-                        <a:rPr lang="en-US" dirty="0"/>
-                        <a:t>Actual</a:t>
-                      </a:r>
-                    </a:p>
-                  </a:txBody>
-                  <a:tcPr marT="91440" anchor="ctr"/>
-                </a:tc>
-                <a:extLst>
-                  <a:ext uri="{0D108BD9-81ED-4DB2-BD59-A6C34878D82A}">
-                    <a16:rowId xmlns:a16="http://schemas.microsoft.com/office/drawing/2014/main" val="3342107652"/>
-                  </a:ext>
-                </a:extLst>
-              </a:tr>
-              <a:tr h="795131">
-                <a:tc>
-                  <a:txBody>
-                    <a:bodyPr/>
-                    <a:lstStyle/>
-                    <a:p>
-                      <a:r>
-                        <a:rPr lang="en-US" dirty="0"/>
-                        <a:t>Audience attendance</a:t>
-                      </a:r>
-                    </a:p>
-                  </a:txBody>
-                  <a:tcPr marT="91440" anchor="ctr"/>
-                </a:tc>
-                <a:tc>
-                  <a:txBody>
-                    <a:bodyPr/>
-                    <a:lstStyle/>
-                    <a:p>
-                      <a:r>
-                        <a:rPr lang="en-US" dirty="0"/>
-                        <a:t># of attendees</a:t>
-                      </a:r>
-                    </a:p>
-                  </a:txBody>
-                  <a:tcPr marT="91440" anchor="ctr"/>
-                </a:tc>
-                <a:tc>
-                  <a:txBody>
-                    <a:bodyPr/>
-                    <a:lstStyle/>
-                    <a:p>
-                      <a:r>
-                        <a:rPr lang="en-US" dirty="0"/>
-                        <a:t>150</a:t>
-                      </a:r>
-                    </a:p>
-                  </a:txBody>
-                  <a:tcPr marT="91440" anchor="ctr"/>
-                </a:tc>
-                <a:tc>
-                  <a:txBody>
-                    <a:bodyPr/>
-                    <a:lstStyle/>
-                    <a:p>
-                      <a:r>
-                        <a:rPr lang="en-US" dirty="0"/>
-                        <a:t>120</a:t>
-                      </a:r>
-                    </a:p>
-                  </a:txBody>
-                  <a:tcPr marT="91440" anchor="ctr"/>
-                </a:tc>
-                <a:extLst>
-                  <a:ext uri="{0D108BD9-81ED-4DB2-BD59-A6C34878D82A}">
-                    <a16:rowId xmlns:a16="http://schemas.microsoft.com/office/drawing/2014/main" val="57143556"/>
-                  </a:ext>
-                </a:extLst>
-              </a:tr>
-              <a:tr h="795131">
-                <a:tc>
-                  <a:txBody>
-                    <a:bodyPr/>
-                    <a:lstStyle/>
-                    <a:p>
-                      <a:r>
-                        <a:rPr lang="en-US" dirty="0"/>
-                        <a:t>Engagement duration</a:t>
-                      </a:r>
-                    </a:p>
-                  </a:txBody>
-                  <a:tcPr marT="91440" anchor="ctr"/>
-                </a:tc>
-                <a:tc>
-                  <a:txBody>
-                    <a:bodyPr/>
-                    <a:lstStyle/>
-                    <a:p>
-                      <a:r>
-                        <a:rPr lang="en-US" dirty="0"/>
-                        <a:t>Minutes</a:t>
-                      </a:r>
-                    </a:p>
-                  </a:txBody>
-                  <a:tcPr marT="91440" anchor="ctr"/>
-                </a:tc>
-                <a:tc>
-                  <a:txBody>
-                    <a:bodyPr/>
-                    <a:lstStyle/>
-                    <a:p>
-                      <a:r>
-                        <a:rPr lang="en-US" dirty="0"/>
-                        <a:t>60</a:t>
-                      </a:r>
-                    </a:p>
-                  </a:txBody>
-                  <a:tcPr marT="91440" anchor="ctr"/>
-                </a:tc>
-                <a:tc>
-                  <a:txBody>
-                    <a:bodyPr/>
-                    <a:lstStyle/>
-                    <a:p>
-                      <a:r>
-                        <a:rPr lang="en-US" dirty="0"/>
-                        <a:t>75</a:t>
-                      </a:r>
-                    </a:p>
-                  </a:txBody>
-                  <a:tcPr marT="91440" anchor="ctr"/>
-                </a:tc>
-                <a:extLst>
-                  <a:ext uri="{0D108BD9-81ED-4DB2-BD59-A6C34878D82A}">
-                    <a16:rowId xmlns:a16="http://schemas.microsoft.com/office/drawing/2014/main" val="2328625713"/>
-                  </a:ext>
-                </a:extLst>
-              </a:tr>
-              <a:tr h="795131">
-                <a:tc>
-                  <a:txBody>
-                    <a:bodyPr/>
-                    <a:lstStyle/>
-                    <a:p>
-                      <a:r>
-                        <a:rPr lang="en-US" dirty="0"/>
-                        <a:t>Q&amp;A interaction</a:t>
-                      </a:r>
-                    </a:p>
-                  </a:txBody>
-                  <a:tcPr marT="91440" anchor="ctr"/>
-                </a:tc>
-                <a:tc>
-                  <a:txBody>
-                    <a:bodyPr/>
-                    <a:lstStyle/>
-                    <a:p>
-                      <a:r>
-                        <a:rPr lang="en-US" dirty="0"/>
-                        <a:t># of questions</a:t>
-                      </a:r>
-                    </a:p>
-                  </a:txBody>
-                  <a:tcPr marT="91440" anchor="ctr"/>
-                </a:tc>
-                <a:tc>
-                  <a:txBody>
-                    <a:bodyPr/>
-                    <a:lstStyle/>
-                    <a:p>
-                      <a:r>
-                        <a:rPr lang="en-US" dirty="0"/>
-                        <a:t>10</a:t>
-                      </a:r>
-                    </a:p>
-                  </a:txBody>
-                  <a:tcPr marT="91440" anchor="ctr"/>
-                </a:tc>
-                <a:tc>
-                  <a:txBody>
-                    <a:bodyPr/>
-                    <a:lstStyle/>
-                    <a:p>
-                      <a:r>
-                        <a:rPr lang="en-US" dirty="0"/>
-                        <a:t>15</a:t>
-                      </a:r>
-                    </a:p>
-                  </a:txBody>
-                  <a:tcPr marT="91440" anchor="ctr"/>
-                </a:tc>
-                <a:extLst>
-                  <a:ext uri="{0D108BD9-81ED-4DB2-BD59-A6C34878D82A}">
-                    <a16:rowId xmlns:a16="http://schemas.microsoft.com/office/drawing/2014/main" val="280048660"/>
-                  </a:ext>
-                </a:extLst>
-              </a:tr>
-              <a:tr h="795131">
-                <a:tc>
-                  <a:txBody>
-                    <a:bodyPr/>
-                    <a:lstStyle/>
-                    <a:p>
-                      <a:r>
-                        <a:rPr lang="en-US" dirty="0"/>
-                        <a:t>Positive feedback</a:t>
-                      </a:r>
-                    </a:p>
-                  </a:txBody>
-                  <a:tcPr marT="91440" anchor="ctr"/>
-                </a:tc>
-                <a:tc>
-                  <a:txBody>
-                    <a:bodyPr/>
-                    <a:lstStyle/>
-                    <a:p>
-                      <a:r>
-                        <a:rPr lang="en-US" dirty="0"/>
-                        <a:t>Percentage (%)</a:t>
-                      </a:r>
-                    </a:p>
-                  </a:txBody>
-                  <a:tcPr marT="91440" anchor="ctr"/>
-                </a:tc>
-                <a:tc>
-                  <a:txBody>
-                    <a:bodyPr/>
-                    <a:lstStyle/>
-                    <a:p>
-                      <a:r>
-                        <a:rPr lang="en-US" dirty="0"/>
-                        <a:t>90</a:t>
-                      </a:r>
-                    </a:p>
-                  </a:txBody>
-                  <a:tcPr marT="91440" anchor="ctr"/>
-                </a:tc>
-                <a:tc>
-                  <a:txBody>
-                    <a:bodyPr/>
-                    <a:lstStyle/>
-                    <a:p>
-                      <a:r>
-                        <a:rPr lang="en-US" dirty="0"/>
-                        <a:t>95</a:t>
-                      </a:r>
-                    </a:p>
-                  </a:txBody>
-                  <a:tcPr marT="91440" anchor="ctr"/>
-                </a:tc>
-                <a:extLst>
-                  <a:ext uri="{0D108BD9-81ED-4DB2-BD59-A6C34878D82A}">
-                    <a16:rowId xmlns:a16="http://schemas.microsoft.com/office/drawing/2014/main" val="3515855353"/>
-                  </a:ext>
-                </a:extLst>
-              </a:tr>
-            </a:tbl>
-          </a:graphicData>
-        </a:graphic>
-      </p:graphicFrame>
+              <a:rPr lang="en-US" dirty="0" err="1"/>
+              <a:t>asdfasdfasdf</a:t>
+            </a:r>
+            <a:endParaRPr lang="en-US" dirty="0"/>
+          </a:p>
+          <a:p>
+            <a:endParaRPr lang="en-US" dirty="0"/>
+          </a:p>
+        </p:txBody>
+      </p:sp>
+      <p:sp>
+        <p:nvSpPr>
+          <p:cNvPr id="7" name="Content Placeholder 6">
+            <a:extLst>
+              <a:ext uri="{FF2B5EF4-FFF2-40B4-BE49-F238E27FC236}">
+                <a16:creationId xmlns:a16="http://schemas.microsoft.com/office/drawing/2014/main" id="{7078F1DC-7EF8-5514-E97B-D47663F284D3}"/>
+              </a:ext>
+            </a:extLst>
+          </p:cNvPr>
+          <p:cNvSpPr>
+            <a:spLocks noGrp="1"/>
+          </p:cNvSpPr>
+          <p:nvPr>
+            <p:ph sz="quarter" idx="19"/>
+          </p:nvPr>
+        </p:nvSpPr>
+        <p:spPr/>
+        <p:txBody>
+          <a:bodyPr>
+            <a:normAutofit/>
+          </a:bodyPr>
+          <a:lstStyle/>
+          <a:p>
+            <a:r>
+              <a:rPr lang="en-US" dirty="0" err="1"/>
+              <a:t>asdfasdf</a:t>
+            </a:r>
+            <a:endParaRPr lang="en-US" dirty="0"/>
+          </a:p>
+          <a:p>
+            <a:endParaRPr lang="en-US" dirty="0"/>
+          </a:p>
+          <a:p>
+            <a:endParaRPr lang="en-US" dirty="0"/>
+          </a:p>
+        </p:txBody>
+      </p:sp>
     </p:spTree>
     <p:extLst>
       <p:ext uri="{BB962C8B-B14F-4D97-AF65-F5344CB8AC3E}">
-        <p14:creationId xmlns:p14="http://schemas.microsoft.com/office/powerpoint/2010/main" val="2394014735"/>
+        <p14:creationId xmlns:p14="http://schemas.microsoft.com/office/powerpoint/2010/main" val="4153247059"/>
       </p:ext>
     </p:extLst>
   </p:cSld>
@@ -15012,10 +14114,10 @@
       </p:grpSpPr>
       <p:sp>
         <p:nvSpPr>
-          <p:cNvPr id="2" name="Title 1">
-            <a:extLst>
-              <a:ext uri="{FF2B5EF4-FFF2-40B4-BE49-F238E27FC236}">
-                <a16:creationId xmlns:a16="http://schemas.microsoft.com/office/drawing/2014/main" id="{E2D30E0F-10C6-298A-C347-E831FFF4ECB8}"/>
+          <p:cNvPr id="6" name="Title 5">
+            <a:extLst>
+              <a:ext uri="{FF2B5EF4-FFF2-40B4-BE49-F238E27FC236}">
+                <a16:creationId xmlns:a16="http://schemas.microsoft.com/office/drawing/2014/main" id="{AFE67981-079D-4463-B997-67E6CA039B58}"/>
               </a:ext>
             </a:extLst>
           </p:cNvPr>
@@ -15033,210 +14135,7 @@
           <a:p>
             <a:r>
               <a:rPr lang="en-US" dirty="0"/>
-              <a:t>Final tips &amp; takeaways</a:t>
-            </a:r>
-          </a:p>
-        </p:txBody>
-      </p:sp>
-      <p:sp>
-        <p:nvSpPr>
-          <p:cNvPr id="3" name="Content Placeholder 2">
-            <a:extLst>
-              <a:ext uri="{FF2B5EF4-FFF2-40B4-BE49-F238E27FC236}">
-                <a16:creationId xmlns:a16="http://schemas.microsoft.com/office/drawing/2014/main" id="{41191CC7-9CF2-71F0-1AD4-791EA9CBAD97}"/>
-              </a:ext>
-            </a:extLst>
-          </p:cNvPr>
-          <p:cNvSpPr>
-            <a:spLocks noGrp="1"/>
-          </p:cNvSpPr>
-          <p:nvPr>
-            <p:ph sz="quarter" idx="14"/>
-          </p:nvPr>
-        </p:nvSpPr>
-        <p:spPr/>
-        <p:txBody>
-          <a:bodyPr>
-            <a:normAutofit/>
-          </a:bodyPr>
-          <a:lstStyle/>
-          <a:p>
-            <a:r>
-              <a:rPr lang="en-US" dirty="0"/>
-              <a:t>Seek feedback</a:t>
-            </a:r>
-          </a:p>
-          <a:p>
-            <a:r>
-              <a:rPr lang="en-US" dirty="0"/>
-              <a:t>Reflect on performance</a:t>
-            </a:r>
-          </a:p>
-          <a:p>
-            <a:r>
-              <a:rPr lang="en-US" dirty="0"/>
-              <a:t>Explore new techniques</a:t>
-            </a:r>
-          </a:p>
-          <a:p>
-            <a:r>
-              <a:rPr lang="en-US" dirty="0"/>
-              <a:t>Set personal goals</a:t>
-            </a:r>
-          </a:p>
-          <a:p>
-            <a:r>
-              <a:rPr lang="en-US" dirty="0"/>
-              <a:t>Iterate and adapt</a:t>
-            </a:r>
-          </a:p>
-          <a:p>
-            <a:r>
-              <a:rPr lang="en-US" dirty="0"/>
-              <a:t>Consistent rehearsal</a:t>
-            </a:r>
-          </a:p>
-          <a:p>
-            <a:endParaRPr lang="en-US" dirty="0"/>
-          </a:p>
-        </p:txBody>
-      </p:sp>
-      <p:sp>
-        <p:nvSpPr>
-          <p:cNvPr id="7" name="Content Placeholder 6">
-            <a:extLst>
-              <a:ext uri="{FF2B5EF4-FFF2-40B4-BE49-F238E27FC236}">
-                <a16:creationId xmlns:a16="http://schemas.microsoft.com/office/drawing/2014/main" id="{7078F1DC-7EF8-5514-E97B-D47663F284D3}"/>
-              </a:ext>
-            </a:extLst>
-          </p:cNvPr>
-          <p:cNvSpPr>
-            <a:spLocks noGrp="1"/>
-          </p:cNvSpPr>
-          <p:nvPr>
-            <p:ph sz="quarter" idx="19"/>
-          </p:nvPr>
-        </p:nvSpPr>
-        <p:spPr/>
-        <p:txBody>
-          <a:bodyPr>
-            <a:normAutofit lnSpcReduction="10000"/>
-          </a:bodyPr>
-          <a:lstStyle/>
-          <a:p>
-            <a:r>
-              <a:rPr lang="en-US" dirty="0"/>
-              <a:t>Consistent rehearsal</a:t>
-            </a:r>
-          </a:p>
-          <a:p>
-            <a:pPr lvl="1"/>
-            <a:r>
-              <a:rPr lang="en-US" dirty="0"/>
-              <a:t>Strengthen your familiarity</a:t>
-            </a:r>
-          </a:p>
-          <a:p>
-            <a:r>
-              <a:rPr lang="en-US" dirty="0"/>
-              <a:t>Refine delivery style</a:t>
-            </a:r>
-          </a:p>
-          <a:p>
-            <a:pPr lvl="1"/>
-            <a:r>
-              <a:rPr lang="en-US" dirty="0"/>
-              <a:t>Pacing, tone, and emphasis</a:t>
-            </a:r>
-          </a:p>
-          <a:p>
-            <a:r>
-              <a:rPr lang="en-US" dirty="0"/>
-              <a:t>Timing and transitions</a:t>
-            </a:r>
-          </a:p>
-          <a:p>
-            <a:pPr lvl="1"/>
-            <a:r>
-              <a:rPr lang="en-US" dirty="0"/>
-              <a:t>Aim for seamless, professional delivery</a:t>
-            </a:r>
-          </a:p>
-          <a:p>
-            <a:r>
-              <a:rPr lang="en-US" dirty="0"/>
-              <a:t>Practice audience</a:t>
-            </a:r>
-          </a:p>
-          <a:p>
-            <a:pPr lvl="1"/>
-            <a:r>
-              <a:rPr lang="en-US" dirty="0"/>
-              <a:t>Enlist colleagues to listen &amp; provide feedback</a:t>
-            </a:r>
-          </a:p>
-          <a:p>
-            <a:endParaRPr lang="en-US" dirty="0"/>
-          </a:p>
-          <a:p>
-            <a:endParaRPr lang="en-US" dirty="0"/>
-          </a:p>
-        </p:txBody>
-      </p:sp>
-    </p:spTree>
-    <p:extLst>
-      <p:ext uri="{BB962C8B-B14F-4D97-AF65-F5344CB8AC3E}">
-        <p14:creationId xmlns:p14="http://schemas.microsoft.com/office/powerpoint/2010/main" val="4153247059"/>
-      </p:ext>
-    </p:extLst>
-  </p:cSld>
-  <p:clrMapOvr>
-    <a:masterClrMapping/>
-  </p:clrMapOvr>
-</p:sld>
-</file>
-
-<file path=ppt/slides/slide12.xml><?xml version="1.0" encoding="utf-8"?>
-<p:sld xmlns:a="http://schemas.openxmlformats.org/drawingml/2006/main" xmlns:r="http://schemas.openxmlformats.org/officeDocument/2006/relationships" xmlns:p="http://schemas.openxmlformats.org/presentationml/2006/main">
-  <p:cSld>
-    <p:spTree>
-      <p:nvGrpSpPr>
-        <p:cNvPr id="1" name=""/>
-        <p:cNvGrpSpPr/>
-        <p:nvPr/>
-      </p:nvGrpSpPr>
-      <p:grpSpPr>
-        <a:xfrm>
-          <a:off x="0" y="0"/>
-          <a:ext cx="0" cy="0"/>
-          <a:chOff x="0" y="0"/>
-          <a:chExt cx="0" cy="0"/>
-        </a:xfrm>
-      </p:grpSpPr>
-      <p:sp>
-        <p:nvSpPr>
-          <p:cNvPr id="6" name="Title 5">
-            <a:extLst>
-              <a:ext uri="{FF2B5EF4-FFF2-40B4-BE49-F238E27FC236}">
-                <a16:creationId xmlns:a16="http://schemas.microsoft.com/office/drawing/2014/main" id="{AFE67981-079D-4463-B997-67E6CA039B58}"/>
-              </a:ext>
-            </a:extLst>
-          </p:cNvPr>
-          <p:cNvSpPr>
-            <a:spLocks noGrp="1"/>
-          </p:cNvSpPr>
-          <p:nvPr>
-            <p:ph type="title"/>
-          </p:nvPr>
-        </p:nvSpPr>
-        <p:spPr/>
-        <p:txBody>
-          <a:bodyPr/>
-          <a:lstStyle/>
-          <a:p>
-            <a:r>
-              <a:rPr lang="en-US" dirty="0"/>
-              <a:t>Speaking engagement metrics</a:t>
+              <a:t>Conclusion</a:t>
             </a:r>
           </a:p>
         </p:txBody>
@@ -15257,14 +14156,14 @@
             <p:ph type="tbl" sz="quarter" idx="14"/>
             <p:extLst>
               <p:ext uri="{D42A27DB-BD31-4B8C-83A1-F6EECF244321}">
-                <p14:modId xmlns:p14="http://schemas.microsoft.com/office/powerpoint/2010/main" val="1313099663"/>
+                <p14:modId xmlns:p14="http://schemas.microsoft.com/office/powerpoint/2010/main" val="1372280552"/>
               </p:ext>
             </p:extLst>
           </p:nvPr>
         </p:nvGraphicFramePr>
         <p:xfrm>
           <a:off x="1630363" y="2757488"/>
-          <a:ext cx="9918700" cy="3387725"/>
+          <a:ext cx="9918700" cy="3383280"/>
         </p:xfrm>
         <a:graphic>
           <a:graphicData uri="http://schemas.openxmlformats.org/drawingml/2006/table">
@@ -15314,7 +14213,7 @@
                             <a:schemeClr val="tx1"/>
                           </a:solidFill>
                         </a:rPr>
-                        <a:t>Impact factor</a:t>
+                        <a:t>NOT FOR USE IN FINAL</a:t>
                       </a:r>
                     </a:p>
                   </a:txBody>
@@ -15689,7 +14588,7 @@
 </p:sld>
 </file>
 
-<file path=ppt/slides/slide13.xml><?xml version="1.0" encoding="utf-8"?>
+<file path=ppt/slides/slide12.xml><?xml version="1.0" encoding="utf-8"?>
 <p:sld xmlns:a="http://schemas.openxmlformats.org/drawingml/2006/main" xmlns:r="http://schemas.openxmlformats.org/officeDocument/2006/relationships" xmlns:p="http://schemas.openxmlformats.org/presentationml/2006/main">
   <p:cSld>
     <p:spTree>
@@ -15730,54 +14629,6 @@
             <a:r>
               <a:rPr lang="en-US" dirty="0"/>
               <a:t>THANK YOU</a:t>
-            </a:r>
-          </a:p>
-        </p:txBody>
-      </p:sp>
-      <p:sp>
-        <p:nvSpPr>
-          <p:cNvPr id="5" name="Content Placeholder 4">
-            <a:extLst>
-              <a:ext uri="{FF2B5EF4-FFF2-40B4-BE49-F238E27FC236}">
-                <a16:creationId xmlns:a16="http://schemas.microsoft.com/office/drawing/2014/main" id="{5755816F-F516-477A-8EF2-D8CA20267590}"/>
-              </a:ext>
-            </a:extLst>
-          </p:cNvPr>
-          <p:cNvSpPr>
-            <a:spLocks noGrp="1"/>
-          </p:cNvSpPr>
-          <p:nvPr>
-            <p:ph idx="1"/>
-          </p:nvPr>
-        </p:nvSpPr>
-        <p:spPr/>
-        <p:txBody>
-          <a:bodyPr>
-            <a:normAutofit/>
-          </a:bodyPr>
-          <a:lstStyle/>
-          <a:p>
-            <a:r>
-              <a:rPr lang="en-US" dirty="0"/>
-              <a:t>Brita Tamm</a:t>
-            </a:r>
-          </a:p>
-          <a:p>
-            <a:r>
-              <a:rPr lang="en-US" dirty="0"/>
-              <a:t>502-555-0152</a:t>
-            </a:r>
-          </a:p>
-          <a:p>
-            <a:r>
-              <a:rPr lang="en-US" dirty="0"/>
-              <a:t>brita@firstupconsultants.com</a:t>
-            </a:r>
-          </a:p>
-          <a:p>
-            <a:r>
-              <a:rPr lang="en-US" dirty="0"/>
-              <a:t>www.firstupconsultants.com</a:t>
             </a:r>
           </a:p>
         </p:txBody>
@@ -15828,7 +14679,12 @@
             <p:ph type="title"/>
           </p:nvPr>
         </p:nvSpPr>
-        <p:spPr/>
+        <p:spPr>
+          <a:xfrm>
+            <a:off x="787178" y="1361923"/>
+            <a:ext cx="6623040" cy="741197"/>
+          </a:xfrm>
+        </p:spPr>
         <p:txBody>
           <a:bodyPr>
             <a:normAutofit/>
@@ -15837,7 +14693,7 @@
           <a:p>
             <a:r>
               <a:rPr lang="en-US" dirty="0"/>
-              <a:t>Agenda</a:t>
+              <a:t>Executive Summary</a:t>
             </a:r>
           </a:p>
         </p:txBody>
@@ -15858,40 +14714,294 @@
             <p:ph sz="quarter" idx="14"/>
           </p:nvPr>
         </p:nvSpPr>
-        <p:spPr/>
+        <p:spPr>
+          <a:xfrm>
+            <a:off x="787399" y="2103120"/>
+            <a:ext cx="6622819" cy="3666291"/>
+          </a:xfrm>
+        </p:spPr>
         <p:txBody>
           <a:bodyPr>
+            <a:normAutofit fontScale="92500" lnSpcReduction="20000"/>
+          </a:bodyPr>
+          <a:lstStyle/>
+          <a:p>
+            <a:r>
+              <a:rPr lang="en-US" dirty="0"/>
+              <a:t>This project is aimed at producing accurate predictions for tax-assessed value of homes based on the Zillow Housing Dataset. </a:t>
+            </a:r>
+          </a:p>
+          <a:p>
+            <a:pPr marL="342900" indent="-342900">
+              <a:buFont typeface="Arial" panose="020B0604020202020204" pitchFamily="34" charset="0"/>
+              <a:buChar char="•"/>
+            </a:pPr>
+            <a:r>
+              <a:rPr lang="en-US" dirty="0"/>
+              <a:t>Includes features like square footage, location, bed/bathrooms, and more</a:t>
+            </a:r>
+          </a:p>
+          <a:p>
+            <a:pPr marL="342900" indent="-342900">
+              <a:buFont typeface="Arial" panose="020B0604020202020204" pitchFamily="34" charset="0"/>
+              <a:buChar char="•"/>
+            </a:pPr>
+            <a:r>
+              <a:rPr lang="en-US" dirty="0"/>
+              <a:t>Performed cleaning, preprocessing, and feature engineering on the data</a:t>
+            </a:r>
+          </a:p>
+          <a:p>
+            <a:pPr marL="342900" indent="-342900">
+              <a:buFont typeface="Arial" panose="020B0604020202020204" pitchFamily="34" charset="0"/>
+              <a:buChar char="•"/>
+            </a:pPr>
+            <a:r>
+              <a:rPr lang="en-US" dirty="0"/>
+              <a:t>Decided on Gradient Boosting Regressor after testing a number of different models</a:t>
+            </a:r>
+          </a:p>
+        </p:txBody>
+      </p:sp>
+      <p:sp>
+        <p:nvSpPr>
+          <p:cNvPr id="2" name="Content Placeholder 4">
+            <a:extLst>
+              <a:ext uri="{FF2B5EF4-FFF2-40B4-BE49-F238E27FC236}">
+                <a16:creationId xmlns:a16="http://schemas.microsoft.com/office/drawing/2014/main" id="{97F0A541-E300-EB3F-28C9-95BA747BD235}"/>
+              </a:ext>
+            </a:extLst>
+          </p:cNvPr>
+          <p:cNvSpPr txBox="1">
+            <a:spLocks/>
+          </p:cNvSpPr>
+          <p:nvPr/>
+        </p:nvSpPr>
+        <p:spPr>
+          <a:xfrm>
+            <a:off x="8485632" y="1361924"/>
+            <a:ext cx="3438674" cy="4407488"/>
+          </a:xfrm>
+          <a:prstGeom prst="rect">
+            <a:avLst/>
+          </a:prstGeom>
+        </p:spPr>
+        <p:txBody>
+          <a:bodyPr vert="horz" lIns="109728" tIns="109728" rIns="109728" bIns="91440" rtlCol="0" anchor="t">
             <a:normAutofit/>
           </a:bodyPr>
-          <a:lstStyle/>
+          <a:lstStyle>
+            <a:lvl1pPr marL="0" indent="0" algn="l" defTabSz="914400" rtl="0" eaLnBrk="1" latinLnBrk="0" hangingPunct="1">
+              <a:lnSpc>
+                <a:spcPct val="125000"/>
+              </a:lnSpc>
+              <a:spcBef>
+                <a:spcPts val="930"/>
+              </a:spcBef>
+              <a:spcAft>
+                <a:spcPts val="600"/>
+              </a:spcAft>
+              <a:buFont typeface="Corbel" panose="020B0503020204020204" pitchFamily="34" charset="0"/>
+              <a:buNone/>
+              <a:defRPr sz="2000" b="0" kern="1200" spc="150" baseline="0">
+                <a:solidFill>
+                  <a:schemeClr val="tx1">
+                    <a:lumMod val="75000"/>
+                    <a:lumOff val="25000"/>
+                  </a:schemeClr>
+                </a:solidFill>
+                <a:latin typeface="+mn-lt"/>
+                <a:ea typeface="+mn-ea"/>
+                <a:cs typeface="+mn-cs"/>
+              </a:defRPr>
+            </a:lvl1pPr>
+            <a:lvl2pPr marL="0" indent="0" algn="l" defTabSz="914400" rtl="0" eaLnBrk="1" latinLnBrk="0" hangingPunct="1">
+              <a:lnSpc>
+                <a:spcPct val="125000"/>
+              </a:lnSpc>
+              <a:spcBef>
+                <a:spcPts val="930"/>
+              </a:spcBef>
+              <a:spcAft>
+                <a:spcPts val="600"/>
+              </a:spcAft>
+              <a:buFont typeface="Corbel" panose="020B0503020204020204" pitchFamily="34" charset="0"/>
+              <a:buNone/>
+              <a:defRPr sz="1600" kern="1200" spc="150" baseline="0">
+                <a:solidFill>
+                  <a:schemeClr val="tx1">
+                    <a:lumMod val="75000"/>
+                    <a:lumOff val="25000"/>
+                  </a:schemeClr>
+                </a:solidFill>
+                <a:latin typeface="+mn-lt"/>
+                <a:ea typeface="+mn-ea"/>
+                <a:cs typeface="+mn-cs"/>
+              </a:defRPr>
+            </a:lvl2pPr>
+            <a:lvl3pPr marL="0" indent="-320040" algn="l" defTabSz="914400" rtl="0" eaLnBrk="1" latinLnBrk="0" hangingPunct="1">
+              <a:lnSpc>
+                <a:spcPct val="125000"/>
+              </a:lnSpc>
+              <a:spcBef>
+                <a:spcPts val="930"/>
+              </a:spcBef>
+              <a:spcAft>
+                <a:spcPts val="600"/>
+              </a:spcAft>
+              <a:buFont typeface="Corbel" panose="020B0503020204020204" pitchFamily="34" charset="0"/>
+              <a:buChar char="–"/>
+              <a:defRPr sz="1400" i="1" kern="1200" spc="150" baseline="0">
+                <a:solidFill>
+                  <a:schemeClr val="tx1">
+                    <a:lumMod val="75000"/>
+                    <a:lumOff val="25000"/>
+                  </a:schemeClr>
+                </a:solidFill>
+                <a:latin typeface="+mn-lt"/>
+                <a:ea typeface="+mn-ea"/>
+                <a:cs typeface="+mn-cs"/>
+              </a:defRPr>
+            </a:lvl3pPr>
+            <a:lvl4pPr marL="0" indent="-320040" algn="l" defTabSz="914400" rtl="0" eaLnBrk="1" latinLnBrk="0" hangingPunct="1">
+              <a:lnSpc>
+                <a:spcPct val="125000"/>
+              </a:lnSpc>
+              <a:spcBef>
+                <a:spcPts val="930"/>
+              </a:spcBef>
+              <a:spcAft>
+                <a:spcPts val="600"/>
+              </a:spcAft>
+              <a:buFont typeface="Corbel" panose="020B0503020204020204" pitchFamily="34" charset="0"/>
+              <a:buChar char="–"/>
+              <a:defRPr sz="1400" kern="1200" spc="150" baseline="0">
+                <a:solidFill>
+                  <a:schemeClr val="tx1">
+                    <a:lumMod val="75000"/>
+                    <a:lumOff val="25000"/>
+                  </a:schemeClr>
+                </a:solidFill>
+                <a:latin typeface="+mn-lt"/>
+                <a:ea typeface="+mn-ea"/>
+                <a:cs typeface="+mn-cs"/>
+              </a:defRPr>
+            </a:lvl4pPr>
+            <a:lvl5pPr marL="0" indent="-320040" algn="l" defTabSz="914400" rtl="0" eaLnBrk="1" latinLnBrk="0" hangingPunct="1">
+              <a:lnSpc>
+                <a:spcPct val="125000"/>
+              </a:lnSpc>
+              <a:spcBef>
+                <a:spcPts val="930"/>
+              </a:spcBef>
+              <a:spcAft>
+                <a:spcPts val="600"/>
+              </a:spcAft>
+              <a:buFont typeface="Corbel" panose="020B0503020204020204" pitchFamily="34" charset="0"/>
+              <a:buChar char="–"/>
+              <a:defRPr sz="1400" i="1" kern="1200" spc="150" baseline="0">
+                <a:solidFill>
+                  <a:schemeClr val="tx1">
+                    <a:lumMod val="75000"/>
+                    <a:lumOff val="25000"/>
+                  </a:schemeClr>
+                </a:solidFill>
+                <a:latin typeface="+mn-lt"/>
+                <a:ea typeface="+mn-ea"/>
+                <a:cs typeface="+mn-cs"/>
+              </a:defRPr>
+            </a:lvl5pPr>
+            <a:lvl6pPr marL="1920240" indent="-320040" algn="l" defTabSz="914400" rtl="0" eaLnBrk="1" latinLnBrk="0" hangingPunct="1">
+              <a:lnSpc>
+                <a:spcPct val="111000"/>
+              </a:lnSpc>
+              <a:spcBef>
+                <a:spcPts val="930"/>
+              </a:spcBef>
+              <a:buFont typeface="Corbel" panose="020B0503020204020204" pitchFamily="34" charset="0"/>
+              <a:buChar char="–"/>
+              <a:defRPr sz="1400" kern="1200">
+                <a:solidFill>
+                  <a:schemeClr val="accent1">
+                    <a:lumMod val="75000"/>
+                  </a:schemeClr>
+                </a:solidFill>
+                <a:latin typeface="+mn-lt"/>
+                <a:ea typeface="+mn-ea"/>
+                <a:cs typeface="+mn-cs"/>
+              </a:defRPr>
+            </a:lvl6pPr>
+            <a:lvl7pPr marL="2240280" indent="-320040" algn="l" defTabSz="914400" rtl="0" eaLnBrk="1" latinLnBrk="0" hangingPunct="1">
+              <a:lnSpc>
+                <a:spcPct val="111000"/>
+              </a:lnSpc>
+              <a:spcBef>
+                <a:spcPts val="930"/>
+              </a:spcBef>
+              <a:buFont typeface="Corbel" panose="020B0503020204020204" pitchFamily="34" charset="0"/>
+              <a:buChar char="–"/>
+              <a:defRPr sz="1400" i="1" kern="1200">
+                <a:solidFill>
+                  <a:schemeClr val="accent1">
+                    <a:lumMod val="75000"/>
+                  </a:schemeClr>
+                </a:solidFill>
+                <a:latin typeface="+mn-lt"/>
+                <a:ea typeface="+mn-ea"/>
+                <a:cs typeface="+mn-cs"/>
+              </a:defRPr>
+            </a:lvl7pPr>
+            <a:lvl8pPr marL="2560320" indent="-320040" algn="l" defTabSz="914400" rtl="0" eaLnBrk="1" latinLnBrk="0" hangingPunct="1">
+              <a:lnSpc>
+                <a:spcPct val="111000"/>
+              </a:lnSpc>
+              <a:spcBef>
+                <a:spcPts val="930"/>
+              </a:spcBef>
+              <a:buFont typeface="Corbel" panose="020B0503020204020204" pitchFamily="34" charset="0"/>
+              <a:buChar char="–"/>
+              <a:defRPr sz="1400" kern="1200">
+                <a:solidFill>
+                  <a:schemeClr val="accent1">
+                    <a:lumMod val="75000"/>
+                  </a:schemeClr>
+                </a:solidFill>
+                <a:latin typeface="+mn-lt"/>
+                <a:ea typeface="+mn-ea"/>
+                <a:cs typeface="+mn-cs"/>
+              </a:defRPr>
+            </a:lvl8pPr>
+            <a:lvl9pPr marL="2880360" indent="-320040" algn="l" defTabSz="914400" rtl="0" eaLnBrk="1" latinLnBrk="0" hangingPunct="1">
+              <a:lnSpc>
+                <a:spcPct val="111000"/>
+              </a:lnSpc>
+              <a:spcBef>
+                <a:spcPts val="930"/>
+              </a:spcBef>
+              <a:buFont typeface="Corbel" panose="020B0503020204020204" pitchFamily="34" charset="0"/>
+              <a:buChar char="–"/>
+              <a:defRPr sz="1400" i="1" kern="1200">
+                <a:solidFill>
+                  <a:schemeClr val="accent1">
+                    <a:lumMod val="75000"/>
+                  </a:schemeClr>
+                </a:solidFill>
+                <a:latin typeface="+mn-lt"/>
+                <a:ea typeface="+mn-ea"/>
+                <a:cs typeface="+mn-cs"/>
+              </a:defRPr>
+            </a:lvl9pPr>
+          </a:lstStyle>
           <a:p>
             <a:r>
               <a:rPr lang="en-US" dirty="0"/>
-              <a:t>Introduction</a:t>
+              <a:t>Result:</a:t>
             </a:r>
           </a:p>
           <a:p>
             <a:r>
               <a:rPr lang="en-US" dirty="0"/>
-              <a:t>Building confidence</a:t>
-            </a:r>
-          </a:p>
-          <a:p>
-            <a:r>
-              <a:rPr lang="en-US" dirty="0"/>
-              <a:t>Engaging the audience</a:t>
-            </a:r>
-          </a:p>
-          <a:p>
-            <a:r>
-              <a:rPr lang="en-US" dirty="0"/>
-              <a:t>Visual aids</a:t>
-            </a:r>
-          </a:p>
-          <a:p>
-            <a:r>
-              <a:rPr lang="en-US" dirty="0"/>
-              <a:t>Final tips &amp; takeaways</a:t>
+              <a:t>A reliable and interpretable model that can support homeowners, real estate investors, and tax authorities with property valuations.</a:t>
             </a:r>
           </a:p>
         </p:txBody>
@@ -15912,14 +15022,6 @@
 <file path=ppt/slides/slide3.xml><?xml version="1.0" encoding="utf-8"?>
 <p:sld xmlns:a="http://schemas.openxmlformats.org/drawingml/2006/main" xmlns:r="http://schemas.openxmlformats.org/officeDocument/2006/relationships" xmlns:p="http://schemas.openxmlformats.org/presentationml/2006/main">
   <p:cSld>
-    <p:bg>
-      <p:bgPr>
-        <a:solidFill>
-          <a:schemeClr val="bg2"/>
-        </a:solidFill>
-        <a:effectLst/>
-      </p:bgPr>
-    </p:bg>
     <p:spTree>
       <p:nvGrpSpPr>
         <p:cNvPr id="1" name=""/>
@@ -15936,10 +15038,56 @@
       </p:grpSpPr>
       <p:sp>
         <p:nvSpPr>
-          <p:cNvPr id="7" name="Title 6">
-            <a:extLst>
-              <a:ext uri="{FF2B5EF4-FFF2-40B4-BE49-F238E27FC236}">
-                <a16:creationId xmlns:a16="http://schemas.microsoft.com/office/drawing/2014/main" id="{0814B6A3-5F3E-4909-8ED5-87FE82492264}"/>
+          <p:cNvPr id="5" name="Rectangle 4">
+            <a:extLst>
+              <a:ext uri="{FF2B5EF4-FFF2-40B4-BE49-F238E27FC236}">
+                <a16:creationId xmlns:a16="http://schemas.microsoft.com/office/drawing/2014/main" id="{6F00FE34-3ED0-5F2C-A28A-7510FFD54241}"/>
+              </a:ext>
+            </a:extLst>
+          </p:cNvPr>
+          <p:cNvSpPr/>
+          <p:nvPr/>
+        </p:nvSpPr>
+        <p:spPr>
+          <a:xfrm>
+            <a:off x="6574537" y="383722"/>
+            <a:ext cx="4846320" cy="3955650"/>
+          </a:xfrm>
+          <a:prstGeom prst="rect">
+            <a:avLst/>
+          </a:prstGeom>
+        </p:spPr>
+        <p:style>
+          <a:lnRef idx="2">
+            <a:schemeClr val="accent1">
+              <a:shade val="15000"/>
+            </a:schemeClr>
+          </a:lnRef>
+          <a:fillRef idx="1">
+            <a:schemeClr val="accent1"/>
+          </a:fillRef>
+          <a:effectRef idx="0">
+            <a:schemeClr val="accent1"/>
+          </a:effectRef>
+          <a:fontRef idx="minor">
+            <a:schemeClr val="lt1"/>
+          </a:fontRef>
+        </p:style>
+        <p:txBody>
+          <a:bodyPr rtlCol="0" anchor="ctr"/>
+          <a:lstStyle/>
+          <a:p>
+            <a:pPr algn="ctr"/>
+            <a:endParaRPr lang="en-US"/>
+          </a:p>
+        </p:txBody>
+      </p:sp>
+      <p:sp>
+        <p:nvSpPr>
+          <p:cNvPr id="2" name="Title 1">
+            <a:extLst>
+              <a:ext uri="{FF2B5EF4-FFF2-40B4-BE49-F238E27FC236}">
+                <a16:creationId xmlns:a16="http://schemas.microsoft.com/office/drawing/2014/main" id="{E2D30E0F-10C6-298A-C347-E831FFF4ECB8}"/>
               </a:ext>
             </a:extLst>
           </p:cNvPr>
@@ -15947,56 +15095,181 @@
             <a:spLocks noGrp="1"/>
           </p:cNvSpPr>
           <p:nvPr>
-            <p:ph type="ctrTitle"/>
+            <p:ph type="title"/>
           </p:nvPr>
         </p:nvSpPr>
         <p:spPr/>
         <p:txBody>
-          <a:bodyPr vert="horz" lIns="109728" tIns="109728" rIns="109728" bIns="91440" rtlCol="0" anchor="ctr">
-            <a:normAutofit/>
+          <a:bodyPr/>
+          <a:lstStyle/>
+          <a:p>
+            <a:r>
+              <a:rPr lang="en-US" dirty="0"/>
+              <a:t>Introduction</a:t>
+            </a:r>
+          </a:p>
+        </p:txBody>
+      </p:sp>
+      <p:sp>
+        <p:nvSpPr>
+          <p:cNvPr id="3" name="Content Placeholder 2">
+            <a:extLst>
+              <a:ext uri="{FF2B5EF4-FFF2-40B4-BE49-F238E27FC236}">
+                <a16:creationId xmlns:a16="http://schemas.microsoft.com/office/drawing/2014/main" id="{41191CC7-9CF2-71F0-1AD4-791EA9CBAD97}"/>
+              </a:ext>
+            </a:extLst>
+          </p:cNvPr>
+          <p:cNvSpPr>
+            <a:spLocks noGrp="1"/>
+          </p:cNvSpPr>
+          <p:nvPr>
+            <p:ph sz="quarter" idx="18"/>
+          </p:nvPr>
+        </p:nvSpPr>
+        <p:spPr/>
+        <p:txBody>
+          <a:bodyPr>
+            <a:normAutofit fontScale="85000" lnSpcReduction="10000"/>
           </a:bodyPr>
           <a:lstStyle/>
           <a:p>
             <a:r>
               <a:rPr lang="en-US" dirty="0"/>
-              <a:t>The power of communication</a:t>
+              <a:t>In today’s data-driven real estate market, accurate property valuation models are essential for improving transparency and fairness in tax assessments. By developing a model that enhances Zillow’s existing valuation pipeline, we aim to benefit a broad range of stakeholders—including homeowners, investors, tax authorities, and real estate professionals—by improving the accuracy, interpretability, and fairness of automated property tax assessments.</a:t>
+            </a:r>
+          </a:p>
+        </p:txBody>
+      </p:sp>
+      <p:sp>
+        <p:nvSpPr>
+          <p:cNvPr id="4" name="Content Placeholder 3">
+            <a:extLst>
+              <a:ext uri="{FF2B5EF4-FFF2-40B4-BE49-F238E27FC236}">
+                <a16:creationId xmlns:a16="http://schemas.microsoft.com/office/drawing/2014/main" id="{4B1BF1AC-C624-2AD2-DA0F-335AB7BA2CA8}"/>
+              </a:ext>
+            </a:extLst>
+          </p:cNvPr>
+          <p:cNvSpPr>
+            <a:spLocks noGrp="1"/>
+          </p:cNvSpPr>
+          <p:nvPr>
+            <p:ph sz="quarter" idx="19"/>
+          </p:nvPr>
+        </p:nvSpPr>
+        <p:spPr>
+          <a:xfrm>
+            <a:off x="6966631" y="502269"/>
+            <a:ext cx="4454226" cy="3718557"/>
+          </a:xfrm>
+        </p:spPr>
+        <p:txBody>
+          <a:bodyPr>
+            <a:normAutofit fontScale="92500" lnSpcReduction="20000"/>
+          </a:bodyPr>
+          <a:lstStyle/>
+          <a:p>
+            <a:r>
+              <a:rPr lang="en-US" dirty="0"/>
+              <a:t>How do we accomplish this?</a:t>
+            </a:r>
+          </a:p>
+          <a:p>
+            <a:pPr marL="285750" indent="-285750">
+              <a:buFont typeface="Arial" panose="020B0604020202020204" pitchFamily="34" charset="0"/>
+              <a:buChar char="•"/>
+            </a:pPr>
+            <a:r>
+              <a:rPr lang="en-US" dirty="0"/>
+              <a:t>Robust data cleaning and reduction</a:t>
+            </a:r>
+          </a:p>
+          <a:p>
+            <a:pPr marL="285750" indent="-285750">
+              <a:buFont typeface="Arial" panose="020B0604020202020204" pitchFamily="34" charset="0"/>
+              <a:buChar char="•"/>
+            </a:pPr>
+            <a:r>
+              <a:rPr lang="en-US" dirty="0"/>
+              <a:t>Development of new features</a:t>
+            </a:r>
+          </a:p>
+          <a:p>
+            <a:r>
+              <a:rPr lang="en-US" dirty="0"/>
+              <a:t>How do we measure success?</a:t>
+            </a:r>
+          </a:p>
+          <a:p>
+            <a:pPr marL="285750" indent="-285750">
+              <a:buFont typeface="Arial" panose="020B0604020202020204" pitchFamily="34" charset="0"/>
+              <a:buChar char="•"/>
+            </a:pPr>
+            <a:r>
+              <a:rPr lang="en-US" dirty="0"/>
+              <a:t>RMSE, MAE, and R² on unseen data</a:t>
+            </a:r>
+          </a:p>
+          <a:p>
+            <a:pPr marL="285750" indent="-285750">
+              <a:buFont typeface="Arial" panose="020B0604020202020204" pitchFamily="34" charset="0"/>
+              <a:buChar char="•"/>
+            </a:pPr>
+            <a:r>
+              <a:rPr lang="en-US" dirty="0"/>
+              <a:t>Generalization power and interpretability</a:t>
             </a:r>
           </a:p>
         </p:txBody>
       </p:sp>
       <p:pic>
         <p:nvPicPr>
-          <p:cNvPr id="41" name="Picture Placeholder 40" descr="A large room with glass walls&#10;">
-            <a:extLst>
-              <a:ext uri="{FF2B5EF4-FFF2-40B4-BE49-F238E27FC236}">
-                <a16:creationId xmlns:a16="http://schemas.microsoft.com/office/drawing/2014/main" id="{9FB4A3D7-302B-4FAB-B9BD-5F75A796AC7C}"/>
+          <p:cNvPr id="1026" name="Picture 2" descr="Zillow.com - A Washington State Business Legend">
+            <a:extLst>
+              <a:ext uri="{FF2B5EF4-FFF2-40B4-BE49-F238E27FC236}">
+                <a16:creationId xmlns:a16="http://schemas.microsoft.com/office/drawing/2014/main" id="{169D5FFD-A230-2A7D-E3EF-A74CC7656A57}"/>
               </a:ext>
             </a:extLst>
           </p:cNvPr>
           <p:cNvPicPr>
-            <a:picLocks noGrp="1" noChangeAspect="1"/>
+            <a:picLocks noChangeAspect="1" noChangeArrowheads="1"/>
           </p:cNvPicPr>
-          <p:nvPr>
-            <p:ph type="pic" sz="quarter" idx="13"/>
-          </p:nvPr>
+          <p:nvPr/>
         </p:nvPicPr>
         <p:blipFill rotWithShape="1">
-          <a:blip r:embed="rId3" cstate="screen">
+          <a:blip r:embed="rId3">
             <a:extLst>
               <a:ext uri="{28A0092B-C50C-407E-A947-70E740481C1C}">
-                <a14:useLocalDpi xmlns:a14="http://schemas.microsoft.com/office/drawing/2010/main"/>
+                <a14:useLocalDpi xmlns:a14="http://schemas.microsoft.com/office/drawing/2010/main" val="0"/>
               </a:ext>
             </a:extLst>
           </a:blip>
-          <a:srcRect l="7980" r="7980"/>
+          <a:srcRect t="17336" b="11988"/>
           <a:stretch/>
         </p:blipFill>
-        <p:spPr/>
+        <p:spPr bwMode="auto">
+          <a:xfrm>
+            <a:off x="7515446" y="4905756"/>
+            <a:ext cx="3356595" cy="969264"/>
+          </a:xfrm>
+          <a:prstGeom prst="rect">
+            <a:avLst/>
+          </a:prstGeom>
+          <a:noFill/>
+          <a:extLst>
+            <a:ext uri="{909E8E84-426E-40DD-AFC4-6F175D3DCCD1}">
+              <a14:hiddenFill xmlns:a14="http://schemas.microsoft.com/office/drawing/2010/main">
+                <a:solidFill>
+                  <a:srgbClr val="FFFFFF"/>
+                </a:solidFill>
+              </a14:hiddenFill>
+            </a:ext>
+          </a:extLst>
+        </p:spPr>
       </p:pic>
     </p:spTree>
     <p:extLst>
       <p:ext uri="{BB962C8B-B14F-4D97-AF65-F5344CB8AC3E}">
-        <p14:creationId xmlns:p14="http://schemas.microsoft.com/office/powerpoint/2010/main" val="2916022834"/>
+        <p14:creationId xmlns:p14="http://schemas.microsoft.com/office/powerpoint/2010/main" val="1230700268"/>
       </p:ext>
     </p:extLst>
   </p:cSld>
@@ -16025,10 +15298,10 @@
       </p:grpSpPr>
       <p:sp>
         <p:nvSpPr>
-          <p:cNvPr id="14" name="Title 13">
-            <a:extLst>
-              <a:ext uri="{FF2B5EF4-FFF2-40B4-BE49-F238E27FC236}">
-                <a16:creationId xmlns:a16="http://schemas.microsoft.com/office/drawing/2014/main" id="{331CEB84-49DC-40A9-B2F0-D573658AE999}"/>
+          <p:cNvPr id="2" name="Title 1">
+            <a:extLst>
+              <a:ext uri="{FF2B5EF4-FFF2-40B4-BE49-F238E27FC236}">
+                <a16:creationId xmlns:a16="http://schemas.microsoft.com/office/drawing/2014/main" id="{7FAB65A9-1ACB-EE49-7672-A927F8F3463B}"/>
               </a:ext>
             </a:extLst>
           </p:cNvPr>
@@ -16039,24 +15312,29 @@
             <p:ph type="title"/>
           </p:nvPr>
         </p:nvSpPr>
-        <p:spPr/>
+        <p:spPr>
+          <a:xfrm>
+            <a:off x="139255" y="272583"/>
+            <a:ext cx="4323018" cy="865542"/>
+          </a:xfrm>
+        </p:spPr>
         <p:txBody>
           <a:bodyPr/>
           <a:lstStyle/>
           <a:p>
             <a:r>
               <a:rPr lang="en-US" dirty="0"/>
-              <a:t>Overcoming nervousness</a:t>
-            </a:r>
-          </a:p>
-        </p:txBody>
-      </p:sp>
-      <p:sp>
-        <p:nvSpPr>
-          <p:cNvPr id="15" name="Subtitle 14">
-            <a:extLst>
-              <a:ext uri="{FF2B5EF4-FFF2-40B4-BE49-F238E27FC236}">
-                <a16:creationId xmlns:a16="http://schemas.microsoft.com/office/drawing/2014/main" id="{B7886DF7-FA3D-4AD1-AEC1-578EA3AC8C7D}"/>
+              <a:t>The Data</a:t>
+            </a:r>
+          </a:p>
+        </p:txBody>
+      </p:sp>
+      <p:sp>
+        <p:nvSpPr>
+          <p:cNvPr id="6" name="Content Placeholder 5">
+            <a:extLst>
+              <a:ext uri="{FF2B5EF4-FFF2-40B4-BE49-F238E27FC236}">
+                <a16:creationId xmlns:a16="http://schemas.microsoft.com/office/drawing/2014/main" id="{2BBAABBD-8A7F-A90C-3E5F-9B47E6255AA6}"/>
               </a:ext>
             </a:extLst>
           </p:cNvPr>
@@ -16064,189 +15342,496 @@
             <a:spLocks noGrp="1"/>
           </p:cNvSpPr>
           <p:nvPr>
-            <p:ph type="subTitle" idx="1"/>
-          </p:nvPr>
-        </p:nvSpPr>
-        <p:spPr/>
-        <p:txBody>
-          <a:bodyPr/>
-          <a:lstStyle/>
-          <a:p>
+            <p:ph sz="quarter" idx="15"/>
+          </p:nvPr>
+        </p:nvSpPr>
+        <p:spPr>
+          <a:xfrm>
+            <a:off x="138649" y="1138125"/>
+            <a:ext cx="4323624" cy="5447292"/>
+          </a:xfrm>
+        </p:spPr>
+        <p:txBody>
+          <a:bodyPr>
+            <a:normAutofit fontScale="77500" lnSpcReduction="20000"/>
+          </a:bodyPr>
+          <a:lstStyle/>
+          <a:p>
+            <a:r>
+              <a:rPr lang="en-US" b="1" dirty="0"/>
+              <a:t>The 2016 Zillow Property Dataset:</a:t>
+            </a:r>
+          </a:p>
+          <a:p>
+            <a:pPr marL="285750" indent="-285750">
+              <a:buFont typeface="Arial" panose="020B0604020202020204" pitchFamily="34" charset="0"/>
+              <a:buChar char="•"/>
+            </a:pPr>
             <a:r>
               <a:rPr lang="en-US" dirty="0"/>
-              <a:t>Confidence-building strategies</a:t>
+              <a:t>3 million property records </a:t>
+            </a:r>
+          </a:p>
+          <a:p>
+            <a:pPr marL="285750" indent="-285750">
+              <a:buFont typeface="Arial" panose="020B0604020202020204" pitchFamily="34" charset="0"/>
+              <a:buChar char="•"/>
+            </a:pPr>
+            <a:r>
+              <a:rPr lang="en-US" dirty="0"/>
+              <a:t>Various U.S. regions</a:t>
+            </a:r>
+          </a:p>
+          <a:p>
+            <a:pPr marL="285750" indent="-285750">
+              <a:buFont typeface="Arial" panose="020B0604020202020204" pitchFamily="34" charset="0"/>
+              <a:buChar char="•"/>
+            </a:pPr>
+            <a:r>
+              <a:rPr lang="en-US" dirty="0"/>
+              <a:t>home characteristics, geographic identifiers, and administrative data.</a:t>
+            </a:r>
+          </a:p>
+          <a:p>
+            <a:r>
+              <a:rPr lang="en-US" b="1" dirty="0"/>
+              <a:t>Key characteristics:</a:t>
+            </a:r>
+          </a:p>
+          <a:p>
+            <a:pPr marL="285750" indent="-285750">
+              <a:buFont typeface="Arial" panose="020B0604020202020204" pitchFamily="34" charset="0"/>
+              <a:buChar char="•"/>
+            </a:pPr>
+            <a:r>
+              <a:rPr lang="en-US" dirty="0"/>
+              <a:t>Size: ~3 million rows before filtering; reduced to ~250,000 after cleaning</a:t>
+            </a:r>
+          </a:p>
+          <a:p>
+            <a:pPr marL="285750" indent="-285750">
+              <a:buFont typeface="Arial" panose="020B0604020202020204" pitchFamily="34" charset="0"/>
+              <a:buChar char="•"/>
+            </a:pPr>
+            <a:r>
+              <a:rPr lang="en-US" dirty="0"/>
+              <a:t>Target Variable: </a:t>
+            </a:r>
+            <a:r>
+              <a:rPr lang="en-US" dirty="0" err="1"/>
+              <a:t>taxvaluedollarcnt</a:t>
+            </a:r>
+            <a:r>
+              <a:rPr lang="en-US" dirty="0"/>
+              <a:t> — the Zillow-assessed property tax value</a:t>
+            </a:r>
+          </a:p>
+          <a:p>
+            <a:pPr marL="285750" indent="-285750">
+              <a:buFont typeface="Arial" panose="020B0604020202020204" pitchFamily="34" charset="0"/>
+              <a:buChar char="•"/>
+            </a:pPr>
+            <a:r>
+              <a:rPr lang="en-US" dirty="0"/>
+              <a:t>Feature Types: Numerical categorical and string-based</a:t>
+            </a:r>
+          </a:p>
+          <a:p>
+            <a:pPr marL="285750" indent="-285750">
+              <a:buFont typeface="Arial" panose="020B0604020202020204" pitchFamily="34" charset="0"/>
+              <a:buChar char="•"/>
+            </a:pPr>
+            <a:r>
+              <a:rPr lang="en-US" dirty="0"/>
+              <a:t>Missing Values: Some &gt;80%, so we applied strict thresholds to retain only well-populated features.</a:t>
+            </a:r>
+          </a:p>
+          <a:p>
+            <a:pPr marL="285750" indent="-285750">
+              <a:buFont typeface="Arial" panose="020B0604020202020204" pitchFamily="34" charset="0"/>
+              <a:buChar char="•"/>
+            </a:pPr>
+            <a:r>
+              <a:rPr lang="en-US" dirty="0"/>
+              <a:t>Redundancy: Location-based features were streamlined to avoid duplication.</a:t>
             </a:r>
           </a:p>
         </p:txBody>
       </p:sp>
       <p:pic>
         <p:nvPicPr>
-          <p:cNvPr id="5" name="Picture Placeholder 4" descr="People in the middle of a circular room ">
-            <a:extLst>
-              <a:ext uri="{FF2B5EF4-FFF2-40B4-BE49-F238E27FC236}">
-                <a16:creationId xmlns:a16="http://schemas.microsoft.com/office/drawing/2014/main" id="{0CEB905B-7FDD-4B1A-96BF-B5A081A25FC8}"/>
+          <p:cNvPr id="10" name="Picture 9">
+            <a:extLst>
+              <a:ext uri="{FF2B5EF4-FFF2-40B4-BE49-F238E27FC236}">
+                <a16:creationId xmlns:a16="http://schemas.microsoft.com/office/drawing/2014/main" id="{6106D49D-AA8E-2856-7690-633399B6964A}"/>
               </a:ext>
             </a:extLst>
           </p:cNvPr>
           <p:cNvPicPr>
-            <a:picLocks noGrp="1" noChangeAspect="1"/>
+            <a:picLocks noChangeAspect="1"/>
           </p:cNvPicPr>
-          <p:nvPr>
-            <p:ph type="pic" sz="quarter" idx="13"/>
-          </p:nvPr>
+          <p:nvPr/>
         </p:nvPicPr>
-        <p:blipFill rotWithShape="1">
-          <a:blip r:embed="rId3" cstate="screen">
-            <a:extLst>
-              <a:ext uri="{28A0092B-C50C-407E-A947-70E740481C1C}">
-                <a14:useLocalDpi xmlns:a14="http://schemas.microsoft.com/office/drawing/2010/main"/>
-              </a:ext>
-            </a:extLst>
-          </a:blip>
-          <a:srcRect l="7618" r="7618"/>
-          <a:stretch/>
+        <p:blipFill>
+          <a:blip r:embed="rId3"/>
+          <a:stretch>
+            <a:fillRect/>
+          </a:stretch>
         </p:blipFill>
-        <p:spPr/>
+        <p:spPr>
+          <a:xfrm>
+            <a:off x="5010912" y="272583"/>
+            <a:ext cx="6897624" cy="865542"/>
+          </a:xfrm>
+          <a:prstGeom prst="rect">
+            <a:avLst/>
+          </a:prstGeom>
+        </p:spPr>
       </p:pic>
-    </p:spTree>
-    <p:extLst>
-      <p:ext uri="{BB962C8B-B14F-4D97-AF65-F5344CB8AC3E}">
-        <p14:creationId xmlns:p14="http://schemas.microsoft.com/office/powerpoint/2010/main" val="2779792646"/>
-      </p:ext>
-    </p:extLst>
-  </p:cSld>
-  <p:clrMapOvr>
-    <a:masterClrMapping/>
-  </p:clrMapOvr>
-</p:sld>
-</file>
-
-<file path=ppt/slides/slide5.xml><?xml version="1.0" encoding="utf-8"?>
-<p:sld xmlns:a="http://schemas.openxmlformats.org/drawingml/2006/main" xmlns:r="http://schemas.openxmlformats.org/officeDocument/2006/relationships" xmlns:p="http://schemas.openxmlformats.org/presentationml/2006/main">
-  <p:cSld>
-    <p:spTree>
-      <p:nvGrpSpPr>
-        <p:cNvPr id="1" name=""/>
-        <p:cNvGrpSpPr/>
-        <p:nvPr/>
-      </p:nvGrpSpPr>
-      <p:grpSpPr>
-        <a:xfrm>
-          <a:off x="0" y="0"/>
-          <a:ext cx="0" cy="0"/>
-          <a:chOff x="0" y="0"/>
-          <a:chExt cx="0" cy="0"/>
-        </a:xfrm>
-      </p:grpSpPr>
-      <p:sp>
-        <p:nvSpPr>
-          <p:cNvPr id="2" name="Title 1">
-            <a:extLst>
-              <a:ext uri="{FF2B5EF4-FFF2-40B4-BE49-F238E27FC236}">
-                <a16:creationId xmlns:a16="http://schemas.microsoft.com/office/drawing/2014/main" id="{7FAB65A9-1ACB-EE49-7672-A927F8F3463B}"/>
-              </a:ext>
-            </a:extLst>
-          </p:cNvPr>
-          <p:cNvSpPr>
-            <a:spLocks noGrp="1"/>
-          </p:cNvSpPr>
-          <p:nvPr>
-            <p:ph type="title"/>
-          </p:nvPr>
-        </p:nvSpPr>
-        <p:spPr/>
-        <p:txBody>
-          <a:bodyPr/>
-          <a:lstStyle/>
-          <a:p>
-            <a:r>
-              <a:rPr lang="en-US" dirty="0"/>
-              <a:t>Engaging the audience</a:t>
-            </a:r>
-          </a:p>
-        </p:txBody>
-      </p:sp>
       <p:pic>
         <p:nvPicPr>
-          <p:cNvPr id="9" name="Content Placeholder 8" descr="Person alone in an office">
-            <a:extLst>
-              <a:ext uri="{FF2B5EF4-FFF2-40B4-BE49-F238E27FC236}">
-                <a16:creationId xmlns:a16="http://schemas.microsoft.com/office/drawing/2014/main" id="{2C6BF86C-38BB-3B7E-9F36-9166C538BD1D}"/>
+          <p:cNvPr id="12" name="Picture 11">
+            <a:extLst>
+              <a:ext uri="{FF2B5EF4-FFF2-40B4-BE49-F238E27FC236}">
+                <a16:creationId xmlns:a16="http://schemas.microsoft.com/office/drawing/2014/main" id="{45306F03-860A-F0FA-191F-D45C456C0573}"/>
               </a:ext>
             </a:extLst>
           </p:cNvPr>
           <p:cNvPicPr>
-            <a:picLocks noGrp="1" noChangeAspect="1"/>
+            <a:picLocks noChangeAspect="1"/>
           </p:cNvPicPr>
-          <p:nvPr>
-            <p:ph sz="quarter" idx="16"/>
-          </p:nvPr>
+          <p:nvPr/>
         </p:nvPicPr>
         <p:blipFill>
-          <a:blip r:embed="rId3" cstate="screen">
-            <a:extLst>
-              <a:ext uri="{28A0092B-C50C-407E-A947-70E740481C1C}">
-                <a14:useLocalDpi xmlns:a14="http://schemas.microsoft.com/office/drawing/2010/main"/>
-              </a:ext>
-            </a:extLst>
-          </a:blip>
-          <a:stretch/>
+          <a:blip r:embed="rId4"/>
+          <a:stretch>
+            <a:fillRect/>
+          </a:stretch>
         </p:blipFill>
         <p:spPr>
           <a:xfrm>
-            <a:off x="0" y="1038"/>
-            <a:ext cx="4613275" cy="6855923"/>
-          </a:xfrm>
+            <a:off x="5010912" y="1408284"/>
+            <a:ext cx="3392424" cy="5177133"/>
+          </a:xfrm>
+          <a:prstGeom prst="rect">
+            <a:avLst/>
+          </a:prstGeom>
         </p:spPr>
       </p:pic>
       <p:sp>
         <p:nvSpPr>
-          <p:cNvPr id="6" name="Content Placeholder 5">
-            <a:extLst>
-              <a:ext uri="{FF2B5EF4-FFF2-40B4-BE49-F238E27FC236}">
-                <a16:creationId xmlns:a16="http://schemas.microsoft.com/office/drawing/2014/main" id="{2BBAABBD-8A7F-A90C-3E5F-9B47E6255AA6}"/>
-              </a:ext>
-            </a:extLst>
-          </p:cNvPr>
-          <p:cNvSpPr>
-            <a:spLocks noGrp="1"/>
-          </p:cNvSpPr>
-          <p:nvPr>
-            <p:ph sz="quarter" idx="15"/>
-          </p:nvPr>
-        </p:nvSpPr>
-        <p:spPr/>
-        <p:txBody>
-          <a:bodyPr>
-            <a:normAutofit/>
+          <p:cNvPr id="13" name="Rectangle 12">
+            <a:extLst>
+              <a:ext uri="{FF2B5EF4-FFF2-40B4-BE49-F238E27FC236}">
+                <a16:creationId xmlns:a16="http://schemas.microsoft.com/office/drawing/2014/main" id="{9991A42D-4D98-E4A7-20F5-A4D88B68EC04}"/>
+              </a:ext>
+            </a:extLst>
+          </p:cNvPr>
+          <p:cNvSpPr/>
+          <p:nvPr/>
+        </p:nvSpPr>
+        <p:spPr>
+          <a:xfrm>
+            <a:off x="8732520" y="2030076"/>
+            <a:ext cx="3176016" cy="4003638"/>
+          </a:xfrm>
+          <a:prstGeom prst="rect">
+            <a:avLst/>
+          </a:prstGeom>
+        </p:spPr>
+        <p:style>
+          <a:lnRef idx="2">
+            <a:schemeClr val="accent1">
+              <a:shade val="15000"/>
+            </a:schemeClr>
+          </a:lnRef>
+          <a:fillRef idx="1">
+            <a:schemeClr val="accent1"/>
+          </a:fillRef>
+          <a:effectRef idx="0">
+            <a:schemeClr val="accent1"/>
+          </a:effectRef>
+          <a:fontRef idx="minor">
+            <a:schemeClr val="lt1"/>
+          </a:fontRef>
+        </p:style>
+        <p:txBody>
+          <a:bodyPr rtlCol="0" anchor="ctr"/>
+          <a:lstStyle/>
+          <a:p>
+            <a:pPr algn="ctr"/>
+            <a:endParaRPr lang="en-US"/>
+          </a:p>
+        </p:txBody>
+      </p:sp>
+      <p:sp>
+        <p:nvSpPr>
+          <p:cNvPr id="14" name="Content Placeholder 5">
+            <a:extLst>
+              <a:ext uri="{FF2B5EF4-FFF2-40B4-BE49-F238E27FC236}">
+                <a16:creationId xmlns:a16="http://schemas.microsoft.com/office/drawing/2014/main" id="{E6DCF376-95A2-F392-718D-A412EB143406}"/>
+              </a:ext>
+            </a:extLst>
+          </p:cNvPr>
+          <p:cNvSpPr txBox="1">
+            <a:spLocks/>
+          </p:cNvSpPr>
+          <p:nvPr/>
+        </p:nvSpPr>
+        <p:spPr>
+          <a:xfrm>
+            <a:off x="8732520" y="2103120"/>
+            <a:ext cx="3176016" cy="356616"/>
+          </a:xfrm>
+          <a:prstGeom prst="rect">
+            <a:avLst/>
+          </a:prstGeom>
+        </p:spPr>
+        <p:txBody>
+          <a:bodyPr vert="horz" lIns="109728" tIns="109728" rIns="109728" bIns="91440" rtlCol="0" anchor="t">
+            <a:normAutofit fontScale="62500" lnSpcReduction="20000"/>
           </a:bodyPr>
-          <a:lstStyle/>
-          <a:p>
-            <a:r>
-              <a:rPr lang="en-US" dirty="0"/>
-              <a:t>Make eye contact with your audience to create a sense of intimacy and involvement</a:t>
-            </a:r>
-          </a:p>
-          <a:p>
-            <a:r>
-              <a:rPr lang="en-US" dirty="0"/>
-              <a:t>Weave relatable stories into your presentation using narratives that make your message memorable and impactful</a:t>
-            </a:r>
-          </a:p>
-          <a:p>
-            <a:r>
-              <a:rPr lang="en-US" dirty="0"/>
-              <a:t>Encourage questions and provide thoughtful responses to enhance audience participation</a:t>
-            </a:r>
-          </a:p>
-          <a:p>
-            <a:r>
-              <a:rPr lang="en-US" dirty="0"/>
-              <a:t>Use live polls or surveys to gather audience opinions, promoting engagement and making sure the audience feel involved</a:t>
-            </a:r>
-          </a:p>
-        </p:txBody>
-      </p:sp>
+          <a:lstStyle>
+            <a:lvl1pPr marL="0" indent="0" algn="l" defTabSz="914400" rtl="0" eaLnBrk="1" latinLnBrk="0" hangingPunct="1">
+              <a:lnSpc>
+                <a:spcPct val="100000"/>
+              </a:lnSpc>
+              <a:spcBef>
+                <a:spcPts val="930"/>
+              </a:spcBef>
+              <a:spcAft>
+                <a:spcPts val="600"/>
+              </a:spcAft>
+              <a:buFont typeface="Corbel" panose="020B0503020204020204" pitchFamily="34" charset="0"/>
+              <a:buNone/>
+              <a:defRPr sz="1800" b="0" kern="1200" spc="150" baseline="0">
+                <a:solidFill>
+                  <a:schemeClr val="tx1">
+                    <a:lumMod val="75000"/>
+                    <a:lumOff val="25000"/>
+                  </a:schemeClr>
+                </a:solidFill>
+                <a:latin typeface="+mn-lt"/>
+                <a:ea typeface="+mn-ea"/>
+                <a:cs typeface="+mn-cs"/>
+              </a:defRPr>
+            </a:lvl1pPr>
+            <a:lvl2pPr marL="0" indent="0" algn="l" defTabSz="914400" rtl="0" eaLnBrk="1" latinLnBrk="0" hangingPunct="1">
+              <a:lnSpc>
+                <a:spcPct val="100000"/>
+              </a:lnSpc>
+              <a:spcBef>
+                <a:spcPts val="930"/>
+              </a:spcBef>
+              <a:spcAft>
+                <a:spcPts val="600"/>
+              </a:spcAft>
+              <a:buFont typeface="Corbel" panose="020B0503020204020204" pitchFamily="34" charset="0"/>
+              <a:buNone/>
+              <a:defRPr sz="1800" kern="1200" spc="150" baseline="0">
+                <a:solidFill>
+                  <a:schemeClr val="tx1">
+                    <a:lumMod val="75000"/>
+                    <a:lumOff val="25000"/>
+                  </a:schemeClr>
+                </a:solidFill>
+                <a:latin typeface="+mn-lt"/>
+                <a:ea typeface="+mn-ea"/>
+                <a:cs typeface="+mn-cs"/>
+              </a:defRPr>
+            </a:lvl2pPr>
+            <a:lvl3pPr marL="0" indent="-320040" algn="l" defTabSz="914400" rtl="0" eaLnBrk="1" latinLnBrk="0" hangingPunct="1">
+              <a:lnSpc>
+                <a:spcPct val="100000"/>
+              </a:lnSpc>
+              <a:spcBef>
+                <a:spcPts val="930"/>
+              </a:spcBef>
+              <a:spcAft>
+                <a:spcPts val="600"/>
+              </a:spcAft>
+              <a:buFont typeface="Corbel" panose="020B0503020204020204" pitchFamily="34" charset="0"/>
+              <a:buChar char="–"/>
+              <a:defRPr sz="1800" i="1" kern="1200" spc="150" baseline="0">
+                <a:solidFill>
+                  <a:schemeClr val="tx1">
+                    <a:lumMod val="75000"/>
+                    <a:lumOff val="25000"/>
+                  </a:schemeClr>
+                </a:solidFill>
+                <a:latin typeface="+mn-lt"/>
+                <a:ea typeface="+mn-ea"/>
+                <a:cs typeface="+mn-cs"/>
+              </a:defRPr>
+            </a:lvl3pPr>
+            <a:lvl4pPr marL="0" indent="-320040" algn="l" defTabSz="914400" rtl="0" eaLnBrk="1" latinLnBrk="0" hangingPunct="1">
+              <a:lnSpc>
+                <a:spcPct val="100000"/>
+              </a:lnSpc>
+              <a:spcBef>
+                <a:spcPts val="930"/>
+              </a:spcBef>
+              <a:spcAft>
+                <a:spcPts val="600"/>
+              </a:spcAft>
+              <a:buFont typeface="Corbel" panose="020B0503020204020204" pitchFamily="34" charset="0"/>
+              <a:buChar char="–"/>
+              <a:defRPr sz="1800" kern="1200" spc="150" baseline="0">
+                <a:solidFill>
+                  <a:schemeClr val="tx1">
+                    <a:lumMod val="75000"/>
+                    <a:lumOff val="25000"/>
+                  </a:schemeClr>
+                </a:solidFill>
+                <a:latin typeface="+mn-lt"/>
+                <a:ea typeface="+mn-ea"/>
+                <a:cs typeface="+mn-cs"/>
+              </a:defRPr>
+            </a:lvl4pPr>
+            <a:lvl5pPr marL="0" indent="-320040" algn="l" defTabSz="914400" rtl="0" eaLnBrk="1" latinLnBrk="0" hangingPunct="1">
+              <a:lnSpc>
+                <a:spcPct val="100000"/>
+              </a:lnSpc>
+              <a:spcBef>
+                <a:spcPts val="930"/>
+              </a:spcBef>
+              <a:spcAft>
+                <a:spcPts val="600"/>
+              </a:spcAft>
+              <a:buFont typeface="Corbel" panose="020B0503020204020204" pitchFamily="34" charset="0"/>
+              <a:buChar char="–"/>
+              <a:defRPr sz="1800" i="1" kern="1200" spc="150" baseline="0">
+                <a:solidFill>
+                  <a:schemeClr val="tx1">
+                    <a:lumMod val="75000"/>
+                    <a:lumOff val="25000"/>
+                  </a:schemeClr>
+                </a:solidFill>
+                <a:latin typeface="+mn-lt"/>
+                <a:ea typeface="+mn-ea"/>
+                <a:cs typeface="+mn-cs"/>
+              </a:defRPr>
+            </a:lvl5pPr>
+            <a:lvl6pPr marL="1920240" indent="-320040" algn="l" defTabSz="914400" rtl="0" eaLnBrk="1" latinLnBrk="0" hangingPunct="1">
+              <a:lnSpc>
+                <a:spcPct val="111000"/>
+              </a:lnSpc>
+              <a:spcBef>
+                <a:spcPts val="930"/>
+              </a:spcBef>
+              <a:buFont typeface="Corbel" panose="020B0503020204020204" pitchFamily="34" charset="0"/>
+              <a:buChar char="–"/>
+              <a:defRPr sz="1400" kern="1200">
+                <a:solidFill>
+                  <a:schemeClr val="accent1">
+                    <a:lumMod val="75000"/>
+                  </a:schemeClr>
+                </a:solidFill>
+                <a:latin typeface="+mn-lt"/>
+                <a:ea typeface="+mn-ea"/>
+                <a:cs typeface="+mn-cs"/>
+              </a:defRPr>
+            </a:lvl6pPr>
+            <a:lvl7pPr marL="2240280" indent="-320040" algn="l" defTabSz="914400" rtl="0" eaLnBrk="1" latinLnBrk="0" hangingPunct="1">
+              <a:lnSpc>
+                <a:spcPct val="111000"/>
+              </a:lnSpc>
+              <a:spcBef>
+                <a:spcPts val="930"/>
+              </a:spcBef>
+              <a:buFont typeface="Corbel" panose="020B0503020204020204" pitchFamily="34" charset="0"/>
+              <a:buChar char="–"/>
+              <a:defRPr sz="1400" i="1" kern="1200">
+                <a:solidFill>
+                  <a:schemeClr val="accent1">
+                    <a:lumMod val="75000"/>
+                  </a:schemeClr>
+                </a:solidFill>
+                <a:latin typeface="+mn-lt"/>
+                <a:ea typeface="+mn-ea"/>
+                <a:cs typeface="+mn-cs"/>
+              </a:defRPr>
+            </a:lvl7pPr>
+            <a:lvl8pPr marL="2560320" indent="-320040" algn="l" defTabSz="914400" rtl="0" eaLnBrk="1" latinLnBrk="0" hangingPunct="1">
+              <a:lnSpc>
+                <a:spcPct val="111000"/>
+              </a:lnSpc>
+              <a:spcBef>
+                <a:spcPts val="930"/>
+              </a:spcBef>
+              <a:buFont typeface="Corbel" panose="020B0503020204020204" pitchFamily="34" charset="0"/>
+              <a:buChar char="–"/>
+              <a:defRPr sz="1400" kern="1200">
+                <a:solidFill>
+                  <a:schemeClr val="accent1">
+                    <a:lumMod val="75000"/>
+                  </a:schemeClr>
+                </a:solidFill>
+                <a:latin typeface="+mn-lt"/>
+                <a:ea typeface="+mn-ea"/>
+                <a:cs typeface="+mn-cs"/>
+              </a:defRPr>
+            </a:lvl8pPr>
+            <a:lvl9pPr marL="2880360" indent="-320040" algn="l" defTabSz="914400" rtl="0" eaLnBrk="1" latinLnBrk="0" hangingPunct="1">
+              <a:lnSpc>
+                <a:spcPct val="111000"/>
+              </a:lnSpc>
+              <a:spcBef>
+                <a:spcPts val="930"/>
+              </a:spcBef>
+              <a:buFont typeface="Corbel" panose="020B0503020204020204" pitchFamily="34" charset="0"/>
+              <a:buChar char="–"/>
+              <a:defRPr sz="1400" i="1" kern="1200">
+                <a:solidFill>
+                  <a:schemeClr val="accent1">
+                    <a:lumMod val="75000"/>
+                  </a:schemeClr>
+                </a:solidFill>
+                <a:latin typeface="+mn-lt"/>
+                <a:ea typeface="+mn-ea"/>
+                <a:cs typeface="+mn-cs"/>
+              </a:defRPr>
+            </a:lvl9pPr>
+          </a:lstStyle>
+          <a:p>
+            <a:r>
+              <a:rPr lang="en-US" b="1" dirty="0"/>
+              <a:t>After Cleaning and Engineering</a:t>
+            </a:r>
+            <a:endParaRPr lang="en-US" dirty="0"/>
+          </a:p>
+        </p:txBody>
+      </p:sp>
+      <p:pic>
+        <p:nvPicPr>
+          <p:cNvPr id="18" name="Picture 17">
+            <a:extLst>
+              <a:ext uri="{FF2B5EF4-FFF2-40B4-BE49-F238E27FC236}">
+                <a16:creationId xmlns:a16="http://schemas.microsoft.com/office/drawing/2014/main" id="{EB75C701-5234-13C5-92BF-83BCD526B8CB}"/>
+              </a:ext>
+            </a:extLst>
+          </p:cNvPr>
+          <p:cNvPicPr>
+            <a:picLocks noChangeAspect="1"/>
+          </p:cNvPicPr>
+          <p:nvPr/>
+        </p:nvPicPr>
+        <p:blipFill>
+          <a:blip r:embed="rId5"/>
+          <a:stretch>
+            <a:fillRect/>
+          </a:stretch>
+        </p:blipFill>
+        <p:spPr>
+          <a:xfrm>
+            <a:off x="8782629" y="2459736"/>
+            <a:ext cx="3075798" cy="3474513"/>
+          </a:xfrm>
+          <a:prstGeom prst="rect">
+            <a:avLst/>
+          </a:prstGeom>
+        </p:spPr>
+      </p:pic>
     </p:spTree>
     <p:extLst>
       <p:ext uri="{BB962C8B-B14F-4D97-AF65-F5344CB8AC3E}">
@@ -16260,7 +15845,7 @@
 </p:sld>
 </file>
 
-<file path=ppt/slides/slide6.xml><?xml version="1.0" encoding="utf-8"?>
+<file path=ppt/slides/slide5.xml><?xml version="1.0" encoding="utf-8"?>
 <p:sld xmlns:a="http://schemas.openxmlformats.org/drawingml/2006/main" xmlns:r="http://schemas.openxmlformats.org/officeDocument/2006/relationships" xmlns:p="http://schemas.openxmlformats.org/presentationml/2006/main">
   <p:cSld>
     <p:bg>
@@ -16303,50 +15888,171 @@
         </p:nvSpPr>
         <p:spPr/>
         <p:txBody>
-          <a:bodyPr vert="horz" lIns="109728" tIns="109728" rIns="109728" bIns="91440" rtlCol="0" anchor="b">
+          <a:bodyPr vert="horz" lIns="109728" tIns="109728" rIns="109728" bIns="91440" rtlCol="0" anchor="ctr">
             <a:normAutofit/>
           </a:bodyPr>
           <a:lstStyle/>
           <a:p>
             <a:r>
               <a:rPr lang="en-US" dirty="0"/>
-              <a:t>Selecting visual aids</a:t>
-            </a:r>
-          </a:p>
-        </p:txBody>
-      </p:sp>
-      <p:sp>
-        <p:nvSpPr>
-          <p:cNvPr id="6" name="Text Placeholder 5">
-            <a:extLst>
-              <a:ext uri="{FF2B5EF4-FFF2-40B4-BE49-F238E27FC236}">
-                <a16:creationId xmlns:a16="http://schemas.microsoft.com/office/drawing/2014/main" id="{7C94F61A-46C1-B831-7EC4-687DF1C757C5}"/>
-              </a:ext>
-            </a:extLst>
-          </p:cNvPr>
-          <p:cNvSpPr>
-            <a:spLocks noGrp="1"/>
-          </p:cNvSpPr>
-          <p:nvPr>
-            <p:ph type="body" sz="quarter" idx="10"/>
-          </p:nvPr>
-        </p:nvSpPr>
+              <a:t>Methodology</a:t>
+            </a:r>
+          </a:p>
+        </p:txBody>
+      </p:sp>
+      <p:pic>
+        <p:nvPicPr>
+          <p:cNvPr id="41" name="Picture Placeholder 40" descr="A large room with glass walls&#10;">
+            <a:extLst>
+              <a:ext uri="{FF2B5EF4-FFF2-40B4-BE49-F238E27FC236}">
+                <a16:creationId xmlns:a16="http://schemas.microsoft.com/office/drawing/2014/main" id="{9FB4A3D7-302B-4FAB-B9BD-5F75A796AC7C}"/>
+              </a:ext>
+            </a:extLst>
+          </p:cNvPr>
+          <p:cNvPicPr>
+            <a:picLocks noGrp="1" noChangeAspect="1"/>
+          </p:cNvPicPr>
+          <p:nvPr>
+            <p:ph type="pic" sz="quarter" idx="13"/>
+          </p:nvPr>
+        </p:nvPicPr>
+        <p:blipFill rotWithShape="1">
+          <a:blip r:embed="rId3" cstate="screen">
+            <a:extLst>
+              <a:ext uri="{28A0092B-C50C-407E-A947-70E740481C1C}">
+                <a14:useLocalDpi xmlns:a14="http://schemas.microsoft.com/office/drawing/2010/main"/>
+              </a:ext>
+            </a:extLst>
+          </a:blip>
+          <a:srcRect l="7980" r="7980"/>
+          <a:stretch/>
+        </p:blipFill>
         <p:spPr/>
-        <p:txBody>
-          <a:bodyPr/>
-          <a:lstStyle/>
-          <a:p>
-            <a:r>
-              <a:rPr lang="en-US" dirty="0"/>
-              <a:t>Enhancing your presentation</a:t>
-            </a:r>
-          </a:p>
-        </p:txBody>
-      </p:sp>
+      </p:pic>
     </p:spTree>
     <p:extLst>
       <p:ext uri="{BB962C8B-B14F-4D97-AF65-F5344CB8AC3E}">
-        <p14:creationId xmlns:p14="http://schemas.microsoft.com/office/powerpoint/2010/main" val="3111549375"/>
+        <p14:creationId xmlns:p14="http://schemas.microsoft.com/office/powerpoint/2010/main" val="2916022834"/>
+      </p:ext>
+    </p:extLst>
+  </p:cSld>
+  <p:clrMapOvr>
+    <a:masterClrMapping/>
+  </p:clrMapOvr>
+</p:sld>
+</file>
+
+<file path=ppt/slides/slide6.xml><?xml version="1.0" encoding="utf-8"?>
+<p:sld xmlns:a="http://schemas.openxmlformats.org/drawingml/2006/main" xmlns:r="http://schemas.openxmlformats.org/officeDocument/2006/relationships" xmlns:p="http://schemas.openxmlformats.org/presentationml/2006/main">
+  <p:cSld>
+    <p:spTree>
+      <p:nvGrpSpPr>
+        <p:cNvPr id="1" name=""/>
+        <p:cNvGrpSpPr/>
+        <p:nvPr/>
+      </p:nvGrpSpPr>
+      <p:grpSpPr>
+        <a:xfrm>
+          <a:off x="0" y="0"/>
+          <a:ext cx="0" cy="0"/>
+          <a:chOff x="0" y="0"/>
+          <a:chExt cx="0" cy="0"/>
+        </a:xfrm>
+      </p:grpSpPr>
+      <p:sp>
+        <p:nvSpPr>
+          <p:cNvPr id="2" name="Title 1">
+            <a:extLst>
+              <a:ext uri="{FF2B5EF4-FFF2-40B4-BE49-F238E27FC236}">
+                <a16:creationId xmlns:a16="http://schemas.microsoft.com/office/drawing/2014/main" id="{E2D30E0F-10C6-298A-C347-E831FFF4ECB8}"/>
+              </a:ext>
+            </a:extLst>
+          </p:cNvPr>
+          <p:cNvSpPr>
+            <a:spLocks noGrp="1"/>
+          </p:cNvSpPr>
+          <p:nvPr>
+            <p:ph type="title"/>
+          </p:nvPr>
+        </p:nvSpPr>
+        <p:spPr/>
+        <p:txBody>
+          <a:bodyPr/>
+          <a:lstStyle/>
+          <a:p>
+            <a:r>
+              <a:rPr lang="en-US" dirty="0"/>
+              <a:t>Analytical Framework</a:t>
+            </a:r>
+          </a:p>
+        </p:txBody>
+      </p:sp>
+      <p:sp>
+        <p:nvSpPr>
+          <p:cNvPr id="3" name="Content Placeholder 2">
+            <a:extLst>
+              <a:ext uri="{FF2B5EF4-FFF2-40B4-BE49-F238E27FC236}">
+                <a16:creationId xmlns:a16="http://schemas.microsoft.com/office/drawing/2014/main" id="{41191CC7-9CF2-71F0-1AD4-791EA9CBAD97}"/>
+              </a:ext>
+            </a:extLst>
+          </p:cNvPr>
+          <p:cNvSpPr>
+            <a:spLocks noGrp="1"/>
+          </p:cNvSpPr>
+          <p:nvPr>
+            <p:ph sz="quarter" idx="18"/>
+          </p:nvPr>
+        </p:nvSpPr>
+        <p:spPr/>
+        <p:txBody>
+          <a:bodyPr>
+            <a:normAutofit/>
+          </a:bodyPr>
+          <a:lstStyle/>
+          <a:p>
+            <a:r>
+              <a:rPr lang="en-US" dirty="0" err="1"/>
+              <a:t>asdfasdf</a:t>
+            </a:r>
+            <a:endParaRPr lang="en-US" dirty="0"/>
+          </a:p>
+        </p:txBody>
+      </p:sp>
+      <p:sp>
+        <p:nvSpPr>
+          <p:cNvPr id="4" name="Content Placeholder 3">
+            <a:extLst>
+              <a:ext uri="{FF2B5EF4-FFF2-40B4-BE49-F238E27FC236}">
+                <a16:creationId xmlns:a16="http://schemas.microsoft.com/office/drawing/2014/main" id="{4B1BF1AC-C624-2AD2-DA0F-335AB7BA2CA8}"/>
+              </a:ext>
+            </a:extLst>
+          </p:cNvPr>
+          <p:cNvSpPr>
+            <a:spLocks noGrp="1"/>
+          </p:cNvSpPr>
+          <p:nvPr>
+            <p:ph sz="quarter" idx="17"/>
+          </p:nvPr>
+        </p:nvSpPr>
+        <p:spPr/>
+        <p:txBody>
+          <a:bodyPr>
+            <a:normAutofit/>
+          </a:bodyPr>
+          <a:lstStyle/>
+          <a:p>
+            <a:r>
+              <a:rPr lang="en-US" dirty="0" err="1"/>
+              <a:t>asdfasdf</a:t>
+            </a:r>
+            <a:endParaRPr lang="en-US" dirty="0"/>
+          </a:p>
+        </p:txBody>
+      </p:sp>
+    </p:spTree>
+    <p:extLst>
+      <p:ext uri="{BB962C8B-B14F-4D97-AF65-F5344CB8AC3E}">
+        <p14:creationId xmlns:p14="http://schemas.microsoft.com/office/powerpoint/2010/main" val="2225637236"/>
       </p:ext>
     </p:extLst>
   </p:cSld>
@@ -16375,10 +16081,10 @@
       </p:grpSpPr>
       <p:sp>
         <p:nvSpPr>
-          <p:cNvPr id="2" name="Title 1">
-            <a:extLst>
-              <a:ext uri="{FF2B5EF4-FFF2-40B4-BE49-F238E27FC236}">
-                <a16:creationId xmlns:a16="http://schemas.microsoft.com/office/drawing/2014/main" id="{E2D30E0F-10C6-298A-C347-E831FFF4ECB8}"/>
+          <p:cNvPr id="14" name="Title 13">
+            <a:extLst>
+              <a:ext uri="{FF2B5EF4-FFF2-40B4-BE49-F238E27FC236}">
+                <a16:creationId xmlns:a16="http://schemas.microsoft.com/office/drawing/2014/main" id="{331CEB84-49DC-40A9-B2F0-D573658AE999}"/>
               </a:ext>
             </a:extLst>
           </p:cNvPr>
@@ -16396,17 +16102,17 @@
           <a:p>
             <a:r>
               <a:rPr lang="en-US" dirty="0"/>
-              <a:t>Effective delivery techniques</a:t>
-            </a:r>
-          </a:p>
-        </p:txBody>
-      </p:sp>
-      <p:sp>
-        <p:nvSpPr>
-          <p:cNvPr id="3" name="Content Placeholder 2">
-            <a:extLst>
-              <a:ext uri="{FF2B5EF4-FFF2-40B4-BE49-F238E27FC236}">
-                <a16:creationId xmlns:a16="http://schemas.microsoft.com/office/drawing/2014/main" id="{41191CC7-9CF2-71F0-1AD4-791EA9CBAD97}"/>
+              <a:t>Cleaning and Preprocessing</a:t>
+            </a:r>
+          </a:p>
+        </p:txBody>
+      </p:sp>
+      <p:sp>
+        <p:nvSpPr>
+          <p:cNvPr id="15" name="Subtitle 14">
+            <a:extLst>
+              <a:ext uri="{FF2B5EF4-FFF2-40B4-BE49-F238E27FC236}">
+                <a16:creationId xmlns:a16="http://schemas.microsoft.com/office/drawing/2014/main" id="{B7886DF7-FA3D-4AD1-AEC1-578EA3AC8C7D}"/>
               </a:ext>
             </a:extLst>
           </p:cNvPr>
@@ -16414,109 +16120,54 @@
             <a:spLocks noGrp="1"/>
           </p:cNvSpPr>
           <p:nvPr>
-            <p:ph sz="quarter" idx="18"/>
+            <p:ph type="subTitle" idx="1"/>
           </p:nvPr>
         </p:nvSpPr>
         <p:spPr/>
         <p:txBody>
-          <a:bodyPr>
-            <a:normAutofit/>
-          </a:bodyPr>
+          <a:bodyPr/>
           <a:lstStyle/>
           <a:p>
             <a:r>
               <a:rPr lang="en-US" dirty="0"/>
-              <a:t>Voice modulation is a powerful tool in public speaking. It involves varying pitch, tone, and volume to convey emotion, emphasize points, and maintain interest:</a:t>
-            </a:r>
-          </a:p>
-          <a:p>
-            <a:pPr lvl="1"/>
-            <a:r>
-              <a:rPr lang="en-US" dirty="0"/>
-              <a:t>Pitch variation</a:t>
-            </a:r>
-          </a:p>
-          <a:p>
-            <a:pPr lvl="1"/>
-            <a:r>
-              <a:rPr lang="en-US" dirty="0"/>
-              <a:t>Tone inflection</a:t>
-            </a:r>
-          </a:p>
-          <a:p>
-            <a:pPr lvl="1"/>
-            <a:r>
-              <a:rPr lang="en-US" dirty="0"/>
-              <a:t>Volume control</a:t>
-            </a:r>
-          </a:p>
-        </p:txBody>
-      </p:sp>
-      <p:sp>
-        <p:nvSpPr>
-          <p:cNvPr id="4" name="Content Placeholder 3">
-            <a:extLst>
-              <a:ext uri="{FF2B5EF4-FFF2-40B4-BE49-F238E27FC236}">
-                <a16:creationId xmlns:a16="http://schemas.microsoft.com/office/drawing/2014/main" id="{4B1BF1AC-C624-2AD2-DA0F-335AB7BA2CA8}"/>
-              </a:ext>
-            </a:extLst>
-          </p:cNvPr>
-          <p:cNvSpPr>
-            <a:spLocks noGrp="1"/>
-          </p:cNvSpPr>
-          <p:nvPr>
-            <p:ph sz="quarter" idx="19"/>
-          </p:nvPr>
-        </p:nvSpPr>
+              <a:t>3 Steps</a:t>
+            </a:r>
+          </a:p>
+        </p:txBody>
+      </p:sp>
+      <p:pic>
+        <p:nvPicPr>
+          <p:cNvPr id="5" name="Picture Placeholder 4" descr="People in the middle of a circular room ">
+            <a:extLst>
+              <a:ext uri="{FF2B5EF4-FFF2-40B4-BE49-F238E27FC236}">
+                <a16:creationId xmlns:a16="http://schemas.microsoft.com/office/drawing/2014/main" id="{0CEB905B-7FDD-4B1A-96BF-B5A081A25FC8}"/>
+              </a:ext>
+            </a:extLst>
+          </p:cNvPr>
+          <p:cNvPicPr>
+            <a:picLocks noGrp="1" noChangeAspect="1"/>
+          </p:cNvPicPr>
+          <p:nvPr>
+            <p:ph type="pic" sz="quarter" idx="13"/>
+          </p:nvPr>
+        </p:nvPicPr>
+        <p:blipFill rotWithShape="1">
+          <a:blip r:embed="rId3" cstate="screen">
+            <a:extLst>
+              <a:ext uri="{28A0092B-C50C-407E-A947-70E740481C1C}">
+                <a14:useLocalDpi xmlns:a14="http://schemas.microsoft.com/office/drawing/2010/main"/>
+              </a:ext>
+            </a:extLst>
+          </a:blip>
+          <a:srcRect l="7618" r="7618"/>
+          <a:stretch/>
+        </p:blipFill>
         <p:spPr/>
-        <p:txBody>
-          <a:bodyPr/>
-          <a:lstStyle/>
-          <a:p>
-            <a:r>
-              <a:rPr lang="en-US" dirty="0"/>
-              <a:t>Effective body language enhances your message, making it more impactful </a:t>
-            </a:r>
-            <a:r>
-              <a:rPr lang="en-US"/>
-              <a:t>and memorable:</a:t>
-            </a:r>
-            <a:endParaRPr lang="en-US" dirty="0"/>
-          </a:p>
-          <a:p>
-            <a:pPr lvl="1"/>
-            <a:r>
-              <a:rPr lang="en-US" dirty="0"/>
-              <a:t>Meaningful eye contact</a:t>
-            </a:r>
-          </a:p>
-          <a:p>
-            <a:pPr lvl="1"/>
-            <a:r>
-              <a:rPr lang="en-US" dirty="0"/>
-              <a:t>Purposeful gestures</a:t>
-            </a:r>
-          </a:p>
-          <a:p>
-            <a:pPr lvl="1"/>
-            <a:r>
-              <a:rPr lang="en-US" dirty="0"/>
-              <a:t>Maintain good posture</a:t>
-            </a:r>
-          </a:p>
-          <a:p>
-            <a:pPr lvl="1"/>
-            <a:r>
-              <a:rPr lang="en-US" dirty="0"/>
-              <a:t>Control your expressions</a:t>
-            </a:r>
-          </a:p>
-        </p:txBody>
-      </p:sp>
+      </p:pic>
     </p:spTree>
     <p:extLst>
       <p:ext uri="{BB962C8B-B14F-4D97-AF65-F5344CB8AC3E}">
-        <p14:creationId xmlns:p14="http://schemas.microsoft.com/office/powerpoint/2010/main" val="1230700268"/>
+        <p14:creationId xmlns:p14="http://schemas.microsoft.com/office/powerpoint/2010/main" val="2779792646"/>
       </p:ext>
     </p:extLst>
   </p:cSld>
@@ -16548,7 +16199,7 @@
           <p:cNvPr id="2" name="Title 1">
             <a:extLst>
               <a:ext uri="{FF2B5EF4-FFF2-40B4-BE49-F238E27FC236}">
-                <a16:creationId xmlns:a16="http://schemas.microsoft.com/office/drawing/2014/main" id="{E2D30E0F-10C6-298A-C347-E831FFF4ECB8}"/>
+                <a16:creationId xmlns:a16="http://schemas.microsoft.com/office/drawing/2014/main" id="{6A0D2769-08DE-E62F-163A-27A5442A9FFA}"/>
               </a:ext>
             </a:extLst>
           </p:cNvPr>
@@ -16566,7 +16217,7 @@
           <a:p>
             <a:r>
               <a:rPr lang="en-US" dirty="0"/>
-              <a:t>Navigating Q&amp;A sessions</a:t>
+              <a:t>Feature Engineering</a:t>
             </a:r>
           </a:p>
         </p:txBody>
@@ -16576,7 +16227,7 @@
           <p:cNvPr id="3" name="Content Placeholder 2">
             <a:extLst>
               <a:ext uri="{FF2B5EF4-FFF2-40B4-BE49-F238E27FC236}">
-                <a16:creationId xmlns:a16="http://schemas.microsoft.com/office/drawing/2014/main" id="{41191CC7-9CF2-71F0-1AD4-791EA9CBAD97}"/>
+                <a16:creationId xmlns:a16="http://schemas.microsoft.com/office/drawing/2014/main" id="{3EAD3192-D337-8C2E-FAAC-9B46B5DFBD21}"/>
               </a:ext>
             </a:extLst>
           </p:cNvPr>
@@ -16584,68 +16235,7 @@
             <a:spLocks noGrp="1"/>
           </p:cNvSpPr>
           <p:nvPr>
-            <p:ph sz="quarter" idx="18"/>
-          </p:nvPr>
-        </p:nvSpPr>
-        <p:spPr/>
-        <p:txBody>
-          <a:bodyPr>
-            <a:normAutofit lnSpcReduction="10000"/>
-          </a:bodyPr>
-          <a:lstStyle/>
-          <a:p>
-            <a:r>
-              <a:rPr lang="en-US" dirty="0"/>
-              <a:t>Maintaining composure during the Q&amp;A session is essential for projecting confidence and authority. Consider the following tips for staying composed:</a:t>
-            </a:r>
-          </a:p>
-          <a:p>
-            <a:pPr lvl="1"/>
-            <a:r>
-              <a:rPr lang="en-US" dirty="0"/>
-              <a:t>Stay calm</a:t>
-            </a:r>
-          </a:p>
-          <a:p>
-            <a:pPr lvl="1"/>
-            <a:r>
-              <a:rPr lang="en-US" dirty="0"/>
-              <a:t>Actively listen</a:t>
-            </a:r>
-          </a:p>
-          <a:p>
-            <a:pPr lvl="1"/>
-            <a:r>
-              <a:rPr lang="en-US" dirty="0"/>
-              <a:t>Pause and reflect</a:t>
-            </a:r>
-          </a:p>
-          <a:p>
-            <a:pPr lvl="1"/>
-            <a:r>
-              <a:rPr lang="en-US" dirty="0"/>
-              <a:t>Maintain eye contact</a:t>
-            </a:r>
-          </a:p>
-          <a:p>
-            <a:endParaRPr lang="en-US" dirty="0"/>
-          </a:p>
-        </p:txBody>
-      </p:sp>
-      <p:sp>
-        <p:nvSpPr>
-          <p:cNvPr id="4" name="Content Placeholder 3">
-            <a:extLst>
-              <a:ext uri="{FF2B5EF4-FFF2-40B4-BE49-F238E27FC236}">
-                <a16:creationId xmlns:a16="http://schemas.microsoft.com/office/drawing/2014/main" id="{4B1BF1AC-C624-2AD2-DA0F-335AB7BA2CA8}"/>
-              </a:ext>
-            </a:extLst>
-          </p:cNvPr>
-          <p:cNvSpPr>
-            <a:spLocks noGrp="1"/>
-          </p:cNvSpPr>
-          <p:nvPr>
-            <p:ph sz="quarter" idx="17"/>
+            <p:ph sz="quarter" idx="16"/>
           </p:nvPr>
         </p:nvSpPr>
         <p:spPr/>
@@ -16657,30 +16247,50 @@
           <a:p>
             <a:r>
               <a:rPr lang="en-US" dirty="0"/>
-              <a:t>Know your material in advance</a:t>
-            </a:r>
-          </a:p>
+              <a:t>ASDGFASD</a:t>
+            </a:r>
+          </a:p>
+        </p:txBody>
+      </p:sp>
+      <p:sp>
+        <p:nvSpPr>
+          <p:cNvPr id="4" name="TextBox 3">
+            <a:extLst>
+              <a:ext uri="{FF2B5EF4-FFF2-40B4-BE49-F238E27FC236}">
+                <a16:creationId xmlns:a16="http://schemas.microsoft.com/office/drawing/2014/main" id="{54F62501-32BB-9A93-A8EB-6D8E25DFA66B}"/>
+              </a:ext>
+            </a:extLst>
+          </p:cNvPr>
+          <p:cNvSpPr txBox="1"/>
+          <p:nvPr/>
+        </p:nvSpPr>
+        <p:spPr>
+          <a:xfrm>
+            <a:off x="707919" y="2558486"/>
+            <a:ext cx="1892808" cy="923330"/>
+          </a:xfrm>
+          <a:prstGeom prst="rect">
+            <a:avLst/>
+          </a:prstGeom>
+          <a:noFill/>
+        </p:spPr>
+        <p:txBody>
+          <a:bodyPr wrap="square" rtlCol="0">
+            <a:spAutoFit/>
+          </a:bodyPr>
+          <a:lstStyle/>
           <a:p>
             <a:r>
               <a:rPr lang="en-US" dirty="0"/>
-              <a:t>Anticipate common questions</a:t>
-            </a:r>
-          </a:p>
-          <a:p>
-            <a:r>
-              <a:rPr lang="en-US" dirty="0"/>
-              <a:t>Rehearse your responses</a:t>
-            </a:r>
-          </a:p>
-          <a:p>
-            <a:endParaRPr lang="en-US" dirty="0"/>
+              <a:t>Potentially flow chart of steps here</a:t>
+            </a:r>
           </a:p>
         </p:txBody>
       </p:sp>
     </p:spTree>
     <p:extLst>
       <p:ext uri="{BB962C8B-B14F-4D97-AF65-F5344CB8AC3E}">
-        <p14:creationId xmlns:p14="http://schemas.microsoft.com/office/powerpoint/2010/main" val="2225637236"/>
+        <p14:creationId xmlns:p14="http://schemas.microsoft.com/office/powerpoint/2010/main" val="4065057152"/>
       </p:ext>
     </p:extLst>
   </p:cSld>
@@ -16712,7 +16322,7 @@
           <p:cNvPr id="2" name="Title 1">
             <a:extLst>
               <a:ext uri="{FF2B5EF4-FFF2-40B4-BE49-F238E27FC236}">
-                <a16:creationId xmlns:a16="http://schemas.microsoft.com/office/drawing/2014/main" id="{6A0D2769-08DE-E62F-163A-27A5442A9FFA}"/>
+                <a16:creationId xmlns:a16="http://schemas.microsoft.com/office/drawing/2014/main" id="{E2D30E0F-10C6-298A-C347-E831FFF4ECB8}"/>
               </a:ext>
             </a:extLst>
           </p:cNvPr>
@@ -16730,7 +16340,7 @@
           <a:p>
             <a:r>
               <a:rPr lang="en-US" dirty="0"/>
-              <a:t>Speaking impact</a:t>
+              <a:t>Model Selection</a:t>
             </a:r>
           </a:p>
         </p:txBody>
@@ -16740,7 +16350,7 @@
           <p:cNvPr id="3" name="Content Placeholder 2">
             <a:extLst>
               <a:ext uri="{FF2B5EF4-FFF2-40B4-BE49-F238E27FC236}">
-                <a16:creationId xmlns:a16="http://schemas.microsoft.com/office/drawing/2014/main" id="{3EAD3192-D337-8C2E-FAAC-9B46B5DFBD21}"/>
+                <a16:creationId xmlns:a16="http://schemas.microsoft.com/office/drawing/2014/main" id="{41191CC7-9CF2-71F0-1AD4-791EA9CBAD97}"/>
               </a:ext>
             </a:extLst>
           </p:cNvPr>
@@ -16748,7 +16358,7 @@
             <a:spLocks noGrp="1"/>
           </p:cNvSpPr>
           <p:nvPr>
-            <p:ph sz="quarter" idx="16"/>
+            <p:ph sz="quarter" idx="14"/>
           </p:nvPr>
         </p:nvSpPr>
         <p:spPr/>
@@ -16759,22 +16369,386 @@
           <a:lstStyle/>
           <a:p>
             <a:r>
+              <a:rPr lang="en-US" dirty="0" err="1"/>
+              <a:t>Asdfasdfasdf</a:t>
+            </a:r>
+            <a:endParaRPr lang="en-US" dirty="0"/>
+          </a:p>
+          <a:p>
+            <a:endParaRPr lang="en-US" dirty="0"/>
+          </a:p>
+          <a:p>
+            <a:r>
               <a:rPr lang="en-US" dirty="0"/>
-              <a:t>Your ability to communicate effectively will leave a lasting impact on your audience</a:t>
-            </a:r>
-          </a:p>
-          <a:p>
-            <a:r>
-              <a:rPr lang="en-US" dirty="0"/>
-              <a:t>Effectively communicating involves not only delivering a message but also resonating with the experiences, values, and emotions of those listening </a:t>
-            </a:r>
-          </a:p>
-        </p:txBody>
-      </p:sp>
+              <a:t>Maybe stats on the models to the right</a:t>
+            </a:r>
+          </a:p>
+        </p:txBody>
+      </p:sp>
+      <p:graphicFrame>
+        <p:nvGraphicFramePr>
+          <p:cNvPr id="11" name="Content Placeholder 10">
+            <a:extLst>
+              <a:ext uri="{FF2B5EF4-FFF2-40B4-BE49-F238E27FC236}">
+                <a16:creationId xmlns:a16="http://schemas.microsoft.com/office/drawing/2014/main" id="{453CE196-36B9-5361-5120-20DF8B3B5581}"/>
+              </a:ext>
+            </a:extLst>
+          </p:cNvPr>
+          <p:cNvGraphicFramePr>
+            <a:graphicFrameLocks noGrp="1"/>
+          </p:cNvGraphicFramePr>
+          <p:nvPr>
+            <p:ph type="tbl" sz="quarter" idx="15"/>
+            <p:extLst>
+              <p:ext uri="{D42A27DB-BD31-4B8C-83A1-F6EECF244321}">
+                <p14:modId xmlns:p14="http://schemas.microsoft.com/office/powerpoint/2010/main" val="3662960558"/>
+              </p:ext>
+            </p:extLst>
+          </p:nvPr>
+        </p:nvGraphicFramePr>
+        <p:xfrm>
+          <a:off x="5075238" y="461963"/>
+          <a:ext cx="6473823" cy="3866324"/>
+        </p:xfrm>
+        <a:graphic>
+          <a:graphicData uri="http://schemas.openxmlformats.org/drawingml/2006/table">
+            <a:tbl>
+              <a:tblPr firstRow="1" bandRow="1">
+                <a:tableStyleId>{8A107856-5554-42FB-B03E-39F5DBC370BA}</a:tableStyleId>
+              </a:tblPr>
+              <a:tblGrid>
+                <a:gridCol w="2038538">
+                  <a:extLst>
+                    <a:ext uri="{9D8B030D-6E8A-4147-A177-3AD203B41FA5}">
+                      <a16:colId xmlns:a16="http://schemas.microsoft.com/office/drawing/2014/main" val="1123561819"/>
+                    </a:ext>
+                  </a:extLst>
+                </a:gridCol>
+                <a:gridCol w="2097154">
+                  <a:extLst>
+                    <a:ext uri="{9D8B030D-6E8A-4147-A177-3AD203B41FA5}">
+                      <a16:colId xmlns:a16="http://schemas.microsoft.com/office/drawing/2014/main" val="1296588374"/>
+                    </a:ext>
+                  </a:extLst>
+                </a:gridCol>
+                <a:gridCol w="1178835">
+                  <a:extLst>
+                    <a:ext uri="{9D8B030D-6E8A-4147-A177-3AD203B41FA5}">
+                      <a16:colId xmlns:a16="http://schemas.microsoft.com/office/drawing/2014/main" val="1285016582"/>
+                    </a:ext>
+                  </a:extLst>
+                </a:gridCol>
+                <a:gridCol w="1159296">
+                  <a:extLst>
+                    <a:ext uri="{9D8B030D-6E8A-4147-A177-3AD203B41FA5}">
+                      <a16:colId xmlns:a16="http://schemas.microsoft.com/office/drawing/2014/main" val="4218447726"/>
+                    </a:ext>
+                  </a:extLst>
+                </a:gridCol>
+              </a:tblGrid>
+              <a:tr h="477078">
+                <a:tc>
+                  <a:txBody>
+                    <a:bodyPr/>
+                    <a:lstStyle/>
+                    <a:p>
+                      <a:r>
+                        <a:rPr lang="en-US" dirty="0"/>
+                        <a:t>NOT FOR USE IN FINAL</a:t>
+                      </a:r>
+                    </a:p>
+                  </a:txBody>
+                  <a:tcPr marT="91440" anchor="ctr"/>
+                </a:tc>
+                <a:tc>
+                  <a:txBody>
+                    <a:bodyPr/>
+                    <a:lstStyle/>
+                    <a:p>
+                      <a:r>
+                        <a:rPr lang="en-US" dirty="0"/>
+                        <a:t>Measurement</a:t>
+                      </a:r>
+                    </a:p>
+                  </a:txBody>
+                  <a:tcPr marT="91440" anchor="ctr"/>
+                </a:tc>
+                <a:tc>
+                  <a:txBody>
+                    <a:bodyPr/>
+                    <a:lstStyle/>
+                    <a:p>
+                      <a:r>
+                        <a:rPr lang="en-US" dirty="0"/>
+                        <a:t>Target</a:t>
+                      </a:r>
+                    </a:p>
+                  </a:txBody>
+                  <a:tcPr marT="91440" anchor="ctr"/>
+                </a:tc>
+                <a:tc>
+                  <a:txBody>
+                    <a:bodyPr/>
+                    <a:lstStyle/>
+                    <a:p>
+                      <a:r>
+                        <a:rPr lang="en-US" dirty="0"/>
+                        <a:t>Actual</a:t>
+                      </a:r>
+                    </a:p>
+                  </a:txBody>
+                  <a:tcPr marT="91440" anchor="ctr"/>
+                </a:tc>
+                <a:extLst>
+                  <a:ext uri="{0D108BD9-81ED-4DB2-BD59-A6C34878D82A}">
+                    <a16:rowId xmlns:a16="http://schemas.microsoft.com/office/drawing/2014/main" val="3342107652"/>
+                  </a:ext>
+                </a:extLst>
+              </a:tr>
+              <a:tr h="795131">
+                <a:tc>
+                  <a:txBody>
+                    <a:bodyPr/>
+                    <a:lstStyle/>
+                    <a:p>
+                      <a:r>
+                        <a:rPr lang="en-US" dirty="0"/>
+                        <a:t>Audience attendance</a:t>
+                      </a:r>
+                    </a:p>
+                  </a:txBody>
+                  <a:tcPr marT="91440" anchor="ctr"/>
+                </a:tc>
+                <a:tc>
+                  <a:txBody>
+                    <a:bodyPr/>
+                    <a:lstStyle/>
+                    <a:p>
+                      <a:r>
+                        <a:rPr lang="en-US" dirty="0"/>
+                        <a:t># of attendees</a:t>
+                      </a:r>
+                    </a:p>
+                  </a:txBody>
+                  <a:tcPr marT="91440" anchor="ctr"/>
+                </a:tc>
+                <a:tc>
+                  <a:txBody>
+                    <a:bodyPr/>
+                    <a:lstStyle/>
+                    <a:p>
+                      <a:r>
+                        <a:rPr lang="en-US" dirty="0"/>
+                        <a:t>150</a:t>
+                      </a:r>
+                    </a:p>
+                  </a:txBody>
+                  <a:tcPr marT="91440" anchor="ctr"/>
+                </a:tc>
+                <a:tc>
+                  <a:txBody>
+                    <a:bodyPr/>
+                    <a:lstStyle/>
+                    <a:p>
+                      <a:r>
+                        <a:rPr lang="en-US" dirty="0"/>
+                        <a:t>120</a:t>
+                      </a:r>
+                    </a:p>
+                  </a:txBody>
+                  <a:tcPr marT="91440" anchor="ctr"/>
+                </a:tc>
+                <a:extLst>
+                  <a:ext uri="{0D108BD9-81ED-4DB2-BD59-A6C34878D82A}">
+                    <a16:rowId xmlns:a16="http://schemas.microsoft.com/office/drawing/2014/main" val="57143556"/>
+                  </a:ext>
+                </a:extLst>
+              </a:tr>
+              <a:tr h="795131">
+                <a:tc>
+                  <a:txBody>
+                    <a:bodyPr/>
+                    <a:lstStyle/>
+                    <a:p>
+                      <a:r>
+                        <a:rPr lang="en-US" dirty="0"/>
+                        <a:t>Engagement duration</a:t>
+                      </a:r>
+                    </a:p>
+                  </a:txBody>
+                  <a:tcPr marT="91440" anchor="ctr"/>
+                </a:tc>
+                <a:tc>
+                  <a:txBody>
+                    <a:bodyPr/>
+                    <a:lstStyle/>
+                    <a:p>
+                      <a:r>
+                        <a:rPr lang="en-US" dirty="0"/>
+                        <a:t>Minutes</a:t>
+                      </a:r>
+                    </a:p>
+                  </a:txBody>
+                  <a:tcPr marT="91440" anchor="ctr"/>
+                </a:tc>
+                <a:tc>
+                  <a:txBody>
+                    <a:bodyPr/>
+                    <a:lstStyle/>
+                    <a:p>
+                      <a:r>
+                        <a:rPr lang="en-US" dirty="0"/>
+                        <a:t>60</a:t>
+                      </a:r>
+                    </a:p>
+                  </a:txBody>
+                  <a:tcPr marT="91440" anchor="ctr"/>
+                </a:tc>
+                <a:tc>
+                  <a:txBody>
+                    <a:bodyPr/>
+                    <a:lstStyle/>
+                    <a:p>
+                      <a:r>
+                        <a:rPr lang="en-US" dirty="0"/>
+                        <a:t>75</a:t>
+                      </a:r>
+                    </a:p>
+                  </a:txBody>
+                  <a:tcPr marT="91440" anchor="ctr"/>
+                </a:tc>
+                <a:extLst>
+                  <a:ext uri="{0D108BD9-81ED-4DB2-BD59-A6C34878D82A}">
+                    <a16:rowId xmlns:a16="http://schemas.microsoft.com/office/drawing/2014/main" val="2328625713"/>
+                  </a:ext>
+                </a:extLst>
+              </a:tr>
+              <a:tr h="795131">
+                <a:tc>
+                  <a:txBody>
+                    <a:bodyPr/>
+                    <a:lstStyle/>
+                    <a:p>
+                      <a:r>
+                        <a:rPr lang="en-US" dirty="0"/>
+                        <a:t>Q&amp;A interaction</a:t>
+                      </a:r>
+                    </a:p>
+                  </a:txBody>
+                  <a:tcPr marT="91440" anchor="ctr"/>
+                </a:tc>
+                <a:tc>
+                  <a:txBody>
+                    <a:bodyPr/>
+                    <a:lstStyle/>
+                    <a:p>
+                      <a:r>
+                        <a:rPr lang="en-US" dirty="0"/>
+                        <a:t># of questions</a:t>
+                      </a:r>
+                    </a:p>
+                  </a:txBody>
+                  <a:tcPr marT="91440" anchor="ctr"/>
+                </a:tc>
+                <a:tc>
+                  <a:txBody>
+                    <a:bodyPr/>
+                    <a:lstStyle/>
+                    <a:p>
+                      <a:r>
+                        <a:rPr lang="en-US" dirty="0"/>
+                        <a:t>10</a:t>
+                      </a:r>
+                    </a:p>
+                  </a:txBody>
+                  <a:tcPr marT="91440" anchor="ctr"/>
+                </a:tc>
+                <a:tc>
+                  <a:txBody>
+                    <a:bodyPr/>
+                    <a:lstStyle/>
+                    <a:p>
+                      <a:r>
+                        <a:rPr lang="en-US" dirty="0"/>
+                        <a:t>15</a:t>
+                      </a:r>
+                    </a:p>
+                  </a:txBody>
+                  <a:tcPr marT="91440" anchor="ctr"/>
+                </a:tc>
+                <a:extLst>
+                  <a:ext uri="{0D108BD9-81ED-4DB2-BD59-A6C34878D82A}">
+                    <a16:rowId xmlns:a16="http://schemas.microsoft.com/office/drawing/2014/main" val="280048660"/>
+                  </a:ext>
+                </a:extLst>
+              </a:tr>
+              <a:tr h="795131">
+                <a:tc>
+                  <a:txBody>
+                    <a:bodyPr/>
+                    <a:lstStyle/>
+                    <a:p>
+                      <a:r>
+                        <a:rPr lang="en-US" dirty="0"/>
+                        <a:t>Positive feedback</a:t>
+                      </a:r>
+                    </a:p>
+                  </a:txBody>
+                  <a:tcPr marT="91440" anchor="ctr"/>
+                </a:tc>
+                <a:tc>
+                  <a:txBody>
+                    <a:bodyPr/>
+                    <a:lstStyle/>
+                    <a:p>
+                      <a:r>
+                        <a:rPr lang="en-US" dirty="0"/>
+                        <a:t>Percentage (%)</a:t>
+                      </a:r>
+                    </a:p>
+                  </a:txBody>
+                  <a:tcPr marT="91440" anchor="ctr"/>
+                </a:tc>
+                <a:tc>
+                  <a:txBody>
+                    <a:bodyPr/>
+                    <a:lstStyle/>
+                    <a:p>
+                      <a:r>
+                        <a:rPr lang="en-US" dirty="0"/>
+                        <a:t>90</a:t>
+                      </a:r>
+                    </a:p>
+                  </a:txBody>
+                  <a:tcPr marT="91440" anchor="ctr"/>
+                </a:tc>
+                <a:tc>
+                  <a:txBody>
+                    <a:bodyPr/>
+                    <a:lstStyle/>
+                    <a:p>
+                      <a:r>
+                        <a:rPr lang="en-US" dirty="0"/>
+                        <a:t>95</a:t>
+                      </a:r>
+                    </a:p>
+                  </a:txBody>
+                  <a:tcPr marT="91440" anchor="ctr"/>
+                </a:tc>
+                <a:extLst>
+                  <a:ext uri="{0D108BD9-81ED-4DB2-BD59-A6C34878D82A}">
+                    <a16:rowId xmlns:a16="http://schemas.microsoft.com/office/drawing/2014/main" val="3515855353"/>
+                  </a:ext>
+                </a:extLst>
+              </a:tr>
+            </a:tbl>
+          </a:graphicData>
+        </a:graphic>
+      </p:graphicFrame>
     </p:spTree>
     <p:extLst>
       <p:ext uri="{BB962C8B-B14F-4D97-AF65-F5344CB8AC3E}">
-        <p14:creationId xmlns:p14="http://schemas.microsoft.com/office/powerpoint/2010/main" val="4065057152"/>
+        <p14:creationId xmlns:p14="http://schemas.microsoft.com/office/powerpoint/2010/main" val="2394014735"/>
       </p:ext>
     </p:extLst>
   </p:cSld>
@@ -17558,15 +17532,6 @@
 </file>
 
 <file path=customXml/item1.xml><?xml version="1.0" encoding="utf-8"?>
-<?mso-contentType ?>
-<FormTemplates xmlns="http://schemas.microsoft.com/sharepoint/v3/contenttype/forms">
-  <Display>DocumentLibraryForm</Display>
-  <Edit>DocumentLibraryForm</Edit>
-  <New>DocumentLibraryForm</New>
-</FormTemplates>
-</file>
-
-<file path=customXml/item2.xml><?xml version="1.0" encoding="utf-8"?>
 <p:properties xmlns:p="http://schemas.microsoft.com/office/2006/metadata/properties" xmlns:xsi="http://www.w3.org/2001/XMLSchema-instance" xmlns:pc="http://schemas.microsoft.com/office/infopath/2007/PartnerControls">
   <documentManagement>
     <_ip_UnifiedCompliancePolicyUIAction xmlns="http://schemas.microsoft.com/sharepoint/v3" xsi:nil="true"/>
@@ -17584,6 +17549,15 @@
     <MediaServiceKeyPoints xmlns="71af3243-3dd4-4a8d-8c0d-dd76da1f02a5" xsi:nil="true"/>
   </documentManagement>
 </p:properties>
+</file>
+
+<file path=customXml/item2.xml><?xml version="1.0" encoding="utf-8"?>
+<?mso-contentType ?>
+<FormTemplates xmlns="http://schemas.microsoft.com/sharepoint/v3/contenttype/forms">
+  <Display>DocumentLibraryForm</Display>
+  <Edit>DocumentLibraryForm</Edit>
+  <New>DocumentLibraryForm</New>
+</FormTemplates>
 </file>
 
 <file path=customXml/item3.xml><?xml version="1.0" encoding="utf-8"?>
@@ -17899,14 +17873,6 @@
 </file>
 
 <file path=customXml/itemProps1.xml><?xml version="1.0" encoding="utf-8"?>
-<ds:datastoreItem xmlns:ds="http://schemas.openxmlformats.org/officeDocument/2006/customXml" ds:itemID="{6F36CB81-A037-44A8-88EB-C0C0F17FD4B1}">
-  <ds:schemaRefs>
-    <ds:schemaRef ds:uri="http://schemas.microsoft.com/sharepoint/v3/contenttype/forms"/>
-  </ds:schemaRefs>
-</ds:datastoreItem>
-</file>
-
-<file path=customXml/itemProps2.xml><?xml version="1.0" encoding="utf-8"?>
 <ds:datastoreItem xmlns:ds="http://schemas.openxmlformats.org/officeDocument/2006/customXml" ds:itemID="{57FF477C-132F-44F8-8C56-EBFF95FAF97B}">
   <ds:schemaRefs>
     <ds:schemaRef ds:uri="http://schemas.microsoft.com/office/2006/metadata/properties"/>
@@ -17914,6 +17880,14 @@
     <ds:schemaRef ds:uri="http://schemas.microsoft.com/sharepoint/v3"/>
     <ds:schemaRef ds:uri="71af3243-3dd4-4a8d-8c0d-dd76da1f02a5"/>
     <ds:schemaRef ds:uri="230e9df3-be65-4c73-a93b-d1236ebd677e"/>
+  </ds:schemaRefs>
+</ds:datastoreItem>
+</file>
+
+<file path=customXml/itemProps2.xml><?xml version="1.0" encoding="utf-8"?>
+<ds:datastoreItem xmlns:ds="http://schemas.openxmlformats.org/officeDocument/2006/customXml" ds:itemID="{6F36CB81-A037-44A8-88EB-C0C0F17FD4B1}">
+  <ds:schemaRefs>
+    <ds:schemaRef ds:uri="http://schemas.microsoft.com/sharepoint/v3/contenttype/forms"/>
   </ds:schemaRefs>
 </ds:datastoreItem>
 </file>

</xml_diff>

<commit_message>
more slides - matt
</commit_message>
<xml_diff>
--- a/presentation.pptx
+++ b/presentation.pptx
@@ -16006,15 +16006,64 @@
         <p:spPr/>
         <p:txBody>
           <a:bodyPr>
-            <a:normAutofit/>
+            <a:normAutofit fontScale="77500" lnSpcReduction="20000"/>
           </a:bodyPr>
           <a:lstStyle/>
           <a:p>
             <a:r>
+              <a:rPr lang="en-US" dirty="0"/>
+              <a:t>RMSE (Root Mean Squared Error) was chosen for its sensitivity to large errors, aligning with the business goal of accurate high-value home assessments.</a:t>
+            </a:r>
+          </a:p>
+          <a:p>
+            <a:r>
+              <a:rPr lang="en-US" dirty="0"/>
+              <a:t>We used cross-validation to assess generalization, particularly </a:t>
+            </a:r>
+            <a:r>
               <a:rPr lang="en-US" dirty="0" err="1"/>
-              <a:t>asdfasdf</a:t>
-            </a:r>
-            <a:endParaRPr lang="en-US" dirty="0"/>
+              <a:t>KFold</a:t>
+            </a:r>
+            <a:r>
+              <a:rPr lang="en-US" dirty="0"/>
+              <a:t> and </a:t>
+            </a:r>
+            <a:r>
+              <a:rPr lang="en-US" dirty="0" err="1"/>
+              <a:t>RepeatedKFold</a:t>
+            </a:r>
+            <a:r>
+              <a:rPr lang="en-US" dirty="0"/>
+              <a:t>, to ensure stability across multiple data splits.</a:t>
+            </a:r>
+          </a:p>
+          <a:p>
+            <a:r>
+              <a:rPr lang="en-US" dirty="0"/>
+              <a:t>We explored linear models, tree-based models, and ensemble techniques to cover a range of complexities and interpretabilities.</a:t>
+            </a:r>
+          </a:p>
+          <a:p>
+            <a:r>
+              <a:rPr lang="en-US" dirty="0"/>
+              <a:t>Initially, </a:t>
+            </a:r>
+            <a:r>
+              <a:rPr lang="en-US" dirty="0" err="1"/>
+              <a:t>RandomizedSearchCV</a:t>
+            </a:r>
+            <a:r>
+              <a:rPr lang="en-US" dirty="0"/>
+              <a:t> was used for efficient exploration. </a:t>
+            </a:r>
+            <a:r>
+              <a:rPr lang="en-US" dirty="0" err="1"/>
+              <a:t>GridSearchCV</a:t>
+            </a:r>
+            <a:r>
+              <a:rPr lang="en-US" dirty="0"/>
+              <a:t> was later removed due to marginal performance gains and high computational cost.</a:t>
+            </a:r>
           </a:p>
         </p:txBody>
       </p:sp>
@@ -16034,18 +16083,749 @@
             <p:ph sz="quarter" idx="17"/>
           </p:nvPr>
         </p:nvSpPr>
-        <p:spPr/>
+        <p:spPr>
+          <a:xfrm>
+            <a:off x="8243082" y="2727960"/>
+            <a:ext cx="3653262" cy="618743"/>
+          </a:xfrm>
+        </p:spPr>
         <p:txBody>
           <a:bodyPr>
             <a:normAutofit/>
           </a:bodyPr>
           <a:lstStyle/>
           <a:p>
-            <a:r>
-              <a:rPr lang="en-US" dirty="0" err="1"/>
-              <a:t>asdfasdf</a:t>
-            </a:r>
-            <a:endParaRPr lang="en-US" dirty="0"/>
+            <a:pPr>
+              <a:buFont typeface="Meiryo" panose="020B0604030504040204" pitchFamily="34" charset="-128"/>
+              <a:buChar char="←"/>
+            </a:pPr>
+            <a:r>
+              <a:rPr lang="en-US" dirty="0"/>
+              <a:t>Error Metric</a:t>
+            </a:r>
+          </a:p>
+        </p:txBody>
+      </p:sp>
+      <p:sp>
+        <p:nvSpPr>
+          <p:cNvPr id="6" name="Content Placeholder 3">
+            <a:extLst>
+              <a:ext uri="{FF2B5EF4-FFF2-40B4-BE49-F238E27FC236}">
+                <a16:creationId xmlns:a16="http://schemas.microsoft.com/office/drawing/2014/main" id="{89EDE988-8293-E1AE-1AB1-D5703331EE67}"/>
+              </a:ext>
+            </a:extLst>
+          </p:cNvPr>
+          <p:cNvSpPr txBox="1">
+            <a:spLocks/>
+          </p:cNvSpPr>
+          <p:nvPr/>
+        </p:nvSpPr>
+        <p:spPr>
+          <a:xfrm>
+            <a:off x="8243082" y="5303521"/>
+            <a:ext cx="3653262" cy="661416"/>
+          </a:xfrm>
+          <a:prstGeom prst="rect">
+            <a:avLst/>
+          </a:prstGeom>
+        </p:spPr>
+        <p:txBody>
+          <a:bodyPr vert="horz" lIns="109728" tIns="109728" rIns="109728" bIns="91440" rtlCol="0" anchor="t">
+            <a:normAutofit/>
+          </a:bodyPr>
+          <a:lstStyle>
+            <a:lvl1pPr marL="285750" indent="-285750" algn="l" defTabSz="914400" rtl="0" eaLnBrk="1" latinLnBrk="0" hangingPunct="1">
+              <a:lnSpc>
+                <a:spcPct val="125000"/>
+              </a:lnSpc>
+              <a:spcBef>
+                <a:spcPts val="930"/>
+              </a:spcBef>
+              <a:spcAft>
+                <a:spcPts val="600"/>
+              </a:spcAft>
+              <a:buFont typeface="Wingdings" panose="05000000000000000000" pitchFamily="2" charset="2"/>
+              <a:buChar char="§"/>
+              <a:defRPr sz="1800" b="0" kern="1200" spc="150" baseline="0">
+                <a:solidFill>
+                  <a:schemeClr val="tx1">
+                    <a:lumMod val="75000"/>
+                    <a:lumOff val="25000"/>
+                  </a:schemeClr>
+                </a:solidFill>
+                <a:latin typeface="+mn-lt"/>
+                <a:ea typeface="+mn-ea"/>
+                <a:cs typeface="+mn-cs"/>
+              </a:defRPr>
+            </a:lvl1pPr>
+            <a:lvl2pPr marL="0" indent="0" algn="l" defTabSz="914400" rtl="0" eaLnBrk="1" latinLnBrk="0" hangingPunct="1">
+              <a:lnSpc>
+                <a:spcPct val="125000"/>
+              </a:lnSpc>
+              <a:spcBef>
+                <a:spcPts val="930"/>
+              </a:spcBef>
+              <a:spcAft>
+                <a:spcPts val="600"/>
+              </a:spcAft>
+              <a:buFont typeface="Corbel" panose="020B0503020204020204" pitchFamily="34" charset="0"/>
+              <a:buNone/>
+              <a:defRPr sz="1800" kern="1200" spc="150" baseline="0">
+                <a:solidFill>
+                  <a:schemeClr val="tx1">
+                    <a:lumMod val="75000"/>
+                    <a:lumOff val="25000"/>
+                  </a:schemeClr>
+                </a:solidFill>
+                <a:latin typeface="+mn-lt"/>
+                <a:ea typeface="+mn-ea"/>
+                <a:cs typeface="+mn-cs"/>
+              </a:defRPr>
+            </a:lvl2pPr>
+            <a:lvl3pPr marL="0" indent="-320040" algn="l" defTabSz="914400" rtl="0" eaLnBrk="1" latinLnBrk="0" hangingPunct="1">
+              <a:lnSpc>
+                <a:spcPct val="125000"/>
+              </a:lnSpc>
+              <a:spcBef>
+                <a:spcPts val="930"/>
+              </a:spcBef>
+              <a:spcAft>
+                <a:spcPts val="600"/>
+              </a:spcAft>
+              <a:buFont typeface="Corbel" panose="020B0503020204020204" pitchFamily="34" charset="0"/>
+              <a:buChar char="–"/>
+              <a:defRPr sz="1800" i="1" kern="1200" spc="150" baseline="0">
+                <a:solidFill>
+                  <a:schemeClr val="tx1">
+                    <a:lumMod val="75000"/>
+                    <a:lumOff val="25000"/>
+                  </a:schemeClr>
+                </a:solidFill>
+                <a:latin typeface="+mn-lt"/>
+                <a:ea typeface="+mn-ea"/>
+                <a:cs typeface="+mn-cs"/>
+              </a:defRPr>
+            </a:lvl3pPr>
+            <a:lvl4pPr marL="0" indent="-320040" algn="l" defTabSz="914400" rtl="0" eaLnBrk="1" latinLnBrk="0" hangingPunct="1">
+              <a:lnSpc>
+                <a:spcPct val="125000"/>
+              </a:lnSpc>
+              <a:spcBef>
+                <a:spcPts val="930"/>
+              </a:spcBef>
+              <a:spcAft>
+                <a:spcPts val="600"/>
+              </a:spcAft>
+              <a:buFont typeface="Corbel" panose="020B0503020204020204" pitchFamily="34" charset="0"/>
+              <a:buChar char="–"/>
+              <a:defRPr sz="1800" kern="1200" spc="150" baseline="0">
+                <a:solidFill>
+                  <a:schemeClr val="tx1">
+                    <a:lumMod val="75000"/>
+                    <a:lumOff val="25000"/>
+                  </a:schemeClr>
+                </a:solidFill>
+                <a:latin typeface="+mn-lt"/>
+                <a:ea typeface="+mn-ea"/>
+                <a:cs typeface="+mn-cs"/>
+              </a:defRPr>
+            </a:lvl4pPr>
+            <a:lvl5pPr marL="0" indent="-320040" algn="l" defTabSz="914400" rtl="0" eaLnBrk="1" latinLnBrk="0" hangingPunct="1">
+              <a:lnSpc>
+                <a:spcPct val="125000"/>
+              </a:lnSpc>
+              <a:spcBef>
+                <a:spcPts val="930"/>
+              </a:spcBef>
+              <a:spcAft>
+                <a:spcPts val="600"/>
+              </a:spcAft>
+              <a:buFont typeface="Corbel" panose="020B0503020204020204" pitchFamily="34" charset="0"/>
+              <a:buChar char="–"/>
+              <a:defRPr sz="1800" i="1" kern="1200" spc="150" baseline="0">
+                <a:solidFill>
+                  <a:schemeClr val="tx1">
+                    <a:lumMod val="75000"/>
+                    <a:lumOff val="25000"/>
+                  </a:schemeClr>
+                </a:solidFill>
+                <a:latin typeface="+mn-lt"/>
+                <a:ea typeface="+mn-ea"/>
+                <a:cs typeface="+mn-cs"/>
+              </a:defRPr>
+            </a:lvl5pPr>
+            <a:lvl6pPr marL="1920240" indent="-320040" algn="l" defTabSz="914400" rtl="0" eaLnBrk="1" latinLnBrk="0" hangingPunct="1">
+              <a:lnSpc>
+                <a:spcPct val="111000"/>
+              </a:lnSpc>
+              <a:spcBef>
+                <a:spcPts val="930"/>
+              </a:spcBef>
+              <a:buFont typeface="Corbel" panose="020B0503020204020204" pitchFamily="34" charset="0"/>
+              <a:buChar char="–"/>
+              <a:defRPr sz="1400" kern="1200">
+                <a:solidFill>
+                  <a:schemeClr val="accent1">
+                    <a:lumMod val="75000"/>
+                  </a:schemeClr>
+                </a:solidFill>
+                <a:latin typeface="+mn-lt"/>
+                <a:ea typeface="+mn-ea"/>
+                <a:cs typeface="+mn-cs"/>
+              </a:defRPr>
+            </a:lvl6pPr>
+            <a:lvl7pPr marL="2240280" indent="-320040" algn="l" defTabSz="914400" rtl="0" eaLnBrk="1" latinLnBrk="0" hangingPunct="1">
+              <a:lnSpc>
+                <a:spcPct val="111000"/>
+              </a:lnSpc>
+              <a:spcBef>
+                <a:spcPts val="930"/>
+              </a:spcBef>
+              <a:buFont typeface="Corbel" panose="020B0503020204020204" pitchFamily="34" charset="0"/>
+              <a:buChar char="–"/>
+              <a:defRPr sz="1400" i="1" kern="1200">
+                <a:solidFill>
+                  <a:schemeClr val="accent1">
+                    <a:lumMod val="75000"/>
+                  </a:schemeClr>
+                </a:solidFill>
+                <a:latin typeface="+mn-lt"/>
+                <a:ea typeface="+mn-ea"/>
+                <a:cs typeface="+mn-cs"/>
+              </a:defRPr>
+            </a:lvl7pPr>
+            <a:lvl8pPr marL="2560320" indent="-320040" algn="l" defTabSz="914400" rtl="0" eaLnBrk="1" latinLnBrk="0" hangingPunct="1">
+              <a:lnSpc>
+                <a:spcPct val="111000"/>
+              </a:lnSpc>
+              <a:spcBef>
+                <a:spcPts val="930"/>
+              </a:spcBef>
+              <a:buFont typeface="Corbel" panose="020B0503020204020204" pitchFamily="34" charset="0"/>
+              <a:buChar char="–"/>
+              <a:defRPr sz="1400" kern="1200">
+                <a:solidFill>
+                  <a:schemeClr val="accent1">
+                    <a:lumMod val="75000"/>
+                  </a:schemeClr>
+                </a:solidFill>
+                <a:latin typeface="+mn-lt"/>
+                <a:ea typeface="+mn-ea"/>
+                <a:cs typeface="+mn-cs"/>
+              </a:defRPr>
+            </a:lvl8pPr>
+            <a:lvl9pPr marL="2880360" indent="-320040" algn="l" defTabSz="914400" rtl="0" eaLnBrk="1" latinLnBrk="0" hangingPunct="1">
+              <a:lnSpc>
+                <a:spcPct val="111000"/>
+              </a:lnSpc>
+              <a:spcBef>
+                <a:spcPts val="930"/>
+              </a:spcBef>
+              <a:buFont typeface="Corbel" panose="020B0503020204020204" pitchFamily="34" charset="0"/>
+              <a:buChar char="–"/>
+              <a:defRPr sz="1400" i="1" kern="1200">
+                <a:solidFill>
+                  <a:schemeClr val="accent1">
+                    <a:lumMod val="75000"/>
+                  </a:schemeClr>
+                </a:solidFill>
+                <a:latin typeface="+mn-lt"/>
+                <a:ea typeface="+mn-ea"/>
+                <a:cs typeface="+mn-cs"/>
+              </a:defRPr>
+            </a:lvl9pPr>
+          </a:lstStyle>
+          <a:p>
+            <a:pPr>
+              <a:buFont typeface="Meiryo" panose="020B0604030504040204" pitchFamily="34" charset="-128"/>
+              <a:buChar char="←"/>
+            </a:pPr>
+            <a:r>
+              <a:rPr lang="en-US" dirty="0"/>
+              <a:t>Hyperparameter Tuning</a:t>
+            </a:r>
+          </a:p>
+        </p:txBody>
+      </p:sp>
+      <p:sp>
+        <p:nvSpPr>
+          <p:cNvPr id="7" name="Content Placeholder 3">
+            <a:extLst>
+              <a:ext uri="{FF2B5EF4-FFF2-40B4-BE49-F238E27FC236}">
+                <a16:creationId xmlns:a16="http://schemas.microsoft.com/office/drawing/2014/main" id="{D50D2A7C-875A-BACE-9322-9168EA105383}"/>
+              </a:ext>
+            </a:extLst>
+          </p:cNvPr>
+          <p:cNvSpPr txBox="1">
+            <a:spLocks/>
+          </p:cNvSpPr>
+          <p:nvPr/>
+        </p:nvSpPr>
+        <p:spPr>
+          <a:xfrm>
+            <a:off x="8243082" y="3621768"/>
+            <a:ext cx="3653262" cy="618743"/>
+          </a:xfrm>
+          <a:prstGeom prst="rect">
+            <a:avLst/>
+          </a:prstGeom>
+        </p:spPr>
+        <p:txBody>
+          <a:bodyPr vert="horz" lIns="109728" tIns="109728" rIns="109728" bIns="91440" rtlCol="0" anchor="t">
+            <a:normAutofit/>
+          </a:bodyPr>
+          <a:lstStyle>
+            <a:lvl1pPr marL="285750" indent="-285750" algn="l" defTabSz="914400" rtl="0" eaLnBrk="1" latinLnBrk="0" hangingPunct="1">
+              <a:lnSpc>
+                <a:spcPct val="125000"/>
+              </a:lnSpc>
+              <a:spcBef>
+                <a:spcPts val="930"/>
+              </a:spcBef>
+              <a:spcAft>
+                <a:spcPts val="600"/>
+              </a:spcAft>
+              <a:buFont typeface="Wingdings" panose="05000000000000000000" pitchFamily="2" charset="2"/>
+              <a:buChar char="§"/>
+              <a:defRPr sz="1800" b="0" kern="1200" spc="150" baseline="0">
+                <a:solidFill>
+                  <a:schemeClr val="tx1">
+                    <a:lumMod val="75000"/>
+                    <a:lumOff val="25000"/>
+                  </a:schemeClr>
+                </a:solidFill>
+                <a:latin typeface="+mn-lt"/>
+                <a:ea typeface="+mn-ea"/>
+                <a:cs typeface="+mn-cs"/>
+              </a:defRPr>
+            </a:lvl1pPr>
+            <a:lvl2pPr marL="0" indent="0" algn="l" defTabSz="914400" rtl="0" eaLnBrk="1" latinLnBrk="0" hangingPunct="1">
+              <a:lnSpc>
+                <a:spcPct val="125000"/>
+              </a:lnSpc>
+              <a:spcBef>
+                <a:spcPts val="930"/>
+              </a:spcBef>
+              <a:spcAft>
+                <a:spcPts val="600"/>
+              </a:spcAft>
+              <a:buFont typeface="Corbel" panose="020B0503020204020204" pitchFamily="34" charset="0"/>
+              <a:buNone/>
+              <a:defRPr sz="1800" kern="1200" spc="150" baseline="0">
+                <a:solidFill>
+                  <a:schemeClr val="tx1">
+                    <a:lumMod val="75000"/>
+                    <a:lumOff val="25000"/>
+                  </a:schemeClr>
+                </a:solidFill>
+                <a:latin typeface="+mn-lt"/>
+                <a:ea typeface="+mn-ea"/>
+                <a:cs typeface="+mn-cs"/>
+              </a:defRPr>
+            </a:lvl2pPr>
+            <a:lvl3pPr marL="0" indent="-320040" algn="l" defTabSz="914400" rtl="0" eaLnBrk="1" latinLnBrk="0" hangingPunct="1">
+              <a:lnSpc>
+                <a:spcPct val="125000"/>
+              </a:lnSpc>
+              <a:spcBef>
+                <a:spcPts val="930"/>
+              </a:spcBef>
+              <a:spcAft>
+                <a:spcPts val="600"/>
+              </a:spcAft>
+              <a:buFont typeface="Corbel" panose="020B0503020204020204" pitchFamily="34" charset="0"/>
+              <a:buChar char="–"/>
+              <a:defRPr sz="1800" i="1" kern="1200" spc="150" baseline="0">
+                <a:solidFill>
+                  <a:schemeClr val="tx1">
+                    <a:lumMod val="75000"/>
+                    <a:lumOff val="25000"/>
+                  </a:schemeClr>
+                </a:solidFill>
+                <a:latin typeface="+mn-lt"/>
+                <a:ea typeface="+mn-ea"/>
+                <a:cs typeface="+mn-cs"/>
+              </a:defRPr>
+            </a:lvl3pPr>
+            <a:lvl4pPr marL="0" indent="-320040" algn="l" defTabSz="914400" rtl="0" eaLnBrk="1" latinLnBrk="0" hangingPunct="1">
+              <a:lnSpc>
+                <a:spcPct val="125000"/>
+              </a:lnSpc>
+              <a:spcBef>
+                <a:spcPts val="930"/>
+              </a:spcBef>
+              <a:spcAft>
+                <a:spcPts val="600"/>
+              </a:spcAft>
+              <a:buFont typeface="Corbel" panose="020B0503020204020204" pitchFamily="34" charset="0"/>
+              <a:buChar char="–"/>
+              <a:defRPr sz="1800" kern="1200" spc="150" baseline="0">
+                <a:solidFill>
+                  <a:schemeClr val="tx1">
+                    <a:lumMod val="75000"/>
+                    <a:lumOff val="25000"/>
+                  </a:schemeClr>
+                </a:solidFill>
+                <a:latin typeface="+mn-lt"/>
+                <a:ea typeface="+mn-ea"/>
+                <a:cs typeface="+mn-cs"/>
+              </a:defRPr>
+            </a:lvl4pPr>
+            <a:lvl5pPr marL="0" indent="-320040" algn="l" defTabSz="914400" rtl="0" eaLnBrk="1" latinLnBrk="0" hangingPunct="1">
+              <a:lnSpc>
+                <a:spcPct val="125000"/>
+              </a:lnSpc>
+              <a:spcBef>
+                <a:spcPts val="930"/>
+              </a:spcBef>
+              <a:spcAft>
+                <a:spcPts val="600"/>
+              </a:spcAft>
+              <a:buFont typeface="Corbel" panose="020B0503020204020204" pitchFamily="34" charset="0"/>
+              <a:buChar char="–"/>
+              <a:defRPr sz="1800" i="1" kern="1200" spc="150" baseline="0">
+                <a:solidFill>
+                  <a:schemeClr val="tx1">
+                    <a:lumMod val="75000"/>
+                    <a:lumOff val="25000"/>
+                  </a:schemeClr>
+                </a:solidFill>
+                <a:latin typeface="+mn-lt"/>
+                <a:ea typeface="+mn-ea"/>
+                <a:cs typeface="+mn-cs"/>
+              </a:defRPr>
+            </a:lvl5pPr>
+            <a:lvl6pPr marL="1920240" indent="-320040" algn="l" defTabSz="914400" rtl="0" eaLnBrk="1" latinLnBrk="0" hangingPunct="1">
+              <a:lnSpc>
+                <a:spcPct val="111000"/>
+              </a:lnSpc>
+              <a:spcBef>
+                <a:spcPts val="930"/>
+              </a:spcBef>
+              <a:buFont typeface="Corbel" panose="020B0503020204020204" pitchFamily="34" charset="0"/>
+              <a:buChar char="–"/>
+              <a:defRPr sz="1400" kern="1200">
+                <a:solidFill>
+                  <a:schemeClr val="accent1">
+                    <a:lumMod val="75000"/>
+                  </a:schemeClr>
+                </a:solidFill>
+                <a:latin typeface="+mn-lt"/>
+                <a:ea typeface="+mn-ea"/>
+                <a:cs typeface="+mn-cs"/>
+              </a:defRPr>
+            </a:lvl6pPr>
+            <a:lvl7pPr marL="2240280" indent="-320040" algn="l" defTabSz="914400" rtl="0" eaLnBrk="1" latinLnBrk="0" hangingPunct="1">
+              <a:lnSpc>
+                <a:spcPct val="111000"/>
+              </a:lnSpc>
+              <a:spcBef>
+                <a:spcPts val="930"/>
+              </a:spcBef>
+              <a:buFont typeface="Corbel" panose="020B0503020204020204" pitchFamily="34" charset="0"/>
+              <a:buChar char="–"/>
+              <a:defRPr sz="1400" i="1" kern="1200">
+                <a:solidFill>
+                  <a:schemeClr val="accent1">
+                    <a:lumMod val="75000"/>
+                  </a:schemeClr>
+                </a:solidFill>
+                <a:latin typeface="+mn-lt"/>
+                <a:ea typeface="+mn-ea"/>
+                <a:cs typeface="+mn-cs"/>
+              </a:defRPr>
+            </a:lvl7pPr>
+            <a:lvl8pPr marL="2560320" indent="-320040" algn="l" defTabSz="914400" rtl="0" eaLnBrk="1" latinLnBrk="0" hangingPunct="1">
+              <a:lnSpc>
+                <a:spcPct val="111000"/>
+              </a:lnSpc>
+              <a:spcBef>
+                <a:spcPts val="930"/>
+              </a:spcBef>
+              <a:buFont typeface="Corbel" panose="020B0503020204020204" pitchFamily="34" charset="0"/>
+              <a:buChar char="–"/>
+              <a:defRPr sz="1400" kern="1200">
+                <a:solidFill>
+                  <a:schemeClr val="accent1">
+                    <a:lumMod val="75000"/>
+                  </a:schemeClr>
+                </a:solidFill>
+                <a:latin typeface="+mn-lt"/>
+                <a:ea typeface="+mn-ea"/>
+                <a:cs typeface="+mn-cs"/>
+              </a:defRPr>
+            </a:lvl8pPr>
+            <a:lvl9pPr marL="2880360" indent="-320040" algn="l" defTabSz="914400" rtl="0" eaLnBrk="1" latinLnBrk="0" hangingPunct="1">
+              <a:lnSpc>
+                <a:spcPct val="111000"/>
+              </a:lnSpc>
+              <a:spcBef>
+                <a:spcPts val="930"/>
+              </a:spcBef>
+              <a:buFont typeface="Corbel" panose="020B0503020204020204" pitchFamily="34" charset="0"/>
+              <a:buChar char="–"/>
+              <a:defRPr sz="1400" i="1" kern="1200">
+                <a:solidFill>
+                  <a:schemeClr val="accent1">
+                    <a:lumMod val="75000"/>
+                  </a:schemeClr>
+                </a:solidFill>
+                <a:latin typeface="+mn-lt"/>
+                <a:ea typeface="+mn-ea"/>
+                <a:cs typeface="+mn-cs"/>
+              </a:defRPr>
+            </a:lvl9pPr>
+          </a:lstStyle>
+          <a:p>
+            <a:pPr>
+              <a:buFont typeface="Meiryo" panose="020B0604030504040204" pitchFamily="34" charset="-128"/>
+              <a:buChar char="←"/>
+            </a:pPr>
+            <a:r>
+              <a:rPr lang="en-US" dirty="0"/>
+              <a:t>Validation</a:t>
+            </a:r>
+          </a:p>
+        </p:txBody>
+      </p:sp>
+      <p:sp>
+        <p:nvSpPr>
+          <p:cNvPr id="8" name="Content Placeholder 3">
+            <a:extLst>
+              <a:ext uri="{FF2B5EF4-FFF2-40B4-BE49-F238E27FC236}">
+                <a16:creationId xmlns:a16="http://schemas.microsoft.com/office/drawing/2014/main" id="{5AC01ED3-A816-D0F5-C495-6981C46A8F5B}"/>
+              </a:ext>
+            </a:extLst>
+          </p:cNvPr>
+          <p:cNvSpPr txBox="1">
+            <a:spLocks/>
+          </p:cNvSpPr>
+          <p:nvPr/>
+        </p:nvSpPr>
+        <p:spPr>
+          <a:xfrm>
+            <a:off x="8243082" y="4515577"/>
+            <a:ext cx="3653262" cy="618744"/>
+          </a:xfrm>
+          <a:prstGeom prst="rect">
+            <a:avLst/>
+          </a:prstGeom>
+        </p:spPr>
+        <p:txBody>
+          <a:bodyPr vert="horz" lIns="109728" tIns="109728" rIns="109728" bIns="91440" rtlCol="0" anchor="t">
+            <a:normAutofit/>
+          </a:bodyPr>
+          <a:lstStyle>
+            <a:lvl1pPr marL="285750" indent="-285750" algn="l" defTabSz="914400" rtl="0" eaLnBrk="1" latinLnBrk="0" hangingPunct="1">
+              <a:lnSpc>
+                <a:spcPct val="125000"/>
+              </a:lnSpc>
+              <a:spcBef>
+                <a:spcPts val="930"/>
+              </a:spcBef>
+              <a:spcAft>
+                <a:spcPts val="600"/>
+              </a:spcAft>
+              <a:buFont typeface="Wingdings" panose="05000000000000000000" pitchFamily="2" charset="2"/>
+              <a:buChar char="§"/>
+              <a:defRPr sz="1800" b="0" kern="1200" spc="150" baseline="0">
+                <a:solidFill>
+                  <a:schemeClr val="tx1">
+                    <a:lumMod val="75000"/>
+                    <a:lumOff val="25000"/>
+                  </a:schemeClr>
+                </a:solidFill>
+                <a:latin typeface="+mn-lt"/>
+                <a:ea typeface="+mn-ea"/>
+                <a:cs typeface="+mn-cs"/>
+              </a:defRPr>
+            </a:lvl1pPr>
+            <a:lvl2pPr marL="0" indent="0" algn="l" defTabSz="914400" rtl="0" eaLnBrk="1" latinLnBrk="0" hangingPunct="1">
+              <a:lnSpc>
+                <a:spcPct val="125000"/>
+              </a:lnSpc>
+              <a:spcBef>
+                <a:spcPts val="930"/>
+              </a:spcBef>
+              <a:spcAft>
+                <a:spcPts val="600"/>
+              </a:spcAft>
+              <a:buFont typeface="Corbel" panose="020B0503020204020204" pitchFamily="34" charset="0"/>
+              <a:buNone/>
+              <a:defRPr sz="1800" kern="1200" spc="150" baseline="0">
+                <a:solidFill>
+                  <a:schemeClr val="tx1">
+                    <a:lumMod val="75000"/>
+                    <a:lumOff val="25000"/>
+                  </a:schemeClr>
+                </a:solidFill>
+                <a:latin typeface="+mn-lt"/>
+                <a:ea typeface="+mn-ea"/>
+                <a:cs typeface="+mn-cs"/>
+              </a:defRPr>
+            </a:lvl2pPr>
+            <a:lvl3pPr marL="0" indent="-320040" algn="l" defTabSz="914400" rtl="0" eaLnBrk="1" latinLnBrk="0" hangingPunct="1">
+              <a:lnSpc>
+                <a:spcPct val="125000"/>
+              </a:lnSpc>
+              <a:spcBef>
+                <a:spcPts val="930"/>
+              </a:spcBef>
+              <a:spcAft>
+                <a:spcPts val="600"/>
+              </a:spcAft>
+              <a:buFont typeface="Corbel" panose="020B0503020204020204" pitchFamily="34" charset="0"/>
+              <a:buChar char="–"/>
+              <a:defRPr sz="1800" i="1" kern="1200" spc="150" baseline="0">
+                <a:solidFill>
+                  <a:schemeClr val="tx1">
+                    <a:lumMod val="75000"/>
+                    <a:lumOff val="25000"/>
+                  </a:schemeClr>
+                </a:solidFill>
+                <a:latin typeface="+mn-lt"/>
+                <a:ea typeface="+mn-ea"/>
+                <a:cs typeface="+mn-cs"/>
+              </a:defRPr>
+            </a:lvl3pPr>
+            <a:lvl4pPr marL="0" indent="-320040" algn="l" defTabSz="914400" rtl="0" eaLnBrk="1" latinLnBrk="0" hangingPunct="1">
+              <a:lnSpc>
+                <a:spcPct val="125000"/>
+              </a:lnSpc>
+              <a:spcBef>
+                <a:spcPts val="930"/>
+              </a:spcBef>
+              <a:spcAft>
+                <a:spcPts val="600"/>
+              </a:spcAft>
+              <a:buFont typeface="Corbel" panose="020B0503020204020204" pitchFamily="34" charset="0"/>
+              <a:buChar char="–"/>
+              <a:defRPr sz="1800" kern="1200" spc="150" baseline="0">
+                <a:solidFill>
+                  <a:schemeClr val="tx1">
+                    <a:lumMod val="75000"/>
+                    <a:lumOff val="25000"/>
+                  </a:schemeClr>
+                </a:solidFill>
+                <a:latin typeface="+mn-lt"/>
+                <a:ea typeface="+mn-ea"/>
+                <a:cs typeface="+mn-cs"/>
+              </a:defRPr>
+            </a:lvl4pPr>
+            <a:lvl5pPr marL="0" indent="-320040" algn="l" defTabSz="914400" rtl="0" eaLnBrk="1" latinLnBrk="0" hangingPunct="1">
+              <a:lnSpc>
+                <a:spcPct val="125000"/>
+              </a:lnSpc>
+              <a:spcBef>
+                <a:spcPts val="930"/>
+              </a:spcBef>
+              <a:spcAft>
+                <a:spcPts val="600"/>
+              </a:spcAft>
+              <a:buFont typeface="Corbel" panose="020B0503020204020204" pitchFamily="34" charset="0"/>
+              <a:buChar char="–"/>
+              <a:defRPr sz="1800" i="1" kern="1200" spc="150" baseline="0">
+                <a:solidFill>
+                  <a:schemeClr val="tx1">
+                    <a:lumMod val="75000"/>
+                    <a:lumOff val="25000"/>
+                  </a:schemeClr>
+                </a:solidFill>
+                <a:latin typeface="+mn-lt"/>
+                <a:ea typeface="+mn-ea"/>
+                <a:cs typeface="+mn-cs"/>
+              </a:defRPr>
+            </a:lvl5pPr>
+            <a:lvl6pPr marL="1920240" indent="-320040" algn="l" defTabSz="914400" rtl="0" eaLnBrk="1" latinLnBrk="0" hangingPunct="1">
+              <a:lnSpc>
+                <a:spcPct val="111000"/>
+              </a:lnSpc>
+              <a:spcBef>
+                <a:spcPts val="930"/>
+              </a:spcBef>
+              <a:buFont typeface="Corbel" panose="020B0503020204020204" pitchFamily="34" charset="0"/>
+              <a:buChar char="–"/>
+              <a:defRPr sz="1400" kern="1200">
+                <a:solidFill>
+                  <a:schemeClr val="accent1">
+                    <a:lumMod val="75000"/>
+                  </a:schemeClr>
+                </a:solidFill>
+                <a:latin typeface="+mn-lt"/>
+                <a:ea typeface="+mn-ea"/>
+                <a:cs typeface="+mn-cs"/>
+              </a:defRPr>
+            </a:lvl6pPr>
+            <a:lvl7pPr marL="2240280" indent="-320040" algn="l" defTabSz="914400" rtl="0" eaLnBrk="1" latinLnBrk="0" hangingPunct="1">
+              <a:lnSpc>
+                <a:spcPct val="111000"/>
+              </a:lnSpc>
+              <a:spcBef>
+                <a:spcPts val="930"/>
+              </a:spcBef>
+              <a:buFont typeface="Corbel" panose="020B0503020204020204" pitchFamily="34" charset="0"/>
+              <a:buChar char="–"/>
+              <a:defRPr sz="1400" i="1" kern="1200">
+                <a:solidFill>
+                  <a:schemeClr val="accent1">
+                    <a:lumMod val="75000"/>
+                  </a:schemeClr>
+                </a:solidFill>
+                <a:latin typeface="+mn-lt"/>
+                <a:ea typeface="+mn-ea"/>
+                <a:cs typeface="+mn-cs"/>
+              </a:defRPr>
+            </a:lvl7pPr>
+            <a:lvl8pPr marL="2560320" indent="-320040" algn="l" defTabSz="914400" rtl="0" eaLnBrk="1" latinLnBrk="0" hangingPunct="1">
+              <a:lnSpc>
+                <a:spcPct val="111000"/>
+              </a:lnSpc>
+              <a:spcBef>
+                <a:spcPts val="930"/>
+              </a:spcBef>
+              <a:buFont typeface="Corbel" panose="020B0503020204020204" pitchFamily="34" charset="0"/>
+              <a:buChar char="–"/>
+              <a:defRPr sz="1400" kern="1200">
+                <a:solidFill>
+                  <a:schemeClr val="accent1">
+                    <a:lumMod val="75000"/>
+                  </a:schemeClr>
+                </a:solidFill>
+                <a:latin typeface="+mn-lt"/>
+                <a:ea typeface="+mn-ea"/>
+                <a:cs typeface="+mn-cs"/>
+              </a:defRPr>
+            </a:lvl8pPr>
+            <a:lvl9pPr marL="2880360" indent="-320040" algn="l" defTabSz="914400" rtl="0" eaLnBrk="1" latinLnBrk="0" hangingPunct="1">
+              <a:lnSpc>
+                <a:spcPct val="111000"/>
+              </a:lnSpc>
+              <a:spcBef>
+                <a:spcPts val="930"/>
+              </a:spcBef>
+              <a:buFont typeface="Corbel" panose="020B0503020204020204" pitchFamily="34" charset="0"/>
+              <a:buChar char="–"/>
+              <a:defRPr sz="1400" i="1" kern="1200">
+                <a:solidFill>
+                  <a:schemeClr val="accent1">
+                    <a:lumMod val="75000"/>
+                  </a:schemeClr>
+                </a:solidFill>
+                <a:latin typeface="+mn-lt"/>
+                <a:ea typeface="+mn-ea"/>
+                <a:cs typeface="+mn-cs"/>
+              </a:defRPr>
+            </a:lvl9pPr>
+          </a:lstStyle>
+          <a:p>
+            <a:pPr>
+              <a:buFont typeface="Meiryo" panose="020B0604030504040204" pitchFamily="34" charset="-128"/>
+              <a:buChar char="←"/>
+            </a:pPr>
+            <a:r>
+              <a:rPr lang="en-US" dirty="0"/>
+              <a:t>Model Selection</a:t>
+            </a:r>
           </a:p>
         </p:txBody>
       </p:sp>
@@ -16130,40 +16910,259 @@
           <a:p>
             <a:r>
               <a:rPr lang="en-US" dirty="0"/>
-              <a:t>3 Steps</a:t>
-            </a:r>
-          </a:p>
-        </p:txBody>
-      </p:sp>
-      <p:pic>
-        <p:nvPicPr>
-          <p:cNvPr id="5" name="Picture Placeholder 4" descr="People in the middle of a circular room ">
-            <a:extLst>
-              <a:ext uri="{FF2B5EF4-FFF2-40B4-BE49-F238E27FC236}">
-                <a16:creationId xmlns:a16="http://schemas.microsoft.com/office/drawing/2014/main" id="{0CEB905B-7FDD-4B1A-96BF-B5A081A25FC8}"/>
-              </a:ext>
-            </a:extLst>
-          </p:cNvPr>
-          <p:cNvPicPr>
-            <a:picLocks noGrp="1" noChangeAspect="1"/>
-          </p:cNvPicPr>
-          <p:nvPr>
-            <p:ph type="pic" sz="quarter" idx="13"/>
-          </p:nvPr>
-        </p:nvPicPr>
-        <p:blipFill rotWithShape="1">
-          <a:blip r:embed="rId3" cstate="screen">
-            <a:extLst>
-              <a:ext uri="{28A0092B-C50C-407E-A947-70E740481C1C}">
-                <a14:useLocalDpi xmlns:a14="http://schemas.microsoft.com/office/drawing/2010/main"/>
-              </a:ext>
-            </a:extLst>
-          </a:blip>
-          <a:srcRect l="7618" r="7618"/>
-          <a:stretch/>
-        </p:blipFill>
-        <p:spPr/>
-      </p:pic>
+              <a:t>5 Steps</a:t>
+            </a:r>
+          </a:p>
+        </p:txBody>
+      </p:sp>
+      <p:graphicFrame>
+        <p:nvGraphicFramePr>
+          <p:cNvPr id="4" name="Table 3">
+            <a:extLst>
+              <a:ext uri="{FF2B5EF4-FFF2-40B4-BE49-F238E27FC236}">
+                <a16:creationId xmlns:a16="http://schemas.microsoft.com/office/drawing/2014/main" id="{2706946E-EE62-D8E0-3C3B-F9679B567160}"/>
+              </a:ext>
+            </a:extLst>
+          </p:cNvPr>
+          <p:cNvGraphicFramePr>
+            <a:graphicFrameLocks noGrp="1"/>
+          </p:cNvGraphicFramePr>
+          <p:nvPr>
+            <p:extLst>
+              <p:ext uri="{D42A27DB-BD31-4B8C-83A1-F6EECF244321}">
+                <p14:modId xmlns:p14="http://schemas.microsoft.com/office/powerpoint/2010/main" val="2327435546"/>
+              </p:ext>
+            </p:extLst>
+          </p:nvPr>
+        </p:nvGraphicFramePr>
+        <p:xfrm>
+          <a:off x="175768" y="1316735"/>
+          <a:ext cx="5920232" cy="4568562"/>
+        </p:xfrm>
+        <a:graphic>
+          <a:graphicData uri="http://schemas.openxmlformats.org/drawingml/2006/table">
+            <a:tbl>
+              <a:tblPr firstRow="1" bandRow="1">
+                <a:tableStyleId>{8A107856-5554-42FB-B03E-39F5DBC370BA}</a:tableStyleId>
+              </a:tblPr>
+              <a:tblGrid>
+                <a:gridCol w="1787722">
+                  <a:extLst>
+                    <a:ext uri="{9D8B030D-6E8A-4147-A177-3AD203B41FA5}">
+                      <a16:colId xmlns:a16="http://schemas.microsoft.com/office/drawing/2014/main" val="4205044115"/>
+                    </a:ext>
+                  </a:extLst>
+                </a:gridCol>
+                <a:gridCol w="4132510">
+                  <a:extLst>
+                    <a:ext uri="{9D8B030D-6E8A-4147-A177-3AD203B41FA5}">
+                      <a16:colId xmlns:a16="http://schemas.microsoft.com/office/drawing/2014/main" val="11685251"/>
+                    </a:ext>
+                  </a:extLst>
+                </a:gridCol>
+              </a:tblGrid>
+              <a:tr h="385426">
+                <a:tc>
+                  <a:txBody>
+                    <a:bodyPr/>
+                    <a:lstStyle/>
+                    <a:p>
+                      <a:r>
+                        <a:rPr lang="en-US" dirty="0"/>
+                        <a:t>Step</a:t>
+                      </a:r>
+                    </a:p>
+                  </a:txBody>
+                  <a:tcPr/>
+                </a:tc>
+                <a:tc>
+                  <a:txBody>
+                    <a:bodyPr/>
+                    <a:lstStyle/>
+                    <a:p>
+                      <a:r>
+                        <a:rPr lang="en-US" dirty="0"/>
+                        <a:t>Method</a:t>
+                      </a:r>
+                    </a:p>
+                  </a:txBody>
+                  <a:tcPr/>
+                </a:tc>
+                <a:extLst>
+                  <a:ext uri="{0D108BD9-81ED-4DB2-BD59-A6C34878D82A}">
+                    <a16:rowId xmlns:a16="http://schemas.microsoft.com/office/drawing/2014/main" val="2277524220"/>
+                  </a:ext>
+                </a:extLst>
+              </a:tr>
+              <a:tr h="963562">
+                <a:tc>
+                  <a:txBody>
+                    <a:bodyPr/>
+                    <a:lstStyle/>
+                    <a:p>
+                      <a:r>
+                        <a:rPr lang="en-US" dirty="0"/>
+                        <a:t>1: Initial Cleanup</a:t>
+                      </a:r>
+                    </a:p>
+                  </a:txBody>
+                  <a:tcPr/>
+                </a:tc>
+                <a:tc>
+                  <a:txBody>
+                    <a:bodyPr/>
+                    <a:lstStyle/>
+                    <a:p>
+                      <a:r>
+                        <a:rPr lang="en-US" dirty="0"/>
+                        <a:t>Dropping columns with no predictive power or high redundancy</a:t>
+                      </a:r>
+                    </a:p>
+                  </a:txBody>
+                  <a:tcPr/>
+                </a:tc>
+                <a:extLst>
+                  <a:ext uri="{0D108BD9-81ED-4DB2-BD59-A6C34878D82A}">
+                    <a16:rowId xmlns:a16="http://schemas.microsoft.com/office/drawing/2014/main" val="708125428"/>
+                  </a:ext>
+                </a:extLst>
+              </a:tr>
+              <a:tr h="752004">
+                <a:tc>
+                  <a:txBody>
+                    <a:bodyPr/>
+                    <a:lstStyle/>
+                    <a:p>
+                      <a:r>
+                        <a:rPr lang="en-US" dirty="0"/>
+                        <a:t>2: Handling Missing Data</a:t>
+                      </a:r>
+                    </a:p>
+                  </a:txBody>
+                  <a:tcPr/>
+                </a:tc>
+                <a:tc>
+                  <a:txBody>
+                    <a:bodyPr/>
+                    <a:lstStyle/>
+                    <a:p>
+                      <a:r>
+                        <a:rPr lang="en-US" dirty="0"/>
+                        <a:t>Dropped columns with 80% null and rows with 25% null</a:t>
+                      </a:r>
+                    </a:p>
+                  </a:txBody>
+                  <a:tcPr/>
+                </a:tc>
+                <a:extLst>
+                  <a:ext uri="{0D108BD9-81ED-4DB2-BD59-A6C34878D82A}">
+                    <a16:rowId xmlns:a16="http://schemas.microsoft.com/office/drawing/2014/main" val="3998859164"/>
+                  </a:ext>
+                </a:extLst>
+              </a:tr>
+              <a:tr h="752004">
+                <a:tc>
+                  <a:txBody>
+                    <a:bodyPr/>
+                    <a:lstStyle/>
+                    <a:p>
+                      <a:r>
+                        <a:rPr lang="en-US" dirty="0"/>
+                        <a:t>3: Remove Outliers</a:t>
+                      </a:r>
+                    </a:p>
+                  </a:txBody>
+                  <a:tcPr/>
+                </a:tc>
+                <a:tc>
+                  <a:txBody>
+                    <a:bodyPr/>
+                    <a:lstStyle/>
+                    <a:p>
+                      <a:r>
+                        <a:rPr lang="en-US" dirty="0"/>
+                        <a:t>Reduced the dataset by 20% by trimming according to the IQR</a:t>
+                      </a:r>
+                    </a:p>
+                  </a:txBody>
+                  <a:tcPr/>
+                </a:tc>
+                <a:extLst>
+                  <a:ext uri="{0D108BD9-81ED-4DB2-BD59-A6C34878D82A}">
+                    <a16:rowId xmlns:a16="http://schemas.microsoft.com/office/drawing/2014/main" val="3691632123"/>
+                  </a:ext>
+                </a:extLst>
+              </a:tr>
+              <a:tr h="963562">
+                <a:tc>
+                  <a:txBody>
+                    <a:bodyPr/>
+                    <a:lstStyle/>
+                    <a:p>
+                      <a:r>
+                        <a:rPr lang="en-US" dirty="0"/>
+                        <a:t>4: Imputation</a:t>
+                      </a:r>
+                    </a:p>
+                  </a:txBody>
+                  <a:tcPr/>
+                </a:tc>
+                <a:tc>
+                  <a:txBody>
+                    <a:bodyPr/>
+                    <a:lstStyle/>
+                    <a:p>
+                      <a:r>
+                        <a:rPr lang="en-US" dirty="0"/>
+                        <a:t>Median fill for numeric columns and most common value for categorical</a:t>
+                      </a:r>
+                    </a:p>
+                  </a:txBody>
+                  <a:tcPr/>
+                </a:tc>
+                <a:extLst>
+                  <a:ext uri="{0D108BD9-81ED-4DB2-BD59-A6C34878D82A}">
+                    <a16:rowId xmlns:a16="http://schemas.microsoft.com/office/drawing/2014/main" val="4071917344"/>
+                  </a:ext>
+                </a:extLst>
+              </a:tr>
+              <a:tr h="752004">
+                <a:tc>
+                  <a:txBody>
+                    <a:bodyPr/>
+                    <a:lstStyle/>
+                    <a:p>
+                      <a:r>
+                        <a:rPr lang="en-US" dirty="0"/>
+                        <a:t>5: Final</a:t>
+                      </a:r>
+                    </a:p>
+                  </a:txBody>
+                  <a:tcPr/>
+                </a:tc>
+                <a:tc>
+                  <a:txBody>
+                    <a:bodyPr/>
+                    <a:lstStyle/>
+                    <a:p>
+                      <a:r>
+                        <a:rPr lang="en-US" dirty="0"/>
+                        <a:t>One-Hot Encoding, Rounding count columns, and X/y split</a:t>
+                      </a:r>
+                    </a:p>
+                  </a:txBody>
+                  <a:tcPr/>
+                </a:tc>
+                <a:extLst>
+                  <a:ext uri="{0D108BD9-81ED-4DB2-BD59-A6C34878D82A}">
+                    <a16:rowId xmlns:a16="http://schemas.microsoft.com/office/drawing/2014/main" val="578624340"/>
+                  </a:ext>
+                </a:extLst>
+              </a:tr>
+            </a:tbl>
+          </a:graphicData>
+        </a:graphic>
+      </p:graphicFrame>
     </p:spTree>
     <p:extLst>
       <p:ext uri="{BB962C8B-B14F-4D97-AF65-F5344CB8AC3E}">
@@ -16210,7 +17209,12 @@
             <p:ph type="title"/>
           </p:nvPr>
         </p:nvSpPr>
-        <p:spPr/>
+        <p:spPr>
+          <a:xfrm>
+            <a:off x="4506511" y="1393927"/>
+            <a:ext cx="7042570" cy="754914"/>
+          </a:xfrm>
+        </p:spPr>
         <p:txBody>
           <a:bodyPr/>
           <a:lstStyle/>
@@ -16238,55 +17242,175 @@
             <p:ph sz="quarter" idx="16"/>
           </p:nvPr>
         </p:nvSpPr>
-        <p:spPr/>
+        <p:spPr>
+          <a:xfrm>
+            <a:off x="4506741" y="2558485"/>
+            <a:ext cx="7042335" cy="3242929"/>
+          </a:xfrm>
+        </p:spPr>
         <p:txBody>
           <a:bodyPr>
-            <a:normAutofit/>
+            <a:normAutofit fontScale="92500"/>
           </a:bodyPr>
           <a:lstStyle/>
           <a:p>
             <a:r>
               <a:rPr lang="en-US" dirty="0"/>
-              <a:t>ASDGFASD</a:t>
-            </a:r>
-          </a:p>
-        </p:txBody>
-      </p:sp>
-      <p:sp>
-        <p:nvSpPr>
-          <p:cNvPr id="4" name="TextBox 3">
-            <a:extLst>
-              <a:ext uri="{FF2B5EF4-FFF2-40B4-BE49-F238E27FC236}">
-                <a16:creationId xmlns:a16="http://schemas.microsoft.com/office/drawing/2014/main" id="{54F62501-32BB-9A93-A8EB-6D8E25DFA66B}"/>
-              </a:ext>
-            </a:extLst>
-          </p:cNvPr>
-          <p:cNvSpPr txBox="1"/>
+              <a:t>Bed-to-Bath Ratio: </a:t>
+            </a:r>
+            <a:r>
+              <a:rPr lang="en-US" dirty="0" err="1"/>
+              <a:t>bedroomcnt</a:t>
+            </a:r>
+            <a:r>
+              <a:rPr lang="en-US" dirty="0"/>
+              <a:t> / (</a:t>
+            </a:r>
+            <a:r>
+              <a:rPr lang="en-US" dirty="0" err="1"/>
+              <a:t>bathroomcnt</a:t>
+            </a:r>
+            <a:r>
+              <a:rPr lang="en-US" dirty="0"/>
+              <a:t> + 1) </a:t>
+            </a:r>
+          </a:p>
+          <a:p>
+            <a:r>
+              <a:rPr lang="en-US" dirty="0"/>
+              <a:t>Bed-to-Bath Product: </a:t>
+            </a:r>
+            <a:r>
+              <a:rPr lang="en-US" dirty="0" err="1"/>
+              <a:t>bathroomcnt</a:t>
+            </a:r>
+            <a:r>
+              <a:rPr lang="en-US" dirty="0"/>
+              <a:t> * </a:t>
+            </a:r>
+            <a:r>
+              <a:rPr lang="en-US" dirty="0" err="1"/>
+              <a:t>bedroomcnt</a:t>
+            </a:r>
+            <a:endParaRPr lang="en-US" dirty="0"/>
+          </a:p>
+          <a:p>
+            <a:r>
+              <a:rPr lang="en-US" dirty="0"/>
+              <a:t>Age Feature: Formula: 2025 - </a:t>
+            </a:r>
+            <a:r>
+              <a:rPr lang="en-US" dirty="0" err="1"/>
+              <a:t>yearbuilt</a:t>
+            </a:r>
+            <a:endParaRPr lang="en-US" dirty="0"/>
+          </a:p>
+          <a:p>
+            <a:r>
+              <a:rPr lang="en-US" dirty="0"/>
+              <a:t>Polynomial Features: Squares of various features to increase their variance on the higher end</a:t>
+            </a:r>
+          </a:p>
+          <a:p>
+            <a:r>
+              <a:rPr lang="en-US" dirty="0"/>
+              <a:t>Log Transformations: Logarithms to eliminate right-skewed features’ effects</a:t>
+            </a:r>
+          </a:p>
+        </p:txBody>
+      </p:sp>
+      <p:pic>
+        <p:nvPicPr>
+          <p:cNvPr id="1028" name="Picture 4" descr="Graphs of Second Degree Polynomials">
+            <a:extLst>
+              <a:ext uri="{FF2B5EF4-FFF2-40B4-BE49-F238E27FC236}">
+                <a16:creationId xmlns:a16="http://schemas.microsoft.com/office/drawing/2014/main" id="{ADE774DC-F809-C837-B338-2D0B196E056E}"/>
+              </a:ext>
+            </a:extLst>
+          </p:cNvPr>
+          <p:cNvPicPr>
+            <a:picLocks noChangeAspect="1" noChangeArrowheads="1"/>
+          </p:cNvPicPr>
           <p:nvPr/>
-        </p:nvSpPr>
-        <p:spPr>
-          <a:xfrm>
-            <a:off x="707919" y="2558486"/>
-            <a:ext cx="1892808" cy="923330"/>
+        </p:nvPicPr>
+        <p:blipFill>
+          <a:blip r:embed="rId3">
+            <a:extLst>
+              <a:ext uri="{28A0092B-C50C-407E-A947-70E740481C1C}">
+                <a14:useLocalDpi xmlns:a14="http://schemas.microsoft.com/office/drawing/2010/main" val="0"/>
+              </a:ext>
+            </a:extLst>
+          </a:blip>
+          <a:srcRect/>
+          <a:stretch>
+            <a:fillRect/>
+          </a:stretch>
+        </p:blipFill>
+        <p:spPr bwMode="auto">
+          <a:xfrm>
+            <a:off x="1064762" y="3879056"/>
+            <a:ext cx="1517655" cy="1795463"/>
           </a:xfrm>
           <a:prstGeom prst="rect">
             <a:avLst/>
           </a:prstGeom>
           <a:noFill/>
-        </p:spPr>
-        <p:txBody>
-          <a:bodyPr wrap="square" rtlCol="0">
-            <a:spAutoFit/>
-          </a:bodyPr>
-          <a:lstStyle/>
-          <a:p>
-            <a:r>
-              <a:rPr lang="en-US" dirty="0"/>
-              <a:t>Potentially flow chart of steps here</a:t>
-            </a:r>
-          </a:p>
-        </p:txBody>
-      </p:sp>
+          <a:extLst>
+            <a:ext uri="{909E8E84-426E-40DD-AFC4-6F175D3DCCD1}">
+              <a14:hiddenFill xmlns:a14="http://schemas.microsoft.com/office/drawing/2010/main">
+                <a:solidFill>
+                  <a:srgbClr val="FFFFFF"/>
+                </a:solidFill>
+              </a14:hiddenFill>
+            </a:ext>
+          </a:extLst>
+        </p:spPr>
+      </p:pic>
+      <p:pic>
+        <p:nvPicPr>
+          <p:cNvPr id="1030" name="Picture 6" descr="Logarithm Graph Investigation – GeoGebra">
+            <a:extLst>
+              <a:ext uri="{FF2B5EF4-FFF2-40B4-BE49-F238E27FC236}">
+                <a16:creationId xmlns:a16="http://schemas.microsoft.com/office/drawing/2014/main" id="{38103DF0-206F-8E74-5EB6-AF75E12DB0E4}"/>
+              </a:ext>
+            </a:extLst>
+          </p:cNvPr>
+          <p:cNvPicPr>
+            <a:picLocks noChangeAspect="1" noChangeArrowheads="1"/>
+          </p:cNvPicPr>
+          <p:nvPr/>
+        </p:nvPicPr>
+        <p:blipFill rotWithShape="1">
+          <a:blip r:embed="rId4">
+            <a:extLst>
+              <a:ext uri="{28A0092B-C50C-407E-A947-70E740481C1C}">
+                <a14:useLocalDpi xmlns:a14="http://schemas.microsoft.com/office/drawing/2010/main" val="0"/>
+              </a:ext>
+            </a:extLst>
+          </a:blip>
+          <a:srcRect l="32500" r="24609"/>
+          <a:stretch/>
+        </p:blipFill>
+        <p:spPr bwMode="auto">
+          <a:xfrm>
+            <a:off x="642919" y="1195387"/>
+            <a:ext cx="2361343" cy="2493963"/>
+          </a:xfrm>
+          <a:prstGeom prst="rect">
+            <a:avLst/>
+          </a:prstGeom>
+          <a:noFill/>
+          <a:extLst>
+            <a:ext uri="{909E8E84-426E-40DD-AFC4-6F175D3DCCD1}">
+              <a14:hiddenFill xmlns:a14="http://schemas.microsoft.com/office/drawing/2010/main">
+                <a:solidFill>
+                  <a:srgbClr val="FFFFFF"/>
+                </a:solidFill>
+              </a14:hiddenFill>
+            </a:ext>
+          </a:extLst>
+        </p:spPr>
+      </p:pic>
     </p:spTree>
     <p:extLst>
       <p:ext uri="{BB962C8B-B14F-4D97-AF65-F5344CB8AC3E}">
@@ -17532,6 +18656,15 @@
 </file>
 
 <file path=customXml/item1.xml><?xml version="1.0" encoding="utf-8"?>
+<?mso-contentType ?>
+<FormTemplates xmlns="http://schemas.microsoft.com/sharepoint/v3/contenttype/forms">
+  <Display>DocumentLibraryForm</Display>
+  <Edit>DocumentLibraryForm</Edit>
+  <New>DocumentLibraryForm</New>
+</FormTemplates>
+</file>
+
+<file path=customXml/item2.xml><?xml version="1.0" encoding="utf-8"?>
 <p:properties xmlns:p="http://schemas.microsoft.com/office/2006/metadata/properties" xmlns:xsi="http://www.w3.org/2001/XMLSchema-instance" xmlns:pc="http://schemas.microsoft.com/office/infopath/2007/PartnerControls">
   <documentManagement>
     <_ip_UnifiedCompliancePolicyUIAction xmlns="http://schemas.microsoft.com/sharepoint/v3" xsi:nil="true"/>
@@ -17549,15 +18682,6 @@
     <MediaServiceKeyPoints xmlns="71af3243-3dd4-4a8d-8c0d-dd76da1f02a5" xsi:nil="true"/>
   </documentManagement>
 </p:properties>
-</file>
-
-<file path=customXml/item2.xml><?xml version="1.0" encoding="utf-8"?>
-<?mso-contentType ?>
-<FormTemplates xmlns="http://schemas.microsoft.com/sharepoint/v3/contenttype/forms">
-  <Display>DocumentLibraryForm</Display>
-  <Edit>DocumentLibraryForm</Edit>
-  <New>DocumentLibraryForm</New>
-</FormTemplates>
 </file>
 
 <file path=customXml/item3.xml><?xml version="1.0" encoding="utf-8"?>
@@ -17873,6 +18997,14 @@
 </file>
 
 <file path=customXml/itemProps1.xml><?xml version="1.0" encoding="utf-8"?>
+<ds:datastoreItem xmlns:ds="http://schemas.openxmlformats.org/officeDocument/2006/customXml" ds:itemID="{6F36CB81-A037-44A8-88EB-C0C0F17FD4B1}">
+  <ds:schemaRefs>
+    <ds:schemaRef ds:uri="http://schemas.microsoft.com/sharepoint/v3/contenttype/forms"/>
+  </ds:schemaRefs>
+</ds:datastoreItem>
+</file>
+
+<file path=customXml/itemProps2.xml><?xml version="1.0" encoding="utf-8"?>
 <ds:datastoreItem xmlns:ds="http://schemas.openxmlformats.org/officeDocument/2006/customXml" ds:itemID="{57FF477C-132F-44F8-8C56-EBFF95FAF97B}">
   <ds:schemaRefs>
     <ds:schemaRef ds:uri="http://schemas.microsoft.com/office/2006/metadata/properties"/>
@@ -17880,14 +19012,6 @@
     <ds:schemaRef ds:uri="http://schemas.microsoft.com/sharepoint/v3"/>
     <ds:schemaRef ds:uri="71af3243-3dd4-4a8d-8c0d-dd76da1f02a5"/>
     <ds:schemaRef ds:uri="230e9df3-be65-4c73-a93b-d1236ebd677e"/>
-  </ds:schemaRefs>
-</ds:datastoreItem>
-</file>
-
-<file path=customXml/itemProps2.xml><?xml version="1.0" encoding="utf-8"?>
-<ds:datastoreItem xmlns:ds="http://schemas.openxmlformats.org/officeDocument/2006/customXml" ds:itemID="{6F36CB81-A037-44A8-88EB-C0C0F17FD4B1}">
-  <ds:schemaRefs>
-    <ds:schemaRef ds:uri="http://schemas.microsoft.com/sharepoint/v3/contenttype/forms"/>
   </ds:schemaRefs>
 </ds:datastoreItem>
 </file>

</xml_diff>

<commit_message>
Pres Complete - Matt
</commit_message>
<xml_diff>
--- a/presentation.pptx
+++ b/presentation.pptx
@@ -5,10 +5,10 @@
     <p:sldMasterId id="2147483686" r:id="rId4"/>
   </p:sldMasterIdLst>
   <p:notesMasterIdLst>
-    <p:notesMasterId r:id="rId17"/>
+    <p:notesMasterId r:id="rId19"/>
   </p:notesMasterIdLst>
   <p:handoutMasterIdLst>
-    <p:handoutMasterId r:id="rId18"/>
+    <p:handoutMasterId r:id="rId20"/>
   </p:handoutMasterIdLst>
   <p:sldIdLst>
     <p:sldId id="315" r:id="rId5"/>
@@ -19,10 +19,12 @@
     <p:sldId id="305" r:id="rId10"/>
     <p:sldId id="271" r:id="rId11"/>
     <p:sldId id="310" r:id="rId12"/>
-    <p:sldId id="316" r:id="rId13"/>
-    <p:sldId id="313" r:id="rId14"/>
-    <p:sldId id="300" r:id="rId15"/>
-    <p:sldId id="295" r:id="rId16"/>
+    <p:sldId id="317" r:id="rId13"/>
+    <p:sldId id="316" r:id="rId14"/>
+    <p:sldId id="313" r:id="rId15"/>
+    <p:sldId id="318" r:id="rId16"/>
+    <p:sldId id="319" r:id="rId17"/>
+    <p:sldId id="295" r:id="rId18"/>
   </p:sldIdLst>
   <p:sldSz cx="12192000" cy="6858000"/>
   <p:notesSz cx="6858000" cy="9144000"/>
@@ -134,9 +136,11 @@
             <p14:sldId id="305"/>
             <p14:sldId id="271"/>
             <p14:sldId id="310"/>
+            <p14:sldId id="317"/>
             <p14:sldId id="316"/>
             <p14:sldId id="313"/>
-            <p14:sldId id="300"/>
+            <p14:sldId id="318"/>
+            <p14:sldId id="319"/>
             <p14:sldId id="295"/>
           </p14:sldIdLst>
         </p14:section>
@@ -846,7 +850,7 @@
           <a:p>
             <a:fld id="{54EEB602-95FC-483A-B12D-216A7AD7EA24}" type="slidenum">
               <a:rPr lang="en-US" smtClean="0"/>
-              <a:t>10</a:t>
+              <a:t>11</a:t>
             </a:fld>
             <a:endParaRPr lang="en-US" dirty="0"/>
           </a:p>
@@ -909,90 +913,6 @@
           <a:bodyPr/>
           <a:lstStyle/>
           <a:p>
-            <a:endParaRPr lang="en-US" dirty="0"/>
-          </a:p>
-        </p:txBody>
-      </p:sp>
-      <p:sp>
-        <p:nvSpPr>
-          <p:cNvPr id="4" name="Slide Number Placeholder 3"/>
-          <p:cNvSpPr>
-            <a:spLocks noGrp="1"/>
-          </p:cNvSpPr>
-          <p:nvPr>
-            <p:ph type="sldNum" sz="quarter" idx="5"/>
-          </p:nvPr>
-        </p:nvSpPr>
-        <p:spPr/>
-        <p:txBody>
-          <a:bodyPr/>
-          <a:lstStyle/>
-          <a:p>
-            <a:fld id="{54EEB602-95FC-483A-B12D-216A7AD7EA24}" type="slidenum">
-              <a:rPr lang="en-US" smtClean="0"/>
-              <a:t>11</a:t>
-            </a:fld>
-            <a:endParaRPr lang="en-US" dirty="0"/>
-          </a:p>
-        </p:txBody>
-      </p:sp>
-    </p:spTree>
-    <p:extLst>
-      <p:ext uri="{BB962C8B-B14F-4D97-AF65-F5344CB8AC3E}">
-        <p14:creationId xmlns:p14="http://schemas.microsoft.com/office/powerpoint/2010/main" val="2125366021"/>
-      </p:ext>
-    </p:extLst>
-  </p:cSld>
-  <p:clrMapOvr>
-    <a:masterClrMapping/>
-  </p:clrMapOvr>
-</p:notes>
-</file>
-
-<file path=ppt/notesSlides/notesSlide12.xml><?xml version="1.0" encoding="utf-8"?>
-<p:notes xmlns:a="http://schemas.openxmlformats.org/drawingml/2006/main" xmlns:r="http://schemas.openxmlformats.org/officeDocument/2006/relationships" xmlns:p="http://schemas.openxmlformats.org/presentationml/2006/main">
-  <p:cSld>
-    <p:spTree>
-      <p:nvGrpSpPr>
-        <p:cNvPr id="1" name=""/>
-        <p:cNvGrpSpPr/>
-        <p:nvPr/>
-      </p:nvGrpSpPr>
-      <p:grpSpPr>
-        <a:xfrm>
-          <a:off x="0" y="0"/>
-          <a:ext cx="0" cy="0"/>
-          <a:chOff x="0" y="0"/>
-          <a:chExt cx="0" cy="0"/>
-        </a:xfrm>
-      </p:grpSpPr>
-      <p:sp>
-        <p:nvSpPr>
-          <p:cNvPr id="2" name="Slide Image Placeholder 1"/>
-          <p:cNvSpPr>
-            <a:spLocks noGrp="1" noRot="1" noChangeAspect="1"/>
-          </p:cNvSpPr>
-          <p:nvPr>
-            <p:ph type="sldImg"/>
-          </p:nvPr>
-        </p:nvSpPr>
-        <p:spPr/>
-      </p:sp>
-      <p:sp>
-        <p:nvSpPr>
-          <p:cNvPr id="3" name="Notes Placeholder 2"/>
-          <p:cNvSpPr>
-            <a:spLocks noGrp="1"/>
-          </p:cNvSpPr>
-          <p:nvPr>
-            <p:ph type="body" idx="1"/>
-          </p:nvPr>
-        </p:nvSpPr>
-        <p:spPr/>
-        <p:txBody>
-          <a:bodyPr/>
-          <a:lstStyle/>
-          <a:p>
             <a:pPr marL="0" marR="0" lvl="0" indent="0" algn="l" defTabSz="914400" rtl="0" eaLnBrk="1" fontAlgn="auto" latinLnBrk="0" hangingPunct="1">
               <a:lnSpc>
                 <a:spcPct val="100000"/>
@@ -1031,7 +951,7 @@
           <a:p>
             <a:fld id="{F07F282E-55F5-4803-B60F-09BA4600E538}" type="slidenum">
               <a:rPr lang="en-US" smtClean="0"/>
-              <a:t>12</a:t>
+              <a:t>14</a:t>
             </a:fld>
             <a:endParaRPr lang="en-US" dirty="0"/>
           </a:p>
@@ -1737,7 +1657,7 @@
           <a:p>
             <a:fld id="{54EEB602-95FC-483A-B12D-216A7AD7EA24}" type="slidenum">
               <a:rPr lang="en-US" smtClean="0"/>
-              <a:t>9</a:t>
+              <a:t>10</a:t>
             </a:fld>
             <a:endParaRPr lang="en-US" dirty="0"/>
           </a:p>
@@ -8679,508 +8599,6 @@
 
 <file path=ppt/slideLayouts/slideLayout21.xml><?xml version="1.0" encoding="utf-8"?>
 <p:sldLayout xmlns:a="http://schemas.openxmlformats.org/drawingml/2006/main" xmlns:r="http://schemas.openxmlformats.org/officeDocument/2006/relationships" xmlns:p="http://schemas.openxmlformats.org/presentationml/2006/main" userDrawn="1">
-  <p:cSld name="Table">
-    <p:spTree>
-      <p:nvGrpSpPr>
-        <p:cNvPr id="1" name=""/>
-        <p:cNvGrpSpPr/>
-        <p:nvPr/>
-      </p:nvGrpSpPr>
-      <p:grpSpPr>
-        <a:xfrm>
-          <a:off x="0" y="0"/>
-          <a:ext cx="0" cy="0"/>
-          <a:chOff x="0" y="0"/>
-          <a:chExt cx="0" cy="0"/>
-        </a:xfrm>
-      </p:grpSpPr>
-      <p:sp useBgFill="1">
-        <p:nvSpPr>
-          <p:cNvPr id="6" name="Rectangle 5">
-            <a:extLst>
-              <a:ext uri="{FF2B5EF4-FFF2-40B4-BE49-F238E27FC236}">
-                <a16:creationId xmlns:a16="http://schemas.microsoft.com/office/drawing/2014/main" id="{2DF88512-9E62-4695-B350-39488566A1F7}"/>
-              </a:ext>
-              <a:ext uri="{C183D7F6-B498-43B3-948B-1728B52AA6E4}">
-                <adec:decorative xmlns:adec="http://schemas.microsoft.com/office/drawing/2017/decorative" val="1"/>
-              </a:ext>
-            </a:extLst>
-          </p:cNvPr>
-          <p:cNvSpPr/>
-          <p:nvPr userDrawn="1"/>
-        </p:nvSpPr>
-        <p:spPr>
-          <a:xfrm>
-            <a:off x="0" y="0"/>
-            <a:ext cx="12192001" cy="6858000"/>
-          </a:xfrm>
-          <a:prstGeom prst="rect">
-            <a:avLst/>
-          </a:prstGeom>
-          <a:ln>
-            <a:noFill/>
-          </a:ln>
-        </p:spPr>
-        <p:style>
-          <a:lnRef idx="2">
-            <a:schemeClr val="accent1">
-              <a:shade val="50000"/>
-            </a:schemeClr>
-          </a:lnRef>
-          <a:fillRef idx="1">
-            <a:schemeClr val="accent1"/>
-          </a:fillRef>
-          <a:effectRef idx="0">
-            <a:schemeClr val="accent1"/>
-          </a:effectRef>
-          <a:fontRef idx="minor">
-            <a:schemeClr val="lt1"/>
-          </a:fontRef>
-        </p:style>
-        <p:txBody>
-          <a:bodyPr rtlCol="0" anchor="ctr"/>
-          <a:lstStyle/>
-          <a:p>
-            <a:pPr algn="ctr"/>
-            <a:endParaRPr lang="en-US" dirty="0"/>
-          </a:p>
-        </p:txBody>
-      </p:sp>
-      <p:sp>
-        <p:nvSpPr>
-          <p:cNvPr id="7" name="Rectangle 6">
-            <a:extLst>
-              <a:ext uri="{FF2B5EF4-FFF2-40B4-BE49-F238E27FC236}">
-                <a16:creationId xmlns:a16="http://schemas.microsoft.com/office/drawing/2014/main" id="{18CD596D-95F4-4C5C-A0E7-86D747FE70BE}"/>
-              </a:ext>
-              <a:ext uri="{C183D7F6-B498-43B3-948B-1728B52AA6E4}">
-                <adec:decorative xmlns:adec="http://schemas.microsoft.com/office/drawing/2017/decorative" val="1"/>
-              </a:ext>
-            </a:extLst>
-          </p:cNvPr>
-          <p:cNvSpPr/>
-          <p:nvPr userDrawn="1"/>
-        </p:nvSpPr>
-        <p:spPr>
-          <a:xfrm>
-            <a:off x="1038768" y="2130218"/>
-            <a:ext cx="11153231" cy="4727782"/>
-          </a:xfrm>
-          <a:prstGeom prst="rect">
-            <a:avLst/>
-          </a:prstGeom>
-          <a:solidFill>
-            <a:schemeClr val="bg1">
-              <a:alpha val="75000"/>
-            </a:schemeClr>
-          </a:solidFill>
-          <a:ln>
-            <a:noFill/>
-          </a:ln>
-        </p:spPr>
-        <p:style>
-          <a:lnRef idx="2">
-            <a:schemeClr val="accent1">
-              <a:shade val="50000"/>
-            </a:schemeClr>
-          </a:lnRef>
-          <a:fillRef idx="1">
-            <a:schemeClr val="accent1"/>
-          </a:fillRef>
-          <a:effectRef idx="0">
-            <a:schemeClr val="accent1"/>
-          </a:effectRef>
-          <a:fontRef idx="minor">
-            <a:schemeClr val="lt1"/>
-          </a:fontRef>
-        </p:style>
-        <p:txBody>
-          <a:bodyPr rtlCol="0" anchor="ctr"/>
-          <a:lstStyle/>
-          <a:p>
-            <a:pPr algn="ctr"/>
-            <a:endParaRPr lang="en-US" dirty="0"/>
-          </a:p>
-        </p:txBody>
-      </p:sp>
-      <p:sp>
-        <p:nvSpPr>
-          <p:cNvPr id="8" name="Rectangle 7">
-            <a:extLst>
-              <a:ext uri="{FF2B5EF4-FFF2-40B4-BE49-F238E27FC236}">
-                <a16:creationId xmlns:a16="http://schemas.microsoft.com/office/drawing/2014/main" id="{67553E9F-DCBF-4BEE-A261-5AA97361A0E0}"/>
-              </a:ext>
-              <a:ext uri="{C183D7F6-B498-43B3-948B-1728B52AA6E4}">
-                <adec:decorative xmlns:adec="http://schemas.microsoft.com/office/drawing/2017/decorative" val="1"/>
-              </a:ext>
-            </a:extLst>
-          </p:cNvPr>
-          <p:cNvSpPr/>
-          <p:nvPr userDrawn="1"/>
-        </p:nvSpPr>
-        <p:spPr>
-          <a:xfrm>
-            <a:off x="0" y="896641"/>
-            <a:ext cx="12192000" cy="1347716"/>
-          </a:xfrm>
-          <a:prstGeom prst="rect">
-            <a:avLst/>
-          </a:prstGeom>
-          <a:solidFill>
-            <a:schemeClr val="tx2"/>
-          </a:solidFill>
-          <a:ln>
-            <a:noFill/>
-          </a:ln>
-        </p:spPr>
-        <p:style>
-          <a:lnRef idx="2">
-            <a:schemeClr val="accent1">
-              <a:shade val="50000"/>
-            </a:schemeClr>
-          </a:lnRef>
-          <a:fillRef idx="1">
-            <a:schemeClr val="accent1"/>
-          </a:fillRef>
-          <a:effectRef idx="0">
-            <a:schemeClr val="accent1"/>
-          </a:effectRef>
-          <a:fontRef idx="minor">
-            <a:schemeClr val="lt1"/>
-          </a:fontRef>
-        </p:style>
-        <p:txBody>
-          <a:bodyPr rtlCol="0" anchor="ctr"/>
-          <a:lstStyle/>
-          <a:p>
-            <a:pPr algn="ctr"/>
-            <a:endParaRPr lang="en-US" dirty="0"/>
-          </a:p>
-        </p:txBody>
-      </p:sp>
-      <p:sp>
-        <p:nvSpPr>
-          <p:cNvPr id="9" name="Title 1">
-            <a:extLst>
-              <a:ext uri="{FF2B5EF4-FFF2-40B4-BE49-F238E27FC236}">
-                <a16:creationId xmlns:a16="http://schemas.microsoft.com/office/drawing/2014/main" id="{949B0EB0-AEBA-44ED-BC77-4188C7486144}"/>
-              </a:ext>
-            </a:extLst>
-          </p:cNvPr>
-          <p:cNvSpPr>
-            <a:spLocks noGrp="1"/>
-          </p:cNvSpPr>
-          <p:nvPr>
-            <p:ph type="title" hasCustomPrompt="1"/>
-          </p:nvPr>
-        </p:nvSpPr>
-        <p:spPr>
-          <a:xfrm>
-            <a:off x="1535371" y="962423"/>
-            <a:ext cx="10013710" cy="1216152"/>
-          </a:xfrm>
-        </p:spPr>
-        <p:txBody>
-          <a:bodyPr tIns="182880" anchor="ctr" anchorCtr="0">
-            <a:noAutofit/>
-          </a:bodyPr>
-          <a:lstStyle>
-            <a:lvl1pPr>
-              <a:lnSpc>
-                <a:spcPct val="100000"/>
-              </a:lnSpc>
-              <a:defRPr sz="3200">
-                <a:solidFill>
-                  <a:schemeClr val="bg1"/>
-                </a:solidFill>
-              </a:defRPr>
-            </a:lvl1pPr>
-          </a:lstStyle>
-          <a:p>
-            <a:r>
-              <a:rPr lang="en-US" dirty="0">
-                <a:solidFill>
-                  <a:schemeClr val="bg1"/>
-                </a:solidFill>
-              </a:rPr>
-              <a:t>Click to add title</a:t>
-            </a:r>
-          </a:p>
-        </p:txBody>
-      </p:sp>
-      <p:sp>
-        <p:nvSpPr>
-          <p:cNvPr id="4" name="Table Placeholder 3">
-            <a:extLst>
-              <a:ext uri="{FF2B5EF4-FFF2-40B4-BE49-F238E27FC236}">
-                <a16:creationId xmlns:a16="http://schemas.microsoft.com/office/drawing/2014/main" id="{74D0E84D-2B51-9F8D-82CE-C086143DC605}"/>
-              </a:ext>
-            </a:extLst>
-          </p:cNvPr>
-          <p:cNvSpPr>
-            <a:spLocks noGrp="1"/>
-          </p:cNvSpPr>
-          <p:nvPr>
-            <p:ph type="tbl" sz="quarter" idx="14"/>
-          </p:nvPr>
-        </p:nvSpPr>
-        <p:spPr>
-          <a:xfrm>
-            <a:off x="1630363" y="2757951"/>
-            <a:ext cx="9918700" cy="3387579"/>
-          </a:xfrm>
-        </p:spPr>
-        <p:txBody>
-          <a:bodyPr anchor="t"/>
-          <a:lstStyle>
-            <a:lvl1pPr marL="0" indent="0" algn="ctr">
-              <a:buNone/>
-              <a:defRPr/>
-            </a:lvl1pPr>
-          </a:lstStyle>
-          <a:p>
-            <a:r>
-              <a:rPr lang="en-US"/>
-              <a:t>Click icon to add table</a:t>
-            </a:r>
-            <a:endParaRPr lang="en-US" dirty="0"/>
-          </a:p>
-        </p:txBody>
-      </p:sp>
-      <p:sp>
-        <p:nvSpPr>
-          <p:cNvPr id="10" name="Rectangle 9">
-            <a:extLst>
-              <a:ext uri="{FF2B5EF4-FFF2-40B4-BE49-F238E27FC236}">
-                <a16:creationId xmlns:a16="http://schemas.microsoft.com/office/drawing/2014/main" id="{7278DD10-67BC-4E87-A788-A45C6093F5F8}"/>
-              </a:ext>
-              <a:ext uri="{C183D7F6-B498-43B3-948B-1728B52AA6E4}">
-                <adec:decorative xmlns:adec="http://schemas.microsoft.com/office/drawing/2017/decorative" val="1"/>
-              </a:ext>
-            </a:extLst>
-          </p:cNvPr>
-          <p:cNvSpPr/>
-          <p:nvPr userDrawn="1"/>
-        </p:nvSpPr>
-        <p:spPr>
-          <a:xfrm>
-            <a:off x="-1" y="962423"/>
-            <a:ext cx="1006766" cy="1216152"/>
-          </a:xfrm>
-          <a:prstGeom prst="rect">
-            <a:avLst/>
-          </a:prstGeom>
-          <a:solidFill>
-            <a:schemeClr val="accent1"/>
-          </a:solidFill>
-          <a:ln>
-            <a:noFill/>
-          </a:ln>
-        </p:spPr>
-        <p:style>
-          <a:lnRef idx="2">
-            <a:schemeClr val="accent1">
-              <a:shade val="50000"/>
-            </a:schemeClr>
-          </a:lnRef>
-          <a:fillRef idx="1">
-            <a:schemeClr val="accent1"/>
-          </a:fillRef>
-          <a:effectRef idx="0">
-            <a:schemeClr val="accent1"/>
-          </a:effectRef>
-          <a:fontRef idx="minor">
-            <a:schemeClr val="lt1"/>
-          </a:fontRef>
-        </p:style>
-        <p:txBody>
-          <a:bodyPr rtlCol="0" anchor="ctr"/>
-          <a:lstStyle/>
-          <a:p>
-            <a:pPr algn="ctr"/>
-            <a:endParaRPr lang="en-US" dirty="0"/>
-          </a:p>
-        </p:txBody>
-      </p:sp>
-      <p:sp>
-        <p:nvSpPr>
-          <p:cNvPr id="11" name="Rectangle 10">
-            <a:extLst>
-              <a:ext uri="{FF2B5EF4-FFF2-40B4-BE49-F238E27FC236}">
-                <a16:creationId xmlns:a16="http://schemas.microsoft.com/office/drawing/2014/main" id="{916769F5-486B-4B48-A543-2C70359DF66E}"/>
-              </a:ext>
-              <a:ext uri="{C183D7F6-B498-43B3-948B-1728B52AA6E4}">
-                <adec:decorative xmlns:adec="http://schemas.microsoft.com/office/drawing/2017/decorative" val="1"/>
-              </a:ext>
-            </a:extLst>
-          </p:cNvPr>
-          <p:cNvSpPr/>
-          <p:nvPr userDrawn="1"/>
-        </p:nvSpPr>
-        <p:spPr>
-          <a:xfrm rot="5400000">
-            <a:off x="-2390232" y="3396997"/>
-            <a:ext cx="6858002" cy="64008"/>
-          </a:xfrm>
-          <a:prstGeom prst="rect">
-            <a:avLst/>
-          </a:prstGeom>
-          <a:solidFill>
-            <a:schemeClr val="tx2"/>
-          </a:solidFill>
-          <a:ln>
-            <a:noFill/>
-          </a:ln>
-        </p:spPr>
-        <p:style>
-          <a:lnRef idx="2">
-            <a:schemeClr val="accent1">
-              <a:shade val="50000"/>
-            </a:schemeClr>
-          </a:lnRef>
-          <a:fillRef idx="1">
-            <a:schemeClr val="accent1"/>
-          </a:fillRef>
-          <a:effectRef idx="0">
-            <a:schemeClr val="accent1"/>
-          </a:effectRef>
-          <a:fontRef idx="minor">
-            <a:schemeClr val="lt1"/>
-          </a:fontRef>
-        </p:style>
-        <p:txBody>
-          <a:bodyPr rtlCol="0" anchor="ctr"/>
-          <a:lstStyle/>
-          <a:p>
-            <a:pPr algn="ctr"/>
-            <a:endParaRPr lang="en-US" dirty="0"/>
-          </a:p>
-        </p:txBody>
-      </p:sp>
-      <p:sp>
-        <p:nvSpPr>
-          <p:cNvPr id="15" name="Footer Placeholder 4">
-            <a:extLst>
-              <a:ext uri="{FF2B5EF4-FFF2-40B4-BE49-F238E27FC236}">
-                <a16:creationId xmlns:a16="http://schemas.microsoft.com/office/drawing/2014/main" id="{0DB9557B-D9D3-4FA9-2D64-D2F91957D2FC}"/>
-              </a:ext>
-            </a:extLst>
-          </p:cNvPr>
-          <p:cNvSpPr>
-            <a:spLocks noGrp="1"/>
-          </p:cNvSpPr>
-          <p:nvPr>
-            <p:ph type="ftr" sz="quarter" idx="11"/>
-          </p:nvPr>
-        </p:nvSpPr>
-        <p:spPr>
-          <a:xfrm>
-            <a:off x="1535372" y="6309360"/>
-            <a:ext cx="4946592" cy="457200"/>
-          </a:xfrm>
-        </p:spPr>
-        <p:txBody>
-          <a:bodyPr/>
-          <a:lstStyle/>
-          <a:p>
-            <a:r>
-              <a:rPr lang="en-US" dirty="0"/>
-              <a:t>Presentation Title</a:t>
-            </a:r>
-          </a:p>
-        </p:txBody>
-      </p:sp>
-      <p:sp>
-        <p:nvSpPr>
-          <p:cNvPr id="16" name="Slide Number Placeholder 5">
-            <a:extLst>
-              <a:ext uri="{FF2B5EF4-FFF2-40B4-BE49-F238E27FC236}">
-                <a16:creationId xmlns:a16="http://schemas.microsoft.com/office/drawing/2014/main" id="{3BC3F5B3-7690-C0DA-4084-5EFE50E8C162}"/>
-              </a:ext>
-            </a:extLst>
-          </p:cNvPr>
-          <p:cNvSpPr>
-            <a:spLocks noGrp="1"/>
-          </p:cNvSpPr>
-          <p:nvPr>
-            <p:ph type="sldNum" sz="quarter" idx="12"/>
-          </p:nvPr>
-        </p:nvSpPr>
-        <p:spPr>
-          <a:xfrm>
-            <a:off x="10569202" y="6309360"/>
-            <a:ext cx="979879" cy="457200"/>
-          </a:xfrm>
-        </p:spPr>
-        <p:txBody>
-          <a:bodyPr/>
-          <a:lstStyle>
-            <a:lvl1pPr>
-              <a:defRPr sz="1200" b="0"/>
-            </a:lvl1pPr>
-          </a:lstStyle>
-          <a:p>
-            <a:fld id="{FAEF9944-A4F6-4C59-AEBD-678D6480B8EA}" type="slidenum">
-              <a:rPr lang="en-US" smtClean="0"/>
-              <a:pPr/>
-              <a:t>‹#›</a:t>
-            </a:fld>
-            <a:endParaRPr lang="en-US" dirty="0"/>
-          </a:p>
-        </p:txBody>
-      </p:sp>
-      <p:sp>
-        <p:nvSpPr>
-          <p:cNvPr id="17" name="Date Placeholder 3">
-            <a:extLst>
-              <a:ext uri="{FF2B5EF4-FFF2-40B4-BE49-F238E27FC236}">
-                <a16:creationId xmlns:a16="http://schemas.microsoft.com/office/drawing/2014/main" id="{99E56FFE-09D7-3078-C9E8-DFE8CF68AAD5}"/>
-              </a:ext>
-            </a:extLst>
-          </p:cNvPr>
-          <p:cNvSpPr>
-            <a:spLocks noGrp="1"/>
-          </p:cNvSpPr>
-          <p:nvPr>
-            <p:ph type="dt" sz="half" idx="10"/>
-          </p:nvPr>
-        </p:nvSpPr>
-        <p:spPr>
-          <a:xfrm>
-            <a:off x="6678168" y="6309360"/>
-            <a:ext cx="2148840" cy="457200"/>
-          </a:xfrm>
-        </p:spPr>
-        <p:txBody>
-          <a:bodyPr/>
-          <a:lstStyle>
-            <a:lvl1pPr algn="l">
-              <a:defRPr/>
-            </a:lvl1pPr>
-          </a:lstStyle>
-          <a:p>
-            <a:r>
-              <a:rPr lang="en-US" dirty="0"/>
-              <a:t>9/8/20XX</a:t>
-            </a:r>
-          </a:p>
-        </p:txBody>
-      </p:sp>
-    </p:spTree>
-    <p:extLst>
-      <p:ext uri="{BB962C8B-B14F-4D97-AF65-F5344CB8AC3E}">
-        <p14:creationId xmlns:p14="http://schemas.microsoft.com/office/powerpoint/2010/main" val="2434033329"/>
-      </p:ext>
-    </p:extLst>
-  </p:cSld>
-  <p:clrMapOvr>
-    <a:masterClrMapping/>
-  </p:clrMapOvr>
-</p:sldLayout>
-</file>
-
-<file path=ppt/slideLayouts/slideLayout22.xml><?xml version="1.0" encoding="utf-8"?>
-<p:sldLayout xmlns:a="http://schemas.openxmlformats.org/drawingml/2006/main" xmlns:r="http://schemas.openxmlformats.org/officeDocument/2006/relationships" xmlns:p="http://schemas.openxmlformats.org/presentationml/2006/main" userDrawn="1">
   <p:cSld name="Content 1">
     <p:spTree>
       <p:nvGrpSpPr>
@@ -9918,7 +9336,7 @@
 </p:sldLayout>
 </file>
 
-<file path=ppt/slideLayouts/slideLayout23.xml><?xml version="1.0" encoding="utf-8"?>
+<file path=ppt/slideLayouts/slideLayout22.xml><?xml version="1.0" encoding="utf-8"?>
 <p:sldLayout xmlns:a="http://schemas.openxmlformats.org/drawingml/2006/main" xmlns:r="http://schemas.openxmlformats.org/officeDocument/2006/relationships" xmlns:p="http://schemas.openxmlformats.org/presentationml/2006/main" showMasterSp="0" preserve="1" userDrawn="1">
   <p:cSld name="1_Title Only">
     <p:spTree>
@@ -13485,9 +12903,8 @@
     <p:sldLayoutId id="2147483705" r:id="rId18"/>
     <p:sldLayoutId id="2147483706" r:id="rId19"/>
     <p:sldLayoutId id="2147483707" r:id="rId20"/>
-    <p:sldLayoutId id="2147483708" r:id="rId21"/>
-    <p:sldLayoutId id="2147483709" r:id="rId22"/>
-    <p:sldLayoutId id="2147483682" r:id="rId23"/>
+    <p:sldLayoutId id="2147483709" r:id="rId21"/>
+    <p:sldLayoutId id="2147483682" r:id="rId22"/>
   </p:sldLayoutIdLst>
   <p:hf sldNum="0" hdr="0" ftr="0" dt="0"/>
   <p:txStyles>
@@ -14005,87 +13422,282 @@
           <a:lstStyle/>
           <a:p>
             <a:r>
-              <a:rPr lang="en-US" dirty="0"/>
-              <a:t>Results and Evaluation</a:t>
-            </a:r>
-          </a:p>
-        </p:txBody>
-      </p:sp>
-      <p:sp>
-        <p:nvSpPr>
-          <p:cNvPr id="3" name="Content Placeholder 2">
-            <a:extLst>
-              <a:ext uri="{FF2B5EF4-FFF2-40B4-BE49-F238E27FC236}">
-                <a16:creationId xmlns:a16="http://schemas.microsoft.com/office/drawing/2014/main" id="{41191CC7-9CF2-71F0-1AD4-791EA9CBAD97}"/>
-              </a:ext>
-            </a:extLst>
-          </p:cNvPr>
-          <p:cNvSpPr>
-            <a:spLocks noGrp="1"/>
-          </p:cNvSpPr>
+              <a:rPr lang="en-US" sz="2800" dirty="0"/>
+              <a:t>Model Selection: </a:t>
+            </a:r>
+            <a:r>
+              <a:rPr lang="en-US" sz="2800" dirty="0" err="1"/>
+              <a:t>GradientBoostingRegressor</a:t>
+            </a:r>
+            <a:endParaRPr lang="en-US" sz="2800" dirty="0"/>
+          </a:p>
+        </p:txBody>
+      </p:sp>
+      <p:graphicFrame>
+        <p:nvGraphicFramePr>
+          <p:cNvPr id="11" name="Content Placeholder 10">
+            <a:extLst>
+              <a:ext uri="{FF2B5EF4-FFF2-40B4-BE49-F238E27FC236}">
+                <a16:creationId xmlns:a16="http://schemas.microsoft.com/office/drawing/2014/main" id="{453CE196-36B9-5361-5120-20DF8B3B5581}"/>
+              </a:ext>
+            </a:extLst>
+          </p:cNvPr>
+          <p:cNvGraphicFramePr>
+            <a:graphicFrameLocks noGrp="1"/>
+          </p:cNvGraphicFramePr>
           <p:nvPr>
-            <p:ph sz="quarter" idx="14"/>
+            <p:ph type="tbl" sz="quarter" idx="15"/>
+            <p:extLst>
+              <p:ext uri="{D42A27DB-BD31-4B8C-83A1-F6EECF244321}">
+                <p14:modId xmlns:p14="http://schemas.microsoft.com/office/powerpoint/2010/main" val="3419757732"/>
+              </p:ext>
+            </p:extLst>
           </p:nvPr>
-        </p:nvSpPr>
-        <p:spPr/>
-        <p:txBody>
-          <a:bodyPr>
-            <a:normAutofit/>
-          </a:bodyPr>
-          <a:lstStyle/>
-          <a:p>
-            <a:r>
-              <a:rPr lang="en-US" dirty="0" err="1"/>
-              <a:t>asdfasdfasdf</a:t>
-            </a:r>
-            <a:endParaRPr lang="en-US" dirty="0"/>
-          </a:p>
-          <a:p>
-            <a:endParaRPr lang="en-US" dirty="0"/>
-          </a:p>
-        </p:txBody>
-      </p:sp>
-      <p:sp>
-        <p:nvSpPr>
-          <p:cNvPr id="7" name="Content Placeholder 6">
-            <a:extLst>
-              <a:ext uri="{FF2B5EF4-FFF2-40B4-BE49-F238E27FC236}">
-                <a16:creationId xmlns:a16="http://schemas.microsoft.com/office/drawing/2014/main" id="{7078F1DC-7EF8-5514-E97B-D47663F284D3}"/>
-              </a:ext>
-            </a:extLst>
-          </p:cNvPr>
-          <p:cNvSpPr>
-            <a:spLocks noGrp="1"/>
-          </p:cNvSpPr>
-          <p:nvPr>
-            <p:ph sz="quarter" idx="19"/>
-          </p:nvPr>
-        </p:nvSpPr>
-        <p:spPr/>
-        <p:txBody>
-          <a:bodyPr>
-            <a:normAutofit/>
-          </a:bodyPr>
-          <a:lstStyle/>
-          <a:p>
-            <a:r>
-              <a:rPr lang="en-US" dirty="0" err="1"/>
-              <a:t>asdfasdf</a:t>
-            </a:r>
-            <a:endParaRPr lang="en-US" dirty="0"/>
-          </a:p>
-          <a:p>
-            <a:endParaRPr lang="en-US" dirty="0"/>
-          </a:p>
-          <a:p>
-            <a:endParaRPr lang="en-US" dirty="0"/>
-          </a:p>
-        </p:txBody>
-      </p:sp>
+        </p:nvGraphicFramePr>
+        <p:xfrm>
+          <a:off x="1535372" y="384049"/>
+          <a:ext cx="10013709" cy="3968159"/>
+        </p:xfrm>
+        <a:graphic>
+          <a:graphicData uri="http://schemas.openxmlformats.org/drawingml/2006/table">
+            <a:tbl>
+              <a:tblPr firstRow="1" bandRow="1">
+                <a:tableStyleId>{8A107856-5554-42FB-B03E-39F5DBC370BA}</a:tableStyleId>
+              </a:tblPr>
+              <a:tblGrid>
+                <a:gridCol w="3841043">
+                  <a:extLst>
+                    <a:ext uri="{9D8B030D-6E8A-4147-A177-3AD203B41FA5}">
+                      <a16:colId xmlns:a16="http://schemas.microsoft.com/office/drawing/2014/main" val="1123561819"/>
+                    </a:ext>
+                  </a:extLst>
+                </a:gridCol>
+                <a:gridCol w="3951488">
+                  <a:extLst>
+                    <a:ext uri="{9D8B030D-6E8A-4147-A177-3AD203B41FA5}">
+                      <a16:colId xmlns:a16="http://schemas.microsoft.com/office/drawing/2014/main" val="1296588374"/>
+                    </a:ext>
+                  </a:extLst>
+                </a:gridCol>
+                <a:gridCol w="2221178">
+                  <a:extLst>
+                    <a:ext uri="{9D8B030D-6E8A-4147-A177-3AD203B41FA5}">
+                      <a16:colId xmlns:a16="http://schemas.microsoft.com/office/drawing/2014/main" val="1285016582"/>
+                    </a:ext>
+                  </a:extLst>
+                </a:gridCol>
+              </a:tblGrid>
+              <a:tr h="477055">
+                <a:tc>
+                  <a:txBody>
+                    <a:bodyPr/>
+                    <a:lstStyle/>
+                    <a:p>
+                      <a:r>
+                        <a:rPr lang="en-US" dirty="0"/>
+                        <a:t>Category</a:t>
+                      </a:r>
+                    </a:p>
+                  </a:txBody>
+                  <a:tcPr marT="91440" anchor="ctr"/>
+                </a:tc>
+                <a:tc>
+                  <a:txBody>
+                    <a:bodyPr/>
+                    <a:lstStyle/>
+                    <a:p>
+                      <a:r>
+                        <a:rPr lang="en-US" dirty="0"/>
+                        <a:t>Model(s)</a:t>
+                      </a:r>
+                    </a:p>
+                  </a:txBody>
+                  <a:tcPr marT="91440" anchor="ctr"/>
+                </a:tc>
+                <a:tc>
+                  <a:txBody>
+                    <a:bodyPr/>
+                    <a:lstStyle/>
+                    <a:p>
+                      <a:r>
+                        <a:rPr lang="en-US" dirty="0"/>
+                        <a:t>Best</a:t>
+                      </a:r>
+                    </a:p>
+                  </a:txBody>
+                  <a:tcPr marT="91440" anchor="ctr"/>
+                </a:tc>
+                <a:extLst>
+                  <a:ext uri="{0D108BD9-81ED-4DB2-BD59-A6C34878D82A}">
+                    <a16:rowId xmlns:a16="http://schemas.microsoft.com/office/drawing/2014/main" val="3342107652"/>
+                  </a:ext>
+                </a:extLst>
+              </a:tr>
+              <a:tr h="1104856">
+                <a:tc>
+                  <a:txBody>
+                    <a:bodyPr/>
+                    <a:lstStyle/>
+                    <a:p>
+                      <a:pPr algn="ctr"/>
+                      <a:r>
+                        <a:rPr lang="en-US" dirty="0"/>
+                        <a:t>Linear</a:t>
+                      </a:r>
+                    </a:p>
+                  </a:txBody>
+                  <a:tcPr marT="91440" anchor="ctr"/>
+                </a:tc>
+                <a:tc>
+                  <a:txBody>
+                    <a:bodyPr/>
+                    <a:lstStyle/>
+                    <a:p>
+                      <a:pPr algn="ctr"/>
+                      <a:r>
+                        <a:rPr lang="en-US" dirty="0"/>
+                        <a:t>Linear Regression, Ridge, Lasso</a:t>
+                      </a:r>
+                    </a:p>
+                  </a:txBody>
+                  <a:tcPr marT="91440" anchor="ctr"/>
+                </a:tc>
+                <a:tc>
+                  <a:txBody>
+                    <a:bodyPr/>
+                    <a:lstStyle/>
+                    <a:p>
+                      <a:pPr algn="ctr"/>
+                      <a:r>
+                        <a:rPr lang="en-US" dirty="0"/>
+                        <a:t>Ridge</a:t>
+                      </a:r>
+                    </a:p>
+                  </a:txBody>
+                  <a:tcPr marT="91440" anchor="ctr"/>
+                </a:tc>
+                <a:extLst>
+                  <a:ext uri="{0D108BD9-81ED-4DB2-BD59-A6C34878D82A}">
+                    <a16:rowId xmlns:a16="http://schemas.microsoft.com/office/drawing/2014/main" val="57143556"/>
+                  </a:ext>
+                </a:extLst>
+              </a:tr>
+              <a:tr h="1193124">
+                <a:tc>
+                  <a:txBody>
+                    <a:bodyPr/>
+                    <a:lstStyle/>
+                    <a:p>
+                      <a:pPr algn="ctr"/>
+                      <a:r>
+                        <a:rPr lang="en-US" dirty="0"/>
+                        <a:t>Tree</a:t>
+                      </a:r>
+                    </a:p>
+                  </a:txBody>
+                  <a:tcPr marT="91440" anchor="ctr"/>
+                </a:tc>
+                <a:tc>
+                  <a:txBody>
+                    <a:bodyPr/>
+                    <a:lstStyle/>
+                    <a:p>
+                      <a:pPr algn="ctr"/>
+                      <a:r>
+                        <a:rPr lang="en-US" dirty="0" err="1"/>
+                        <a:t>DecisionTreeRegressor</a:t>
+                      </a:r>
+                      <a:r>
+                        <a:rPr lang="en-US" dirty="0"/>
+                        <a:t>, </a:t>
+                      </a:r>
+                      <a:r>
+                        <a:rPr lang="en-US" dirty="0" err="1"/>
+                        <a:t>RandomForestRegressor</a:t>
+                      </a:r>
+                      <a:endParaRPr lang="en-US" dirty="0"/>
+                    </a:p>
+                  </a:txBody>
+                  <a:tcPr marT="91440" anchor="ctr"/>
+                </a:tc>
+                <a:tc>
+                  <a:txBody>
+                    <a:bodyPr/>
+                    <a:lstStyle/>
+                    <a:p>
+                      <a:pPr algn="ctr"/>
+                      <a:r>
+                        <a:rPr lang="en-US" dirty="0"/>
+                        <a:t>RF</a:t>
+                      </a:r>
+                    </a:p>
+                  </a:txBody>
+                  <a:tcPr marT="91440" anchor="ctr"/>
+                </a:tc>
+                <a:extLst>
+                  <a:ext uri="{0D108BD9-81ED-4DB2-BD59-A6C34878D82A}">
+                    <a16:rowId xmlns:a16="http://schemas.microsoft.com/office/drawing/2014/main" val="2328625713"/>
+                  </a:ext>
+                </a:extLst>
+              </a:tr>
+              <a:tr h="1193124">
+                <a:tc>
+                  <a:txBody>
+                    <a:bodyPr/>
+                    <a:lstStyle/>
+                    <a:p>
+                      <a:pPr algn="ctr"/>
+                      <a:r>
+                        <a:rPr lang="en-US" dirty="0"/>
+                        <a:t>Ensemble</a:t>
+                      </a:r>
+                    </a:p>
+                  </a:txBody>
+                  <a:tcPr marT="91440" anchor="ctr"/>
+                </a:tc>
+                <a:tc>
+                  <a:txBody>
+                    <a:bodyPr/>
+                    <a:lstStyle/>
+                    <a:p>
+                      <a:pPr algn="ctr"/>
+                      <a:r>
+                        <a:rPr lang="en-US" dirty="0" err="1"/>
+                        <a:t>GradientBoostingRegressor</a:t>
+                      </a:r>
+                      <a:endParaRPr lang="en-US" dirty="0"/>
+                    </a:p>
+                  </a:txBody>
+                  <a:tcPr marT="91440" anchor="ctr"/>
+                </a:tc>
+                <a:tc>
+                  <a:txBody>
+                    <a:bodyPr/>
+                    <a:lstStyle/>
+                    <a:p>
+                      <a:pPr algn="ctr"/>
+                      <a:r>
+                        <a:rPr lang="en-US" dirty="0"/>
+                        <a:t>GBR</a:t>
+                      </a:r>
+                    </a:p>
+                  </a:txBody>
+                  <a:tcPr marT="91440" anchor="ctr"/>
+                </a:tc>
+                <a:extLst>
+                  <a:ext uri="{0D108BD9-81ED-4DB2-BD59-A6C34878D82A}">
+                    <a16:rowId xmlns:a16="http://schemas.microsoft.com/office/drawing/2014/main" val="280048660"/>
+                  </a:ext>
+                </a:extLst>
+              </a:tr>
+            </a:tbl>
+          </a:graphicData>
+        </a:graphic>
+      </p:graphicFrame>
     </p:spTree>
     <p:extLst>
       <p:ext uri="{BB962C8B-B14F-4D97-AF65-F5344CB8AC3E}">
-        <p14:creationId xmlns:p14="http://schemas.microsoft.com/office/powerpoint/2010/main" val="4153247059"/>
+        <p14:creationId xmlns:p14="http://schemas.microsoft.com/office/powerpoint/2010/main" val="2394014735"/>
       </p:ext>
     </p:extLst>
   </p:cSld>
@@ -14114,10 +13726,10 @@
       </p:grpSpPr>
       <p:sp>
         <p:nvSpPr>
-          <p:cNvPr id="6" name="Title 5">
-            <a:extLst>
-              <a:ext uri="{FF2B5EF4-FFF2-40B4-BE49-F238E27FC236}">
-                <a16:creationId xmlns:a16="http://schemas.microsoft.com/office/drawing/2014/main" id="{AFE67981-079D-4463-B997-67E6CA039B58}"/>
+          <p:cNvPr id="2" name="Title 1">
+            <a:extLst>
+              <a:ext uri="{FF2B5EF4-FFF2-40B4-BE49-F238E27FC236}">
+                <a16:creationId xmlns:a16="http://schemas.microsoft.com/office/drawing/2014/main" id="{E2D30E0F-10C6-298A-C347-E831FFF4ECB8}"/>
               </a:ext>
             </a:extLst>
           </p:cNvPr>
@@ -14135,450 +13747,144 @@
           <a:p>
             <a:r>
               <a:rPr lang="en-US" dirty="0"/>
-              <a:t>Conclusion</a:t>
-            </a:r>
-          </a:p>
-        </p:txBody>
-      </p:sp>
-      <p:graphicFrame>
-        <p:nvGraphicFramePr>
-          <p:cNvPr id="19" name="Table 9">
-            <a:extLst>
-              <a:ext uri="{FF2B5EF4-FFF2-40B4-BE49-F238E27FC236}">
-                <a16:creationId xmlns:a16="http://schemas.microsoft.com/office/drawing/2014/main" id="{AEFEE5B3-A51E-DC59-9595-7A6911D82E62}"/>
-              </a:ext>
-            </a:extLst>
-          </p:cNvPr>
-          <p:cNvGraphicFramePr>
-            <a:graphicFrameLocks noGrp="1"/>
-          </p:cNvGraphicFramePr>
+              <a:t>Results and Evaluation</a:t>
+            </a:r>
+          </a:p>
+        </p:txBody>
+      </p:sp>
+      <p:sp>
+        <p:nvSpPr>
+          <p:cNvPr id="3" name="Content Placeholder 2">
+            <a:extLst>
+              <a:ext uri="{FF2B5EF4-FFF2-40B4-BE49-F238E27FC236}">
+                <a16:creationId xmlns:a16="http://schemas.microsoft.com/office/drawing/2014/main" id="{41191CC7-9CF2-71F0-1AD4-791EA9CBAD97}"/>
+              </a:ext>
+            </a:extLst>
+          </p:cNvPr>
+          <p:cNvSpPr>
+            <a:spLocks noGrp="1"/>
+          </p:cNvSpPr>
           <p:nvPr>
-            <p:ph type="tbl" sz="quarter" idx="14"/>
-            <p:extLst>
-              <p:ext uri="{D42A27DB-BD31-4B8C-83A1-F6EECF244321}">
-                <p14:modId xmlns:p14="http://schemas.microsoft.com/office/powerpoint/2010/main" val="1372280552"/>
-              </p:ext>
-            </p:extLst>
+            <p:ph sz="quarter" idx="14"/>
           </p:nvPr>
-        </p:nvGraphicFramePr>
-        <p:xfrm>
-          <a:off x="1630363" y="2757488"/>
-          <a:ext cx="9918700" cy="3383280"/>
-        </p:xfrm>
-        <a:graphic>
-          <a:graphicData uri="http://schemas.openxmlformats.org/drawingml/2006/table">
-            <a:tbl>
-              <a:tblPr firstRow="1" bandRow="1">
-                <a:tableStyleId>{8A107856-5554-42FB-B03E-39F5DBC370BA}</a:tableStyleId>
-              </a:tblPr>
-              <a:tblGrid>
-                <a:gridCol w="3793037">
-                  <a:extLst>
-                    <a:ext uri="{9D8B030D-6E8A-4147-A177-3AD203B41FA5}">
-                      <a16:colId xmlns:a16="http://schemas.microsoft.com/office/drawing/2014/main" val="1517755082"/>
-                    </a:ext>
-                  </a:extLst>
-                </a:gridCol>
-                <a:gridCol w="2890770">
-                  <a:extLst>
-                    <a:ext uri="{9D8B030D-6E8A-4147-A177-3AD203B41FA5}">
-                      <a16:colId xmlns:a16="http://schemas.microsoft.com/office/drawing/2014/main" val="2446386500"/>
-                    </a:ext>
-                  </a:extLst>
-                </a:gridCol>
-                <a:gridCol w="1524636">
-                  <a:extLst>
-                    <a:ext uri="{9D8B030D-6E8A-4147-A177-3AD203B41FA5}">
-                      <a16:colId xmlns:a16="http://schemas.microsoft.com/office/drawing/2014/main" val="3308918160"/>
-                    </a:ext>
-                  </a:extLst>
-                </a:gridCol>
-                <a:gridCol w="1710257">
-                  <a:extLst>
-                    <a:ext uri="{9D8B030D-6E8A-4147-A177-3AD203B41FA5}">
-                      <a16:colId xmlns:a16="http://schemas.microsoft.com/office/drawing/2014/main" val="1854486728"/>
-                    </a:ext>
-                  </a:extLst>
-                </a:gridCol>
-              </a:tblGrid>
-              <a:tr h="563880">
-                <a:tc>
-                  <a:txBody>
-                    <a:bodyPr/>
-                    <a:lstStyle/>
-                    <a:p>
-                      <a:r>
-                        <a:rPr lang="en-US" dirty="0">
-                          <a:solidFill>
-                            <a:schemeClr val="tx1"/>
-                          </a:solidFill>
-                        </a:rPr>
-                        <a:t>NOT FOR USE IN FINAL</a:t>
-                      </a:r>
-                    </a:p>
-                  </a:txBody>
-                  <a:tcPr marT="91440" anchor="ctr"/>
-                </a:tc>
-                <a:tc>
-                  <a:txBody>
-                    <a:bodyPr/>
-                    <a:lstStyle/>
-                    <a:p>
-                      <a:r>
-                        <a:rPr lang="en-US" dirty="0">
-                          <a:solidFill>
-                            <a:schemeClr val="tx1"/>
-                          </a:solidFill>
-                        </a:rPr>
-                        <a:t>Measurement</a:t>
-                      </a:r>
-                    </a:p>
-                  </a:txBody>
-                  <a:tcPr marT="91440" anchor="ctr"/>
-                </a:tc>
-                <a:tc>
-                  <a:txBody>
-                    <a:bodyPr/>
-                    <a:lstStyle/>
-                    <a:p>
-                      <a:r>
-                        <a:rPr lang="en-US" dirty="0">
-                          <a:solidFill>
-                            <a:schemeClr val="tx1"/>
-                          </a:solidFill>
-                        </a:rPr>
-                        <a:t>Target</a:t>
-                      </a:r>
-                    </a:p>
-                  </a:txBody>
-                  <a:tcPr marT="91440" anchor="ctr"/>
-                </a:tc>
-                <a:tc>
-                  <a:txBody>
-                    <a:bodyPr/>
-                    <a:lstStyle/>
-                    <a:p>
-                      <a:r>
-                        <a:rPr lang="en-US" dirty="0">
-                          <a:solidFill>
-                            <a:schemeClr val="tx1"/>
-                          </a:solidFill>
-                        </a:rPr>
-                        <a:t>Achieved</a:t>
-                      </a:r>
-                    </a:p>
-                  </a:txBody>
-                  <a:tcPr marT="91440" anchor="ctr"/>
-                </a:tc>
-                <a:extLst>
-                  <a:ext uri="{0D108BD9-81ED-4DB2-BD59-A6C34878D82A}">
-                    <a16:rowId xmlns:a16="http://schemas.microsoft.com/office/drawing/2014/main" val="3100351803"/>
-                  </a:ext>
-                </a:extLst>
-              </a:tr>
-              <a:tr h="563880">
-                <a:tc>
-                  <a:txBody>
-                    <a:bodyPr/>
-                    <a:lstStyle/>
-                    <a:p>
-                      <a:r>
-                        <a:rPr lang="en-US" dirty="0"/>
-                        <a:t>Audience interaction</a:t>
-                      </a:r>
-                    </a:p>
-                  </a:txBody>
-                  <a:tcPr marT="91440" anchor="ctr"/>
-                </a:tc>
-                <a:tc>
-                  <a:txBody>
-                    <a:bodyPr/>
-                    <a:lstStyle/>
-                    <a:p>
-                      <a:r>
-                        <a:rPr lang="en-US" dirty="0"/>
-                        <a:t>Percentage (%)</a:t>
-                      </a:r>
-                    </a:p>
-                  </a:txBody>
-                  <a:tcPr marT="91440" anchor="ctr"/>
-                </a:tc>
-                <a:tc>
-                  <a:txBody>
-                    <a:bodyPr/>
-                    <a:lstStyle/>
-                    <a:p>
-                      <a:r>
-                        <a:rPr lang="en-US" dirty="0"/>
-                        <a:t>85</a:t>
-                      </a:r>
-                    </a:p>
-                  </a:txBody>
-                  <a:tcPr marT="91440" anchor="ctr"/>
-                </a:tc>
-                <a:tc>
-                  <a:txBody>
-                    <a:bodyPr/>
-                    <a:lstStyle/>
-                    <a:p>
-                      <a:r>
-                        <a:rPr lang="en-US" dirty="0"/>
-                        <a:t>88</a:t>
-                      </a:r>
-                    </a:p>
-                  </a:txBody>
-                  <a:tcPr marT="91440" anchor="ctr"/>
-                </a:tc>
-                <a:extLst>
-                  <a:ext uri="{0D108BD9-81ED-4DB2-BD59-A6C34878D82A}">
-                    <a16:rowId xmlns:a16="http://schemas.microsoft.com/office/drawing/2014/main" val="2801628125"/>
-                  </a:ext>
-                </a:extLst>
-              </a:tr>
-              <a:tr h="563880">
-                <a:tc>
-                  <a:txBody>
-                    <a:bodyPr/>
-                    <a:lstStyle/>
-                    <a:p>
-                      <a:r>
-                        <a:rPr lang="en-US" dirty="0"/>
-                        <a:t>Knowledge retention</a:t>
-                      </a:r>
-                    </a:p>
-                  </a:txBody>
-                  <a:tcPr marT="91440" anchor="ctr"/>
-                </a:tc>
-                <a:tc>
-                  <a:txBody>
-                    <a:bodyPr/>
-                    <a:lstStyle/>
-                    <a:p>
-                      <a:r>
-                        <a:rPr lang="en-US" dirty="0"/>
-                        <a:t>Percentage (%)</a:t>
-                      </a:r>
-                    </a:p>
-                  </a:txBody>
-                  <a:tcPr marT="91440" anchor="ctr"/>
-                </a:tc>
-                <a:tc>
-                  <a:txBody>
-                    <a:bodyPr/>
-                    <a:lstStyle/>
-                    <a:p>
-                      <a:r>
-                        <a:rPr lang="en-US" dirty="0"/>
-                        <a:t>75</a:t>
-                      </a:r>
-                    </a:p>
-                  </a:txBody>
-                  <a:tcPr marT="91440" anchor="ctr"/>
-                </a:tc>
-                <a:tc>
-                  <a:txBody>
-                    <a:bodyPr/>
-                    <a:lstStyle/>
-                    <a:p>
-                      <a:r>
-                        <a:rPr lang="en-US" dirty="0"/>
-                        <a:t>80</a:t>
-                      </a:r>
-                    </a:p>
-                  </a:txBody>
-                  <a:tcPr marT="91440" anchor="ctr"/>
-                </a:tc>
-                <a:extLst>
-                  <a:ext uri="{0D108BD9-81ED-4DB2-BD59-A6C34878D82A}">
-                    <a16:rowId xmlns:a16="http://schemas.microsoft.com/office/drawing/2014/main" val="522315634"/>
-                  </a:ext>
-                </a:extLst>
-              </a:tr>
-              <a:tr h="563880">
-                <a:tc>
-                  <a:txBody>
-                    <a:bodyPr/>
-                    <a:lstStyle/>
-                    <a:p>
-                      <a:r>
-                        <a:rPr lang="en-US" dirty="0"/>
-                        <a:t>Post-presentation surveys</a:t>
-                      </a:r>
-                    </a:p>
-                  </a:txBody>
-                  <a:tcPr marT="91440" anchor="ctr"/>
-                </a:tc>
-                <a:tc>
-                  <a:txBody>
-                    <a:bodyPr/>
-                    <a:lstStyle/>
-                    <a:p>
-                      <a:r>
-                        <a:rPr lang="en-US" dirty="0"/>
-                        <a:t>Average rating</a:t>
-                      </a:r>
-                    </a:p>
-                  </a:txBody>
-                  <a:tcPr marT="91440" anchor="ctr"/>
-                </a:tc>
-                <a:tc>
-                  <a:txBody>
-                    <a:bodyPr/>
-                    <a:lstStyle/>
-                    <a:p>
-                      <a:r>
-                        <a:rPr lang="en-US" dirty="0"/>
-                        <a:t>4.2</a:t>
-                      </a:r>
-                    </a:p>
-                  </a:txBody>
-                  <a:tcPr marT="91440" anchor="ctr"/>
-                </a:tc>
-                <a:tc>
-                  <a:txBody>
-                    <a:bodyPr/>
-                    <a:lstStyle/>
-                    <a:p>
-                      <a:r>
-                        <a:rPr lang="en-US" dirty="0"/>
-                        <a:t>4.5</a:t>
-                      </a:r>
-                    </a:p>
-                  </a:txBody>
-                  <a:tcPr marT="91440" anchor="ctr"/>
-                </a:tc>
-                <a:extLst>
-                  <a:ext uri="{0D108BD9-81ED-4DB2-BD59-A6C34878D82A}">
-                    <a16:rowId xmlns:a16="http://schemas.microsoft.com/office/drawing/2014/main" val="3923311043"/>
-                  </a:ext>
-                </a:extLst>
-              </a:tr>
-              <a:tr h="563880">
-                <a:tc>
-                  <a:txBody>
-                    <a:bodyPr/>
-                    <a:lstStyle/>
-                    <a:p>
-                      <a:r>
-                        <a:rPr lang="en-US" dirty="0"/>
-                        <a:t>Referral rate</a:t>
-                      </a:r>
-                    </a:p>
-                  </a:txBody>
-                  <a:tcPr marT="91440" anchor="ctr"/>
-                </a:tc>
-                <a:tc>
-                  <a:txBody>
-                    <a:bodyPr/>
-                    <a:lstStyle/>
-                    <a:p>
-                      <a:r>
-                        <a:rPr lang="en-US" dirty="0"/>
-                        <a:t>Percentage (%)</a:t>
-                      </a:r>
-                    </a:p>
-                  </a:txBody>
-                  <a:tcPr marT="91440" anchor="ctr"/>
-                </a:tc>
-                <a:tc>
-                  <a:txBody>
-                    <a:bodyPr/>
-                    <a:lstStyle/>
-                    <a:p>
-                      <a:r>
-                        <a:rPr lang="en-US" dirty="0"/>
-                        <a:t>10</a:t>
-                      </a:r>
-                    </a:p>
-                  </a:txBody>
-                  <a:tcPr marT="91440" anchor="ctr"/>
-                </a:tc>
-                <a:tc>
-                  <a:txBody>
-                    <a:bodyPr/>
-                    <a:lstStyle/>
-                    <a:p>
-                      <a:r>
-                        <a:rPr lang="en-US" dirty="0"/>
-                        <a:t>12</a:t>
-                      </a:r>
-                    </a:p>
-                  </a:txBody>
-                  <a:tcPr marT="91440" anchor="ctr"/>
-                </a:tc>
-                <a:extLst>
-                  <a:ext uri="{0D108BD9-81ED-4DB2-BD59-A6C34878D82A}">
-                    <a16:rowId xmlns:a16="http://schemas.microsoft.com/office/drawing/2014/main" val="2046739586"/>
-                  </a:ext>
-                </a:extLst>
-              </a:tr>
-              <a:tr h="563880">
-                <a:tc>
-                  <a:txBody>
-                    <a:bodyPr/>
-                    <a:lstStyle/>
-                    <a:p>
-                      <a:r>
-                        <a:rPr lang="en-US" dirty="0"/>
-                        <a:t>Collaboration opportunities</a:t>
-                      </a:r>
-                    </a:p>
-                  </a:txBody>
-                  <a:tcPr marT="91440" anchor="ctr"/>
-                </a:tc>
-                <a:tc>
-                  <a:txBody>
-                    <a:bodyPr/>
-                    <a:lstStyle/>
-                    <a:p>
-                      <a:r>
-                        <a:rPr lang="en-US" dirty="0"/>
-                        <a:t># of opportunities</a:t>
-                      </a:r>
-                    </a:p>
-                  </a:txBody>
-                  <a:tcPr marT="91440" anchor="ctr"/>
-                </a:tc>
-                <a:tc>
-                  <a:txBody>
-                    <a:bodyPr/>
-                    <a:lstStyle/>
-                    <a:p>
-                      <a:r>
-                        <a:rPr lang="en-US" dirty="0"/>
-                        <a:t>8</a:t>
-                      </a:r>
-                    </a:p>
-                  </a:txBody>
-                  <a:tcPr marT="91440" anchor="ctr"/>
-                </a:tc>
-                <a:tc>
-                  <a:txBody>
-                    <a:bodyPr/>
-                    <a:lstStyle/>
-                    <a:p>
-                      <a:r>
-                        <a:rPr lang="en-US" dirty="0"/>
-                        <a:t>10</a:t>
-                      </a:r>
-                    </a:p>
-                  </a:txBody>
-                  <a:tcPr marT="91440" anchor="ctr"/>
-                </a:tc>
-                <a:extLst>
-                  <a:ext uri="{0D108BD9-81ED-4DB2-BD59-A6C34878D82A}">
-                    <a16:rowId xmlns:a16="http://schemas.microsoft.com/office/drawing/2014/main" val="2166282185"/>
-                  </a:ext>
-                </a:extLst>
-              </a:tr>
-            </a:tbl>
-          </a:graphicData>
-        </a:graphic>
-      </p:graphicFrame>
+        </p:nvSpPr>
+        <p:spPr>
+          <a:xfrm>
+            <a:off x="310607" y="1646102"/>
+            <a:ext cx="6968018" cy="4160520"/>
+          </a:xfrm>
+        </p:spPr>
+        <p:txBody>
+          <a:bodyPr>
+            <a:normAutofit fontScale="77500" lnSpcReduction="20000"/>
+          </a:bodyPr>
+          <a:lstStyle/>
+          <a:p>
+            <a:r>
+              <a:rPr lang="en-US" dirty="0"/>
+              <a:t>We selected the </a:t>
+            </a:r>
+            <a:r>
+              <a:rPr lang="en-US" dirty="0" err="1"/>
+              <a:t>GradientBoostingRegressor</a:t>
+            </a:r>
+            <a:r>
+              <a:rPr lang="en-US" dirty="0"/>
+              <a:t> (GBR) as our final model based on its strong overall performance, generalization capability, and ability to model non-linear relationships.</a:t>
+            </a:r>
+          </a:p>
+          <a:p>
+            <a:pPr marL="285750" indent="-285750">
+              <a:buFont typeface="Arial" panose="020B0604020202020204" pitchFamily="34" charset="0"/>
+              <a:buChar char="•"/>
+            </a:pPr>
+            <a:r>
+              <a:rPr lang="en-US" dirty="0"/>
+              <a:t>Train RMSE: 189,200.81</a:t>
+            </a:r>
+          </a:p>
+          <a:p>
+            <a:pPr marL="285750" indent="-285750">
+              <a:buFont typeface="Arial" panose="020B0604020202020204" pitchFamily="34" charset="0"/>
+              <a:buChar char="•"/>
+            </a:pPr>
+            <a:r>
+              <a:rPr lang="en-US" dirty="0"/>
+              <a:t>Test RMSE: 193,634.37</a:t>
+            </a:r>
+          </a:p>
+          <a:p>
+            <a:pPr marL="285750" indent="-285750">
+              <a:buFont typeface="Arial" panose="020B0604020202020204" pitchFamily="34" charset="0"/>
+              <a:buChar char="•"/>
+            </a:pPr>
+            <a:r>
+              <a:rPr lang="en-US" dirty="0"/>
+              <a:t>Cross-Validated RMSE: 193,744.46</a:t>
+            </a:r>
+          </a:p>
+          <a:p>
+            <a:pPr marL="285750" indent="-285750">
+              <a:buFont typeface="Arial" panose="020B0604020202020204" pitchFamily="34" charset="0"/>
+              <a:buChar char="•"/>
+            </a:pPr>
+            <a:r>
+              <a:rPr lang="en-US" dirty="0"/>
+              <a:t>CV RMSE Std Dev: 502,332.56</a:t>
+            </a:r>
+          </a:p>
+          <a:p>
+            <a:pPr marL="285750" indent="-285750">
+              <a:buFont typeface="Arial" panose="020B0604020202020204" pitchFamily="34" charset="0"/>
+              <a:buChar char="•"/>
+            </a:pPr>
+            <a:r>
+              <a:rPr lang="en-US" dirty="0"/>
+              <a:t>Test R² Score ~0.43–0.48 (est.)</a:t>
+            </a:r>
+          </a:p>
+          <a:p>
+            <a:r>
+              <a:rPr lang="en-US" dirty="0"/>
+              <a:t>Although Ridge Regression remained a strong contender (offering faster training and reasonably good test performance), it consistently underperformed the GBR in final runs by a measurable margin.</a:t>
+            </a:r>
+          </a:p>
+        </p:txBody>
+      </p:sp>
+      <p:pic>
+        <p:nvPicPr>
+          <p:cNvPr id="9" name="Picture 8">
+            <a:extLst>
+              <a:ext uri="{FF2B5EF4-FFF2-40B4-BE49-F238E27FC236}">
+                <a16:creationId xmlns:a16="http://schemas.microsoft.com/office/drawing/2014/main" id="{EF7B67FE-2DE3-5039-AC29-826CA65CC215}"/>
+              </a:ext>
+            </a:extLst>
+          </p:cNvPr>
+          <p:cNvPicPr>
+            <a:picLocks noChangeAspect="1"/>
+          </p:cNvPicPr>
+          <p:nvPr/>
+        </p:nvPicPr>
+        <p:blipFill>
+          <a:blip r:embed="rId3"/>
+          <a:stretch>
+            <a:fillRect/>
+          </a:stretch>
+        </p:blipFill>
+        <p:spPr>
+          <a:xfrm>
+            <a:off x="7015889" y="2016244"/>
+            <a:ext cx="4939319" cy="3790378"/>
+          </a:xfrm>
+          <a:prstGeom prst="rect">
+            <a:avLst/>
+          </a:prstGeom>
+        </p:spPr>
+      </p:pic>
     </p:spTree>
     <p:extLst>
       <p:ext uri="{BB962C8B-B14F-4D97-AF65-F5344CB8AC3E}">
-        <p14:creationId xmlns:p14="http://schemas.microsoft.com/office/powerpoint/2010/main" val="3345023337"/>
+        <p14:creationId xmlns:p14="http://schemas.microsoft.com/office/powerpoint/2010/main" val="4153247059"/>
       </p:ext>
     </p:extLst>
   </p:cSld>
@@ -14589,6 +13895,859 @@
 </file>
 
 <file path=ppt/slides/slide12.xml><?xml version="1.0" encoding="utf-8"?>
+<p:sld xmlns:a="http://schemas.openxmlformats.org/drawingml/2006/main" xmlns:r="http://schemas.openxmlformats.org/officeDocument/2006/relationships" xmlns:p="http://schemas.openxmlformats.org/presentationml/2006/main">
+  <p:cSld>
+    <p:spTree>
+      <p:nvGrpSpPr>
+        <p:cNvPr id="1" name=""/>
+        <p:cNvGrpSpPr/>
+        <p:nvPr/>
+      </p:nvGrpSpPr>
+      <p:grpSpPr>
+        <a:xfrm>
+          <a:off x="0" y="0"/>
+          <a:ext cx="0" cy="0"/>
+          <a:chOff x="0" y="0"/>
+          <a:chExt cx="0" cy="0"/>
+        </a:xfrm>
+      </p:grpSpPr>
+      <p:sp>
+        <p:nvSpPr>
+          <p:cNvPr id="2" name="Title 1">
+            <a:extLst>
+              <a:ext uri="{FF2B5EF4-FFF2-40B4-BE49-F238E27FC236}">
+                <a16:creationId xmlns:a16="http://schemas.microsoft.com/office/drawing/2014/main" id="{743A758C-BDB8-B3F9-0A0B-A656BFA95358}"/>
+              </a:ext>
+            </a:extLst>
+          </p:cNvPr>
+          <p:cNvSpPr>
+            <a:spLocks noGrp="1"/>
+          </p:cNvSpPr>
+          <p:nvPr>
+            <p:ph type="title"/>
+          </p:nvPr>
+        </p:nvSpPr>
+        <p:spPr/>
+        <p:txBody>
+          <a:bodyPr/>
+          <a:lstStyle/>
+          <a:p>
+            <a:r>
+              <a:rPr lang="en-US" dirty="0"/>
+              <a:t>Error Analysis</a:t>
+            </a:r>
+          </a:p>
+        </p:txBody>
+      </p:sp>
+      <p:sp>
+        <p:nvSpPr>
+          <p:cNvPr id="4" name="TextBox 3">
+            <a:extLst>
+              <a:ext uri="{FF2B5EF4-FFF2-40B4-BE49-F238E27FC236}">
+                <a16:creationId xmlns:a16="http://schemas.microsoft.com/office/drawing/2014/main" id="{176DA6DE-2207-BA00-C29C-337CA944C407}"/>
+              </a:ext>
+            </a:extLst>
+          </p:cNvPr>
+          <p:cNvSpPr txBox="1"/>
+          <p:nvPr/>
+        </p:nvSpPr>
+        <p:spPr>
+          <a:xfrm>
+            <a:off x="7050011" y="3666357"/>
+            <a:ext cx="5020056" cy="3191643"/>
+          </a:xfrm>
+          <a:prstGeom prst="rect">
+            <a:avLst/>
+          </a:prstGeom>
+          <a:noFill/>
+        </p:spPr>
+        <p:txBody>
+          <a:bodyPr wrap="square" rtlCol="0">
+            <a:spAutoFit/>
+          </a:bodyPr>
+          <a:lstStyle/>
+          <a:p>
+            <a:pPr marL="285750" indent="-285750">
+              <a:lnSpc>
+                <a:spcPct val="105000"/>
+              </a:lnSpc>
+              <a:spcBef>
+                <a:spcPts val="930"/>
+              </a:spcBef>
+              <a:spcAft>
+                <a:spcPts val="600"/>
+              </a:spcAft>
+              <a:buFont typeface="Arial" panose="020B0604020202020204" pitchFamily="34" charset="0"/>
+              <a:buChar char="•"/>
+            </a:pPr>
+            <a:r>
+              <a:rPr lang="en-US" sz="1400" b="1" spc="150" dirty="0">
+                <a:solidFill>
+                  <a:schemeClr val="tx1">
+                    <a:lumMod val="75000"/>
+                    <a:lumOff val="25000"/>
+                  </a:schemeClr>
+                </a:solidFill>
+              </a:rPr>
+              <a:t>Outliers: </a:t>
+            </a:r>
+            <a:r>
+              <a:rPr lang="en-US" sz="1400" spc="150" dirty="0">
+                <a:solidFill>
+                  <a:schemeClr val="tx1">
+                    <a:lumMod val="75000"/>
+                    <a:lumOff val="25000"/>
+                  </a:schemeClr>
+                </a:solidFill>
+              </a:rPr>
+              <a:t>Many high-value homes were harder to predict — likely due to missing luxury indicators not captured in the dataset.</a:t>
+            </a:r>
+          </a:p>
+          <a:p>
+            <a:pPr marL="285750" indent="-285750">
+              <a:lnSpc>
+                <a:spcPct val="105000"/>
+              </a:lnSpc>
+              <a:spcBef>
+                <a:spcPts val="930"/>
+              </a:spcBef>
+              <a:spcAft>
+                <a:spcPts val="600"/>
+              </a:spcAft>
+              <a:buFont typeface="Arial" panose="020B0604020202020204" pitchFamily="34" charset="0"/>
+              <a:buChar char="•"/>
+            </a:pPr>
+            <a:r>
+              <a:rPr lang="en-US" sz="1400" b="1" spc="150" dirty="0">
+                <a:solidFill>
+                  <a:schemeClr val="tx1">
+                    <a:lumMod val="75000"/>
+                    <a:lumOff val="25000"/>
+                  </a:schemeClr>
+                </a:solidFill>
+              </a:rPr>
+              <a:t>Feature Sensitivity: </a:t>
+            </a:r>
+            <a:r>
+              <a:rPr lang="en-US" sz="1400" spc="150" dirty="0">
+                <a:solidFill>
+                  <a:schemeClr val="tx1">
+                    <a:lumMod val="75000"/>
+                    <a:lumOff val="25000"/>
+                  </a:schemeClr>
+                </a:solidFill>
+              </a:rPr>
+              <a:t>GBR leveraged engineered features like Bed-to-Bath ratio and Age more effectively than simpler models.</a:t>
+            </a:r>
+          </a:p>
+          <a:p>
+            <a:pPr marL="285750" indent="-285750">
+              <a:lnSpc>
+                <a:spcPct val="105000"/>
+              </a:lnSpc>
+              <a:spcBef>
+                <a:spcPts val="930"/>
+              </a:spcBef>
+              <a:spcAft>
+                <a:spcPts val="600"/>
+              </a:spcAft>
+              <a:buFont typeface="Arial" panose="020B0604020202020204" pitchFamily="34" charset="0"/>
+              <a:buChar char="•"/>
+            </a:pPr>
+            <a:r>
+              <a:rPr lang="en-US" sz="1400" b="1" spc="150" dirty="0">
+                <a:solidFill>
+                  <a:schemeClr val="tx1">
+                    <a:lumMod val="75000"/>
+                    <a:lumOff val="25000"/>
+                  </a:schemeClr>
+                </a:solidFill>
+              </a:rPr>
+              <a:t>Overfitting Risk: </a:t>
+            </a:r>
+            <a:r>
+              <a:rPr lang="en-US" sz="1400" spc="150" dirty="0">
+                <a:solidFill>
+                  <a:schemeClr val="tx1">
+                    <a:lumMod val="75000"/>
+                    <a:lumOff val="25000"/>
+                  </a:schemeClr>
+                </a:solidFill>
+              </a:rPr>
+              <a:t>Controlled by early stopping and regularization in GBR, with validation curves confirming minimal overfit.</a:t>
+            </a:r>
+          </a:p>
+        </p:txBody>
+      </p:sp>
+    </p:spTree>
+    <p:extLst>
+      <p:ext uri="{BB962C8B-B14F-4D97-AF65-F5344CB8AC3E}">
+        <p14:creationId xmlns:p14="http://schemas.microsoft.com/office/powerpoint/2010/main" val="2503730320"/>
+      </p:ext>
+    </p:extLst>
+  </p:cSld>
+  <p:clrMapOvr>
+    <a:masterClrMapping/>
+  </p:clrMapOvr>
+</p:sld>
+</file>
+
+<file path=ppt/slides/slide13.xml><?xml version="1.0" encoding="utf-8"?>
+<p:sld xmlns:a="http://schemas.openxmlformats.org/drawingml/2006/main" xmlns:r="http://schemas.openxmlformats.org/officeDocument/2006/relationships" xmlns:p="http://schemas.openxmlformats.org/presentationml/2006/main">
+  <p:cSld>
+    <p:spTree>
+      <p:nvGrpSpPr>
+        <p:cNvPr id="1" name=""/>
+        <p:cNvGrpSpPr/>
+        <p:nvPr/>
+      </p:nvGrpSpPr>
+      <p:grpSpPr>
+        <a:xfrm>
+          <a:off x="0" y="0"/>
+          <a:ext cx="0" cy="0"/>
+          <a:chOff x="0" y="0"/>
+          <a:chExt cx="0" cy="0"/>
+        </a:xfrm>
+      </p:grpSpPr>
+      <p:sp>
+        <p:nvSpPr>
+          <p:cNvPr id="2" name="Title 1">
+            <a:extLst>
+              <a:ext uri="{FF2B5EF4-FFF2-40B4-BE49-F238E27FC236}">
+                <a16:creationId xmlns:a16="http://schemas.microsoft.com/office/drawing/2014/main" id="{8648BCF1-513F-39C3-7858-2612B4C9486D}"/>
+              </a:ext>
+            </a:extLst>
+          </p:cNvPr>
+          <p:cNvSpPr>
+            <a:spLocks noGrp="1"/>
+          </p:cNvSpPr>
+          <p:nvPr>
+            <p:ph type="title"/>
+          </p:nvPr>
+        </p:nvSpPr>
+        <p:spPr/>
+        <p:txBody>
+          <a:bodyPr/>
+          <a:lstStyle/>
+          <a:p>
+            <a:r>
+              <a:rPr lang="en-US" dirty="0"/>
+              <a:t>Conclusions</a:t>
+            </a:r>
+          </a:p>
+        </p:txBody>
+      </p:sp>
+      <p:sp>
+        <p:nvSpPr>
+          <p:cNvPr id="3" name="Content Placeholder 2">
+            <a:extLst>
+              <a:ext uri="{FF2B5EF4-FFF2-40B4-BE49-F238E27FC236}">
+                <a16:creationId xmlns:a16="http://schemas.microsoft.com/office/drawing/2014/main" id="{79CBB9AB-9319-1CC8-BFF6-756D1EA91775}"/>
+              </a:ext>
+            </a:extLst>
+          </p:cNvPr>
+          <p:cNvSpPr>
+            <a:spLocks noGrp="1"/>
+          </p:cNvSpPr>
+          <p:nvPr>
+            <p:ph sz="quarter" idx="14"/>
+          </p:nvPr>
+        </p:nvSpPr>
+        <p:spPr>
+          <a:xfrm>
+            <a:off x="329911" y="1560758"/>
+            <a:ext cx="3819652" cy="4160520"/>
+          </a:xfrm>
+        </p:spPr>
+        <p:txBody>
+          <a:bodyPr>
+            <a:normAutofit fontScale="92500" lnSpcReduction="10000"/>
+          </a:bodyPr>
+          <a:lstStyle/>
+          <a:p>
+            <a:r>
+              <a:rPr lang="en-US" b="1" dirty="0"/>
+              <a:t>Findings:</a:t>
+            </a:r>
+          </a:p>
+          <a:p>
+            <a:pPr marL="285750" indent="-285750">
+              <a:buFont typeface="Arial" panose="020B0604020202020204" pitchFamily="34" charset="0"/>
+              <a:buChar char="•"/>
+            </a:pPr>
+            <a:r>
+              <a:rPr lang="en-US" dirty="0"/>
+              <a:t>The importance of rigorous cleaning and engineering</a:t>
+            </a:r>
+          </a:p>
+          <a:p>
+            <a:pPr marL="285750" indent="-285750">
+              <a:buFont typeface="Arial" panose="020B0604020202020204" pitchFamily="34" charset="0"/>
+              <a:buChar char="•"/>
+            </a:pPr>
+            <a:r>
+              <a:rPr lang="en-US" dirty="0"/>
+              <a:t>Ensemble models advantages with nonlinear data</a:t>
+            </a:r>
+          </a:p>
+          <a:p>
+            <a:pPr marL="285750" indent="-285750">
+              <a:buFont typeface="Arial" panose="020B0604020202020204" pitchFamily="34" charset="0"/>
+              <a:buChar char="•"/>
+            </a:pPr>
+            <a:r>
+              <a:rPr lang="en-US" dirty="0"/>
+              <a:t>Our model can support fair and quick tax assessments for a range of stakeholders</a:t>
+            </a:r>
+          </a:p>
+        </p:txBody>
+      </p:sp>
+      <p:sp>
+        <p:nvSpPr>
+          <p:cNvPr id="5" name="Content Placeholder 2">
+            <a:extLst>
+              <a:ext uri="{FF2B5EF4-FFF2-40B4-BE49-F238E27FC236}">
+                <a16:creationId xmlns:a16="http://schemas.microsoft.com/office/drawing/2014/main" id="{6ABF28F6-A9D6-61E1-EA45-C92DF62734B2}"/>
+              </a:ext>
+            </a:extLst>
+          </p:cNvPr>
+          <p:cNvSpPr txBox="1">
+            <a:spLocks/>
+          </p:cNvSpPr>
+          <p:nvPr/>
+        </p:nvSpPr>
+        <p:spPr>
+          <a:xfrm>
+            <a:off x="4149563" y="1560758"/>
+            <a:ext cx="3819652" cy="4160520"/>
+          </a:xfrm>
+          <a:prstGeom prst="rect">
+            <a:avLst/>
+          </a:prstGeom>
+        </p:spPr>
+        <p:txBody>
+          <a:bodyPr vert="horz" lIns="109728" tIns="109728" rIns="109728" bIns="91440" rtlCol="0" anchor="t">
+            <a:normAutofit/>
+          </a:bodyPr>
+          <a:lstStyle>
+            <a:lvl1pPr marL="0" indent="0" algn="l" defTabSz="914400" rtl="0" eaLnBrk="1" latinLnBrk="0" hangingPunct="1">
+              <a:lnSpc>
+                <a:spcPct val="125000"/>
+              </a:lnSpc>
+              <a:spcBef>
+                <a:spcPts val="930"/>
+              </a:spcBef>
+              <a:spcAft>
+                <a:spcPts val="600"/>
+              </a:spcAft>
+              <a:buFont typeface="Corbel" panose="020B0503020204020204" pitchFamily="34" charset="0"/>
+              <a:buNone/>
+              <a:defRPr sz="1800" b="0" kern="1200" spc="150" baseline="0">
+                <a:solidFill>
+                  <a:schemeClr val="tx1">
+                    <a:lumMod val="75000"/>
+                    <a:lumOff val="25000"/>
+                  </a:schemeClr>
+                </a:solidFill>
+                <a:latin typeface="+mn-lt"/>
+                <a:ea typeface="+mn-ea"/>
+                <a:cs typeface="+mn-cs"/>
+              </a:defRPr>
+            </a:lvl1pPr>
+            <a:lvl2pPr marL="0" indent="0" algn="l" defTabSz="914400" rtl="0" eaLnBrk="1" latinLnBrk="0" hangingPunct="1">
+              <a:lnSpc>
+                <a:spcPct val="125000"/>
+              </a:lnSpc>
+              <a:spcBef>
+                <a:spcPts val="930"/>
+              </a:spcBef>
+              <a:spcAft>
+                <a:spcPts val="600"/>
+              </a:spcAft>
+              <a:buFont typeface="Corbel" panose="020B0503020204020204" pitchFamily="34" charset="0"/>
+              <a:buNone/>
+              <a:defRPr sz="1800" kern="1200" spc="150" baseline="0">
+                <a:solidFill>
+                  <a:schemeClr val="tx1">
+                    <a:lumMod val="75000"/>
+                    <a:lumOff val="25000"/>
+                  </a:schemeClr>
+                </a:solidFill>
+                <a:latin typeface="+mn-lt"/>
+                <a:ea typeface="+mn-ea"/>
+                <a:cs typeface="+mn-cs"/>
+              </a:defRPr>
+            </a:lvl2pPr>
+            <a:lvl3pPr marL="0" indent="-320040" algn="l" defTabSz="914400" rtl="0" eaLnBrk="1" latinLnBrk="0" hangingPunct="1">
+              <a:lnSpc>
+                <a:spcPct val="125000"/>
+              </a:lnSpc>
+              <a:spcBef>
+                <a:spcPts val="930"/>
+              </a:spcBef>
+              <a:spcAft>
+                <a:spcPts val="600"/>
+              </a:spcAft>
+              <a:buFont typeface="Corbel" panose="020B0503020204020204" pitchFamily="34" charset="0"/>
+              <a:buChar char="–"/>
+              <a:defRPr sz="1800" i="1" kern="1200" spc="150" baseline="0">
+                <a:solidFill>
+                  <a:schemeClr val="tx1">
+                    <a:lumMod val="75000"/>
+                    <a:lumOff val="25000"/>
+                  </a:schemeClr>
+                </a:solidFill>
+                <a:latin typeface="+mn-lt"/>
+                <a:ea typeface="+mn-ea"/>
+                <a:cs typeface="+mn-cs"/>
+              </a:defRPr>
+            </a:lvl3pPr>
+            <a:lvl4pPr marL="0" indent="-320040" algn="l" defTabSz="914400" rtl="0" eaLnBrk="1" latinLnBrk="0" hangingPunct="1">
+              <a:lnSpc>
+                <a:spcPct val="125000"/>
+              </a:lnSpc>
+              <a:spcBef>
+                <a:spcPts val="930"/>
+              </a:spcBef>
+              <a:spcAft>
+                <a:spcPts val="600"/>
+              </a:spcAft>
+              <a:buFont typeface="Corbel" panose="020B0503020204020204" pitchFamily="34" charset="0"/>
+              <a:buChar char="–"/>
+              <a:defRPr sz="1800" kern="1200" spc="150" baseline="0">
+                <a:solidFill>
+                  <a:schemeClr val="tx1">
+                    <a:lumMod val="75000"/>
+                    <a:lumOff val="25000"/>
+                  </a:schemeClr>
+                </a:solidFill>
+                <a:latin typeface="+mn-lt"/>
+                <a:ea typeface="+mn-ea"/>
+                <a:cs typeface="+mn-cs"/>
+              </a:defRPr>
+            </a:lvl4pPr>
+            <a:lvl5pPr marL="0" indent="-320040" algn="l" defTabSz="914400" rtl="0" eaLnBrk="1" latinLnBrk="0" hangingPunct="1">
+              <a:lnSpc>
+                <a:spcPct val="125000"/>
+              </a:lnSpc>
+              <a:spcBef>
+                <a:spcPts val="930"/>
+              </a:spcBef>
+              <a:spcAft>
+                <a:spcPts val="600"/>
+              </a:spcAft>
+              <a:buFont typeface="Corbel" panose="020B0503020204020204" pitchFamily="34" charset="0"/>
+              <a:buChar char="–"/>
+              <a:defRPr sz="1800" i="1" kern="1200" spc="150" baseline="0">
+                <a:solidFill>
+                  <a:schemeClr val="tx1">
+                    <a:lumMod val="75000"/>
+                    <a:lumOff val="25000"/>
+                  </a:schemeClr>
+                </a:solidFill>
+                <a:latin typeface="+mn-lt"/>
+                <a:ea typeface="+mn-ea"/>
+                <a:cs typeface="+mn-cs"/>
+              </a:defRPr>
+            </a:lvl5pPr>
+            <a:lvl6pPr marL="1920240" indent="-320040" algn="l" defTabSz="914400" rtl="0" eaLnBrk="1" latinLnBrk="0" hangingPunct="1">
+              <a:lnSpc>
+                <a:spcPct val="111000"/>
+              </a:lnSpc>
+              <a:spcBef>
+                <a:spcPts val="930"/>
+              </a:spcBef>
+              <a:buFont typeface="Corbel" panose="020B0503020204020204" pitchFamily="34" charset="0"/>
+              <a:buChar char="–"/>
+              <a:defRPr sz="1400" kern="1200">
+                <a:solidFill>
+                  <a:schemeClr val="accent1">
+                    <a:lumMod val="75000"/>
+                  </a:schemeClr>
+                </a:solidFill>
+                <a:latin typeface="+mn-lt"/>
+                <a:ea typeface="+mn-ea"/>
+                <a:cs typeface="+mn-cs"/>
+              </a:defRPr>
+            </a:lvl6pPr>
+            <a:lvl7pPr marL="2240280" indent="-320040" algn="l" defTabSz="914400" rtl="0" eaLnBrk="1" latinLnBrk="0" hangingPunct="1">
+              <a:lnSpc>
+                <a:spcPct val="111000"/>
+              </a:lnSpc>
+              <a:spcBef>
+                <a:spcPts val="930"/>
+              </a:spcBef>
+              <a:buFont typeface="Corbel" panose="020B0503020204020204" pitchFamily="34" charset="0"/>
+              <a:buChar char="–"/>
+              <a:defRPr sz="1400" i="1" kern="1200">
+                <a:solidFill>
+                  <a:schemeClr val="accent1">
+                    <a:lumMod val="75000"/>
+                  </a:schemeClr>
+                </a:solidFill>
+                <a:latin typeface="+mn-lt"/>
+                <a:ea typeface="+mn-ea"/>
+                <a:cs typeface="+mn-cs"/>
+              </a:defRPr>
+            </a:lvl7pPr>
+            <a:lvl8pPr marL="2560320" indent="-320040" algn="l" defTabSz="914400" rtl="0" eaLnBrk="1" latinLnBrk="0" hangingPunct="1">
+              <a:lnSpc>
+                <a:spcPct val="111000"/>
+              </a:lnSpc>
+              <a:spcBef>
+                <a:spcPts val="930"/>
+              </a:spcBef>
+              <a:buFont typeface="Corbel" panose="020B0503020204020204" pitchFamily="34" charset="0"/>
+              <a:buChar char="–"/>
+              <a:defRPr sz="1400" kern="1200">
+                <a:solidFill>
+                  <a:schemeClr val="accent1">
+                    <a:lumMod val="75000"/>
+                  </a:schemeClr>
+                </a:solidFill>
+                <a:latin typeface="+mn-lt"/>
+                <a:ea typeface="+mn-ea"/>
+                <a:cs typeface="+mn-cs"/>
+              </a:defRPr>
+            </a:lvl8pPr>
+            <a:lvl9pPr marL="2880360" indent="-320040" algn="l" defTabSz="914400" rtl="0" eaLnBrk="1" latinLnBrk="0" hangingPunct="1">
+              <a:lnSpc>
+                <a:spcPct val="111000"/>
+              </a:lnSpc>
+              <a:spcBef>
+                <a:spcPts val="930"/>
+              </a:spcBef>
+              <a:buFont typeface="Corbel" panose="020B0503020204020204" pitchFamily="34" charset="0"/>
+              <a:buChar char="–"/>
+              <a:defRPr sz="1400" i="1" kern="1200">
+                <a:solidFill>
+                  <a:schemeClr val="accent1">
+                    <a:lumMod val="75000"/>
+                  </a:schemeClr>
+                </a:solidFill>
+                <a:latin typeface="+mn-lt"/>
+                <a:ea typeface="+mn-ea"/>
+                <a:cs typeface="+mn-cs"/>
+              </a:defRPr>
+            </a:lvl9pPr>
+          </a:lstStyle>
+          <a:p>
+            <a:r>
+              <a:rPr lang="en-US" b="1" dirty="0"/>
+              <a:t>Limitations:</a:t>
+            </a:r>
+          </a:p>
+          <a:p>
+            <a:pPr marL="285750" indent="-285750">
+              <a:buFont typeface="Arial" panose="020B0604020202020204" pitchFamily="34" charset="0"/>
+              <a:buChar char="•"/>
+            </a:pPr>
+            <a:r>
+              <a:rPr lang="en-US" dirty="0"/>
+              <a:t>The lack of certain key features (e.g., renovation, neighborhood amenities)</a:t>
+            </a:r>
+          </a:p>
+          <a:p>
+            <a:pPr marL="285750" indent="-285750">
+              <a:buFont typeface="Arial" panose="020B0604020202020204" pitchFamily="34" charset="0"/>
+              <a:buChar char="•"/>
+            </a:pPr>
+            <a:r>
+              <a:rPr lang="en-US" dirty="0"/>
+              <a:t>High value homes remain difficult to value</a:t>
+            </a:r>
+          </a:p>
+        </p:txBody>
+      </p:sp>
+      <p:sp>
+        <p:nvSpPr>
+          <p:cNvPr id="6" name="Content Placeholder 2">
+            <a:extLst>
+              <a:ext uri="{FF2B5EF4-FFF2-40B4-BE49-F238E27FC236}">
+                <a16:creationId xmlns:a16="http://schemas.microsoft.com/office/drawing/2014/main" id="{0F3C7AA8-5281-1091-3618-E7292DA4A163}"/>
+              </a:ext>
+            </a:extLst>
+          </p:cNvPr>
+          <p:cNvSpPr txBox="1">
+            <a:spLocks/>
+          </p:cNvSpPr>
+          <p:nvPr/>
+        </p:nvSpPr>
+        <p:spPr>
+          <a:xfrm>
+            <a:off x="8042437" y="1560758"/>
+            <a:ext cx="3819652" cy="4160520"/>
+          </a:xfrm>
+          <a:prstGeom prst="rect">
+            <a:avLst/>
+          </a:prstGeom>
+        </p:spPr>
+        <p:txBody>
+          <a:bodyPr vert="horz" lIns="109728" tIns="109728" rIns="109728" bIns="91440" rtlCol="0" anchor="t">
+            <a:normAutofit/>
+          </a:bodyPr>
+          <a:lstStyle>
+            <a:lvl1pPr marL="0" indent="0" algn="l" defTabSz="914400" rtl="0" eaLnBrk="1" latinLnBrk="0" hangingPunct="1">
+              <a:lnSpc>
+                <a:spcPct val="125000"/>
+              </a:lnSpc>
+              <a:spcBef>
+                <a:spcPts val="930"/>
+              </a:spcBef>
+              <a:spcAft>
+                <a:spcPts val="600"/>
+              </a:spcAft>
+              <a:buFont typeface="Corbel" panose="020B0503020204020204" pitchFamily="34" charset="0"/>
+              <a:buNone/>
+              <a:defRPr sz="1800" b="0" kern="1200" spc="150" baseline="0">
+                <a:solidFill>
+                  <a:schemeClr val="tx1">
+                    <a:lumMod val="75000"/>
+                    <a:lumOff val="25000"/>
+                  </a:schemeClr>
+                </a:solidFill>
+                <a:latin typeface="+mn-lt"/>
+                <a:ea typeface="+mn-ea"/>
+                <a:cs typeface="+mn-cs"/>
+              </a:defRPr>
+            </a:lvl1pPr>
+            <a:lvl2pPr marL="0" indent="0" algn="l" defTabSz="914400" rtl="0" eaLnBrk="1" latinLnBrk="0" hangingPunct="1">
+              <a:lnSpc>
+                <a:spcPct val="125000"/>
+              </a:lnSpc>
+              <a:spcBef>
+                <a:spcPts val="930"/>
+              </a:spcBef>
+              <a:spcAft>
+                <a:spcPts val="600"/>
+              </a:spcAft>
+              <a:buFont typeface="Corbel" panose="020B0503020204020204" pitchFamily="34" charset="0"/>
+              <a:buNone/>
+              <a:defRPr sz="1800" kern="1200" spc="150" baseline="0">
+                <a:solidFill>
+                  <a:schemeClr val="tx1">
+                    <a:lumMod val="75000"/>
+                    <a:lumOff val="25000"/>
+                  </a:schemeClr>
+                </a:solidFill>
+                <a:latin typeface="+mn-lt"/>
+                <a:ea typeface="+mn-ea"/>
+                <a:cs typeface="+mn-cs"/>
+              </a:defRPr>
+            </a:lvl2pPr>
+            <a:lvl3pPr marL="0" indent="-320040" algn="l" defTabSz="914400" rtl="0" eaLnBrk="1" latinLnBrk="0" hangingPunct="1">
+              <a:lnSpc>
+                <a:spcPct val="125000"/>
+              </a:lnSpc>
+              <a:spcBef>
+                <a:spcPts val="930"/>
+              </a:spcBef>
+              <a:spcAft>
+                <a:spcPts val="600"/>
+              </a:spcAft>
+              <a:buFont typeface="Corbel" panose="020B0503020204020204" pitchFamily="34" charset="0"/>
+              <a:buChar char="–"/>
+              <a:defRPr sz="1800" i="1" kern="1200" spc="150" baseline="0">
+                <a:solidFill>
+                  <a:schemeClr val="tx1">
+                    <a:lumMod val="75000"/>
+                    <a:lumOff val="25000"/>
+                  </a:schemeClr>
+                </a:solidFill>
+                <a:latin typeface="+mn-lt"/>
+                <a:ea typeface="+mn-ea"/>
+                <a:cs typeface="+mn-cs"/>
+              </a:defRPr>
+            </a:lvl3pPr>
+            <a:lvl4pPr marL="0" indent="-320040" algn="l" defTabSz="914400" rtl="0" eaLnBrk="1" latinLnBrk="0" hangingPunct="1">
+              <a:lnSpc>
+                <a:spcPct val="125000"/>
+              </a:lnSpc>
+              <a:spcBef>
+                <a:spcPts val="930"/>
+              </a:spcBef>
+              <a:spcAft>
+                <a:spcPts val="600"/>
+              </a:spcAft>
+              <a:buFont typeface="Corbel" panose="020B0503020204020204" pitchFamily="34" charset="0"/>
+              <a:buChar char="–"/>
+              <a:defRPr sz="1800" kern="1200" spc="150" baseline="0">
+                <a:solidFill>
+                  <a:schemeClr val="tx1">
+                    <a:lumMod val="75000"/>
+                    <a:lumOff val="25000"/>
+                  </a:schemeClr>
+                </a:solidFill>
+                <a:latin typeface="+mn-lt"/>
+                <a:ea typeface="+mn-ea"/>
+                <a:cs typeface="+mn-cs"/>
+              </a:defRPr>
+            </a:lvl4pPr>
+            <a:lvl5pPr marL="0" indent="-320040" algn="l" defTabSz="914400" rtl="0" eaLnBrk="1" latinLnBrk="0" hangingPunct="1">
+              <a:lnSpc>
+                <a:spcPct val="125000"/>
+              </a:lnSpc>
+              <a:spcBef>
+                <a:spcPts val="930"/>
+              </a:spcBef>
+              <a:spcAft>
+                <a:spcPts val="600"/>
+              </a:spcAft>
+              <a:buFont typeface="Corbel" panose="020B0503020204020204" pitchFamily="34" charset="0"/>
+              <a:buChar char="–"/>
+              <a:defRPr sz="1800" i="1" kern="1200" spc="150" baseline="0">
+                <a:solidFill>
+                  <a:schemeClr val="tx1">
+                    <a:lumMod val="75000"/>
+                    <a:lumOff val="25000"/>
+                  </a:schemeClr>
+                </a:solidFill>
+                <a:latin typeface="+mn-lt"/>
+                <a:ea typeface="+mn-ea"/>
+                <a:cs typeface="+mn-cs"/>
+              </a:defRPr>
+            </a:lvl5pPr>
+            <a:lvl6pPr marL="1920240" indent="-320040" algn="l" defTabSz="914400" rtl="0" eaLnBrk="1" latinLnBrk="0" hangingPunct="1">
+              <a:lnSpc>
+                <a:spcPct val="111000"/>
+              </a:lnSpc>
+              <a:spcBef>
+                <a:spcPts val="930"/>
+              </a:spcBef>
+              <a:buFont typeface="Corbel" panose="020B0503020204020204" pitchFamily="34" charset="0"/>
+              <a:buChar char="–"/>
+              <a:defRPr sz="1400" kern="1200">
+                <a:solidFill>
+                  <a:schemeClr val="accent1">
+                    <a:lumMod val="75000"/>
+                  </a:schemeClr>
+                </a:solidFill>
+                <a:latin typeface="+mn-lt"/>
+                <a:ea typeface="+mn-ea"/>
+                <a:cs typeface="+mn-cs"/>
+              </a:defRPr>
+            </a:lvl6pPr>
+            <a:lvl7pPr marL="2240280" indent="-320040" algn="l" defTabSz="914400" rtl="0" eaLnBrk="1" latinLnBrk="0" hangingPunct="1">
+              <a:lnSpc>
+                <a:spcPct val="111000"/>
+              </a:lnSpc>
+              <a:spcBef>
+                <a:spcPts val="930"/>
+              </a:spcBef>
+              <a:buFont typeface="Corbel" panose="020B0503020204020204" pitchFamily="34" charset="0"/>
+              <a:buChar char="–"/>
+              <a:defRPr sz="1400" i="1" kern="1200">
+                <a:solidFill>
+                  <a:schemeClr val="accent1">
+                    <a:lumMod val="75000"/>
+                  </a:schemeClr>
+                </a:solidFill>
+                <a:latin typeface="+mn-lt"/>
+                <a:ea typeface="+mn-ea"/>
+                <a:cs typeface="+mn-cs"/>
+              </a:defRPr>
+            </a:lvl7pPr>
+            <a:lvl8pPr marL="2560320" indent="-320040" algn="l" defTabSz="914400" rtl="0" eaLnBrk="1" latinLnBrk="0" hangingPunct="1">
+              <a:lnSpc>
+                <a:spcPct val="111000"/>
+              </a:lnSpc>
+              <a:spcBef>
+                <a:spcPts val="930"/>
+              </a:spcBef>
+              <a:buFont typeface="Corbel" panose="020B0503020204020204" pitchFamily="34" charset="0"/>
+              <a:buChar char="–"/>
+              <a:defRPr sz="1400" kern="1200">
+                <a:solidFill>
+                  <a:schemeClr val="accent1">
+                    <a:lumMod val="75000"/>
+                  </a:schemeClr>
+                </a:solidFill>
+                <a:latin typeface="+mn-lt"/>
+                <a:ea typeface="+mn-ea"/>
+                <a:cs typeface="+mn-cs"/>
+              </a:defRPr>
+            </a:lvl8pPr>
+            <a:lvl9pPr marL="2880360" indent="-320040" algn="l" defTabSz="914400" rtl="0" eaLnBrk="1" latinLnBrk="0" hangingPunct="1">
+              <a:lnSpc>
+                <a:spcPct val="111000"/>
+              </a:lnSpc>
+              <a:spcBef>
+                <a:spcPts val="930"/>
+              </a:spcBef>
+              <a:buFont typeface="Corbel" panose="020B0503020204020204" pitchFamily="34" charset="0"/>
+              <a:buChar char="–"/>
+              <a:defRPr sz="1400" i="1" kern="1200">
+                <a:solidFill>
+                  <a:schemeClr val="accent1">
+                    <a:lumMod val="75000"/>
+                  </a:schemeClr>
+                </a:solidFill>
+                <a:latin typeface="+mn-lt"/>
+                <a:ea typeface="+mn-ea"/>
+                <a:cs typeface="+mn-cs"/>
+              </a:defRPr>
+            </a:lvl9pPr>
+          </a:lstStyle>
+          <a:p>
+            <a:r>
+              <a:rPr lang="en-US" b="1" dirty="0"/>
+              <a:t>Future:</a:t>
+            </a:r>
+          </a:p>
+          <a:p>
+            <a:pPr marL="285750" indent="-285750">
+              <a:buFont typeface="Arial" panose="020B0604020202020204" pitchFamily="34" charset="0"/>
+              <a:buChar char="•"/>
+            </a:pPr>
+            <a:r>
+              <a:rPr lang="en-US" dirty="0"/>
+              <a:t>Incorporate more datasets</a:t>
+            </a:r>
+          </a:p>
+          <a:p>
+            <a:pPr marL="285750" indent="-285750">
+              <a:buFont typeface="Arial" panose="020B0604020202020204" pitchFamily="34" charset="0"/>
+              <a:buChar char="•"/>
+            </a:pPr>
+            <a:r>
+              <a:rPr lang="en-US" dirty="0"/>
+              <a:t>Experiment with </a:t>
+            </a:r>
+            <a:r>
+              <a:rPr lang="en-US" dirty="0" err="1"/>
+              <a:t>XGBoost</a:t>
+            </a:r>
+            <a:r>
+              <a:rPr lang="en-US" dirty="0"/>
+              <a:t> for faster training</a:t>
+            </a:r>
+          </a:p>
+          <a:p>
+            <a:pPr marL="285750" indent="-285750">
+              <a:buFont typeface="Arial" panose="020B0604020202020204" pitchFamily="34" charset="0"/>
+              <a:buChar char="•"/>
+            </a:pPr>
+            <a:r>
+              <a:rPr lang="en-US" dirty="0"/>
+              <a:t>Develop a lightweight version for web integration</a:t>
+            </a:r>
+          </a:p>
+        </p:txBody>
+      </p:sp>
+    </p:spTree>
+    <p:extLst>
+      <p:ext uri="{BB962C8B-B14F-4D97-AF65-F5344CB8AC3E}">
+        <p14:creationId xmlns:p14="http://schemas.microsoft.com/office/powerpoint/2010/main" val="3570999243"/>
+      </p:ext>
+    </p:extLst>
+  </p:cSld>
+  <p:clrMapOvr>
+    <a:masterClrMapping/>
+  </p:clrMapOvr>
+</p:sld>
+</file>
+
+<file path=ppt/slides/slide14.xml><?xml version="1.0" encoding="utf-8"?>
 <p:sld xmlns:a="http://schemas.openxmlformats.org/drawingml/2006/main" xmlns:r="http://schemas.openxmlformats.org/officeDocument/2006/relationships" xmlns:p="http://schemas.openxmlformats.org/presentationml/2006/main">
   <p:cSld>
     <p:spTree>
@@ -17321,94 +17480,32 @@
       </p:sp>
       <p:pic>
         <p:nvPicPr>
-          <p:cNvPr id="1028" name="Picture 4" descr="Graphs of Second Degree Polynomials">
-            <a:extLst>
-              <a:ext uri="{FF2B5EF4-FFF2-40B4-BE49-F238E27FC236}">
-                <a16:creationId xmlns:a16="http://schemas.microsoft.com/office/drawing/2014/main" id="{ADE774DC-F809-C837-B338-2D0B196E056E}"/>
+          <p:cNvPr id="5" name="Picture 4">
+            <a:extLst>
+              <a:ext uri="{FF2B5EF4-FFF2-40B4-BE49-F238E27FC236}">
+                <a16:creationId xmlns:a16="http://schemas.microsoft.com/office/drawing/2014/main" id="{C7F3775C-EBC0-256D-E0D9-6E525D933EC5}"/>
               </a:ext>
             </a:extLst>
           </p:cNvPr>
           <p:cNvPicPr>
-            <a:picLocks noChangeAspect="1" noChangeArrowheads="1"/>
+            <a:picLocks noChangeAspect="1"/>
           </p:cNvPicPr>
           <p:nvPr/>
         </p:nvPicPr>
         <p:blipFill>
-          <a:blip r:embed="rId3">
-            <a:extLst>
-              <a:ext uri="{28A0092B-C50C-407E-A947-70E740481C1C}">
-                <a14:useLocalDpi xmlns:a14="http://schemas.microsoft.com/office/drawing/2010/main" val="0"/>
-              </a:ext>
-            </a:extLst>
-          </a:blip>
-          <a:srcRect/>
+          <a:blip r:embed="rId3"/>
           <a:stretch>
             <a:fillRect/>
           </a:stretch>
         </p:blipFill>
-        <p:spPr bwMode="auto">
+        <p:spPr>
           <a:xfrm>
-            <a:off x="1064762" y="3879056"/>
-            <a:ext cx="1517655" cy="1795463"/>
+            <a:off x="88657" y="1771384"/>
+            <a:ext cx="3826118" cy="3552824"/>
           </a:xfrm>
           <a:prstGeom prst="rect">
             <a:avLst/>
           </a:prstGeom>
-          <a:noFill/>
-          <a:extLst>
-            <a:ext uri="{909E8E84-426E-40DD-AFC4-6F175D3DCCD1}">
-              <a14:hiddenFill xmlns:a14="http://schemas.microsoft.com/office/drawing/2010/main">
-                <a:solidFill>
-                  <a:srgbClr val="FFFFFF"/>
-                </a:solidFill>
-              </a14:hiddenFill>
-            </a:ext>
-          </a:extLst>
-        </p:spPr>
-      </p:pic>
-      <p:pic>
-        <p:nvPicPr>
-          <p:cNvPr id="1030" name="Picture 6" descr="Logarithm Graph Investigation – GeoGebra">
-            <a:extLst>
-              <a:ext uri="{FF2B5EF4-FFF2-40B4-BE49-F238E27FC236}">
-                <a16:creationId xmlns:a16="http://schemas.microsoft.com/office/drawing/2014/main" id="{38103DF0-206F-8E74-5EB6-AF75E12DB0E4}"/>
-              </a:ext>
-            </a:extLst>
-          </p:cNvPr>
-          <p:cNvPicPr>
-            <a:picLocks noChangeAspect="1" noChangeArrowheads="1"/>
-          </p:cNvPicPr>
-          <p:nvPr/>
-        </p:nvPicPr>
-        <p:blipFill rotWithShape="1">
-          <a:blip r:embed="rId4">
-            <a:extLst>
-              <a:ext uri="{28A0092B-C50C-407E-A947-70E740481C1C}">
-                <a14:useLocalDpi xmlns:a14="http://schemas.microsoft.com/office/drawing/2010/main" val="0"/>
-              </a:ext>
-            </a:extLst>
-          </a:blip>
-          <a:srcRect l="32500" r="24609"/>
-          <a:stretch/>
-        </p:blipFill>
-        <p:spPr bwMode="auto">
-          <a:xfrm>
-            <a:off x="642919" y="1195387"/>
-            <a:ext cx="2361343" cy="2493963"/>
-          </a:xfrm>
-          <a:prstGeom prst="rect">
-            <a:avLst/>
-          </a:prstGeom>
-          <a:noFill/>
-          <a:extLst>
-            <a:ext uri="{909E8E84-426E-40DD-AFC4-6F175D3DCCD1}">
-              <a14:hiddenFill xmlns:a14="http://schemas.microsoft.com/office/drawing/2010/main">
-                <a:solidFill>
-                  <a:srgbClr val="FFFFFF"/>
-                </a:solidFill>
-              </a14:hiddenFill>
-            </a:ext>
-          </a:extLst>
         </p:spPr>
       </p:pic>
     </p:spTree>
@@ -17446,7 +17543,7 @@
           <p:cNvPr id="2" name="Title 1">
             <a:extLst>
               <a:ext uri="{FF2B5EF4-FFF2-40B4-BE49-F238E27FC236}">
-                <a16:creationId xmlns:a16="http://schemas.microsoft.com/office/drawing/2014/main" id="{E2D30E0F-10C6-298A-C347-E831FFF4ECB8}"/>
+                <a16:creationId xmlns:a16="http://schemas.microsoft.com/office/drawing/2014/main" id="{B82365B0-6F01-248F-71CB-A1F1F4D00EFE}"/>
               </a:ext>
             </a:extLst>
           </p:cNvPr>
@@ -17464,7 +17561,7 @@
           <a:p>
             <a:r>
               <a:rPr lang="en-US" dirty="0"/>
-              <a:t>Model Selection</a:t>
+              <a:t>Model Evaluation Approach</a:t>
             </a:r>
           </a:p>
         </p:txBody>
@@ -17474,7 +17571,7 @@
           <p:cNvPr id="3" name="Content Placeholder 2">
             <a:extLst>
               <a:ext uri="{FF2B5EF4-FFF2-40B4-BE49-F238E27FC236}">
-                <a16:creationId xmlns:a16="http://schemas.microsoft.com/office/drawing/2014/main" id="{41191CC7-9CF2-71F0-1AD4-791EA9CBAD97}"/>
+                <a16:creationId xmlns:a16="http://schemas.microsoft.com/office/drawing/2014/main" id="{3C2E59AD-2BBD-311A-72A0-90E31C3011C0}"/>
               </a:ext>
             </a:extLst>
           </p:cNvPr>
@@ -17492,387 +17589,31 @@
           </a:bodyPr>
           <a:lstStyle/>
           <a:p>
-            <a:r>
-              <a:rPr lang="en-US" dirty="0" err="1"/>
-              <a:t>Asdfasdfasdf</a:t>
-            </a:r>
-            <a:endParaRPr lang="en-US" dirty="0"/>
-          </a:p>
-          <a:p>
-            <a:endParaRPr lang="en-US" dirty="0"/>
-          </a:p>
-          <a:p>
+            <a:pPr marL="342900" indent="-342900">
+              <a:buFont typeface="Arial" panose="020B0604020202020204" pitchFamily="34" charset="0"/>
+              <a:buChar char="•"/>
+            </a:pPr>
             <a:r>
               <a:rPr lang="en-US" dirty="0"/>
-              <a:t>Maybe stats on the models to the right</a:t>
-            </a:r>
-          </a:p>
-        </p:txBody>
-      </p:sp>
-      <p:graphicFrame>
-        <p:nvGraphicFramePr>
-          <p:cNvPr id="11" name="Content Placeholder 10">
-            <a:extLst>
-              <a:ext uri="{FF2B5EF4-FFF2-40B4-BE49-F238E27FC236}">
-                <a16:creationId xmlns:a16="http://schemas.microsoft.com/office/drawing/2014/main" id="{453CE196-36B9-5361-5120-20DF8B3B5581}"/>
-              </a:ext>
-            </a:extLst>
-          </p:cNvPr>
-          <p:cNvGraphicFramePr>
-            <a:graphicFrameLocks noGrp="1"/>
-          </p:cNvGraphicFramePr>
-          <p:nvPr>
-            <p:ph type="tbl" sz="quarter" idx="15"/>
-            <p:extLst>
-              <p:ext uri="{D42A27DB-BD31-4B8C-83A1-F6EECF244321}">
-                <p14:modId xmlns:p14="http://schemas.microsoft.com/office/powerpoint/2010/main" val="3662960558"/>
-              </p:ext>
-            </p:extLst>
-          </p:nvPr>
-        </p:nvGraphicFramePr>
-        <p:xfrm>
-          <a:off x="5075238" y="461963"/>
-          <a:ext cx="6473823" cy="3866324"/>
-        </p:xfrm>
-        <a:graphic>
-          <a:graphicData uri="http://schemas.openxmlformats.org/drawingml/2006/table">
-            <a:tbl>
-              <a:tblPr firstRow="1" bandRow="1">
-                <a:tableStyleId>{8A107856-5554-42FB-B03E-39F5DBC370BA}</a:tableStyleId>
-              </a:tblPr>
-              <a:tblGrid>
-                <a:gridCol w="2038538">
-                  <a:extLst>
-                    <a:ext uri="{9D8B030D-6E8A-4147-A177-3AD203B41FA5}">
-                      <a16:colId xmlns:a16="http://schemas.microsoft.com/office/drawing/2014/main" val="1123561819"/>
-                    </a:ext>
-                  </a:extLst>
-                </a:gridCol>
-                <a:gridCol w="2097154">
-                  <a:extLst>
-                    <a:ext uri="{9D8B030D-6E8A-4147-A177-3AD203B41FA5}">
-                      <a16:colId xmlns:a16="http://schemas.microsoft.com/office/drawing/2014/main" val="1296588374"/>
-                    </a:ext>
-                  </a:extLst>
-                </a:gridCol>
-                <a:gridCol w="1178835">
-                  <a:extLst>
-                    <a:ext uri="{9D8B030D-6E8A-4147-A177-3AD203B41FA5}">
-                      <a16:colId xmlns:a16="http://schemas.microsoft.com/office/drawing/2014/main" val="1285016582"/>
-                    </a:ext>
-                  </a:extLst>
-                </a:gridCol>
-                <a:gridCol w="1159296">
-                  <a:extLst>
-                    <a:ext uri="{9D8B030D-6E8A-4147-A177-3AD203B41FA5}">
-                      <a16:colId xmlns:a16="http://schemas.microsoft.com/office/drawing/2014/main" val="4218447726"/>
-                    </a:ext>
-                  </a:extLst>
-                </a:gridCol>
-              </a:tblGrid>
-              <a:tr h="477078">
-                <a:tc>
-                  <a:txBody>
-                    <a:bodyPr/>
-                    <a:lstStyle/>
-                    <a:p>
-                      <a:r>
-                        <a:rPr lang="en-US" dirty="0"/>
-                        <a:t>NOT FOR USE IN FINAL</a:t>
-                      </a:r>
-                    </a:p>
-                  </a:txBody>
-                  <a:tcPr marT="91440" anchor="ctr"/>
-                </a:tc>
-                <a:tc>
-                  <a:txBody>
-                    <a:bodyPr/>
-                    <a:lstStyle/>
-                    <a:p>
-                      <a:r>
-                        <a:rPr lang="en-US" dirty="0"/>
-                        <a:t>Measurement</a:t>
-                      </a:r>
-                    </a:p>
-                  </a:txBody>
-                  <a:tcPr marT="91440" anchor="ctr"/>
-                </a:tc>
-                <a:tc>
-                  <a:txBody>
-                    <a:bodyPr/>
-                    <a:lstStyle/>
-                    <a:p>
-                      <a:r>
-                        <a:rPr lang="en-US" dirty="0"/>
-                        <a:t>Target</a:t>
-                      </a:r>
-                    </a:p>
-                  </a:txBody>
-                  <a:tcPr marT="91440" anchor="ctr"/>
-                </a:tc>
-                <a:tc>
-                  <a:txBody>
-                    <a:bodyPr/>
-                    <a:lstStyle/>
-                    <a:p>
-                      <a:r>
-                        <a:rPr lang="en-US" dirty="0"/>
-                        <a:t>Actual</a:t>
-                      </a:r>
-                    </a:p>
-                  </a:txBody>
-                  <a:tcPr marT="91440" anchor="ctr"/>
-                </a:tc>
-                <a:extLst>
-                  <a:ext uri="{0D108BD9-81ED-4DB2-BD59-A6C34878D82A}">
-                    <a16:rowId xmlns:a16="http://schemas.microsoft.com/office/drawing/2014/main" val="3342107652"/>
-                  </a:ext>
-                </a:extLst>
-              </a:tr>
-              <a:tr h="795131">
-                <a:tc>
-                  <a:txBody>
-                    <a:bodyPr/>
-                    <a:lstStyle/>
-                    <a:p>
-                      <a:r>
-                        <a:rPr lang="en-US" dirty="0"/>
-                        <a:t>Audience attendance</a:t>
-                      </a:r>
-                    </a:p>
-                  </a:txBody>
-                  <a:tcPr marT="91440" anchor="ctr"/>
-                </a:tc>
-                <a:tc>
-                  <a:txBody>
-                    <a:bodyPr/>
-                    <a:lstStyle/>
-                    <a:p>
-                      <a:r>
-                        <a:rPr lang="en-US" dirty="0"/>
-                        <a:t># of attendees</a:t>
-                      </a:r>
-                    </a:p>
-                  </a:txBody>
-                  <a:tcPr marT="91440" anchor="ctr"/>
-                </a:tc>
-                <a:tc>
-                  <a:txBody>
-                    <a:bodyPr/>
-                    <a:lstStyle/>
-                    <a:p>
-                      <a:r>
-                        <a:rPr lang="en-US" dirty="0"/>
-                        <a:t>150</a:t>
-                      </a:r>
-                    </a:p>
-                  </a:txBody>
-                  <a:tcPr marT="91440" anchor="ctr"/>
-                </a:tc>
-                <a:tc>
-                  <a:txBody>
-                    <a:bodyPr/>
-                    <a:lstStyle/>
-                    <a:p>
-                      <a:r>
-                        <a:rPr lang="en-US" dirty="0"/>
-                        <a:t>120</a:t>
-                      </a:r>
-                    </a:p>
-                  </a:txBody>
-                  <a:tcPr marT="91440" anchor="ctr"/>
-                </a:tc>
-                <a:extLst>
-                  <a:ext uri="{0D108BD9-81ED-4DB2-BD59-A6C34878D82A}">
-                    <a16:rowId xmlns:a16="http://schemas.microsoft.com/office/drawing/2014/main" val="57143556"/>
-                  </a:ext>
-                </a:extLst>
-              </a:tr>
-              <a:tr h="795131">
-                <a:tc>
-                  <a:txBody>
-                    <a:bodyPr/>
-                    <a:lstStyle/>
-                    <a:p>
-                      <a:r>
-                        <a:rPr lang="en-US" dirty="0"/>
-                        <a:t>Engagement duration</a:t>
-                      </a:r>
-                    </a:p>
-                  </a:txBody>
-                  <a:tcPr marT="91440" anchor="ctr"/>
-                </a:tc>
-                <a:tc>
-                  <a:txBody>
-                    <a:bodyPr/>
-                    <a:lstStyle/>
-                    <a:p>
-                      <a:r>
-                        <a:rPr lang="en-US" dirty="0"/>
-                        <a:t>Minutes</a:t>
-                      </a:r>
-                    </a:p>
-                  </a:txBody>
-                  <a:tcPr marT="91440" anchor="ctr"/>
-                </a:tc>
-                <a:tc>
-                  <a:txBody>
-                    <a:bodyPr/>
-                    <a:lstStyle/>
-                    <a:p>
-                      <a:r>
-                        <a:rPr lang="en-US" dirty="0"/>
-                        <a:t>60</a:t>
-                      </a:r>
-                    </a:p>
-                  </a:txBody>
-                  <a:tcPr marT="91440" anchor="ctr"/>
-                </a:tc>
-                <a:tc>
-                  <a:txBody>
-                    <a:bodyPr/>
-                    <a:lstStyle/>
-                    <a:p>
-                      <a:r>
-                        <a:rPr lang="en-US" dirty="0"/>
-                        <a:t>75</a:t>
-                      </a:r>
-                    </a:p>
-                  </a:txBody>
-                  <a:tcPr marT="91440" anchor="ctr"/>
-                </a:tc>
-                <a:extLst>
-                  <a:ext uri="{0D108BD9-81ED-4DB2-BD59-A6C34878D82A}">
-                    <a16:rowId xmlns:a16="http://schemas.microsoft.com/office/drawing/2014/main" val="2328625713"/>
-                  </a:ext>
-                </a:extLst>
-              </a:tr>
-              <a:tr h="795131">
-                <a:tc>
-                  <a:txBody>
-                    <a:bodyPr/>
-                    <a:lstStyle/>
-                    <a:p>
-                      <a:r>
-                        <a:rPr lang="en-US" dirty="0"/>
-                        <a:t>Q&amp;A interaction</a:t>
-                      </a:r>
-                    </a:p>
-                  </a:txBody>
-                  <a:tcPr marT="91440" anchor="ctr"/>
-                </a:tc>
-                <a:tc>
-                  <a:txBody>
-                    <a:bodyPr/>
-                    <a:lstStyle/>
-                    <a:p>
-                      <a:r>
-                        <a:rPr lang="en-US" dirty="0"/>
-                        <a:t># of questions</a:t>
-                      </a:r>
-                    </a:p>
-                  </a:txBody>
-                  <a:tcPr marT="91440" anchor="ctr"/>
-                </a:tc>
-                <a:tc>
-                  <a:txBody>
-                    <a:bodyPr/>
-                    <a:lstStyle/>
-                    <a:p>
-                      <a:r>
-                        <a:rPr lang="en-US" dirty="0"/>
-                        <a:t>10</a:t>
-                      </a:r>
-                    </a:p>
-                  </a:txBody>
-                  <a:tcPr marT="91440" anchor="ctr"/>
-                </a:tc>
-                <a:tc>
-                  <a:txBody>
-                    <a:bodyPr/>
-                    <a:lstStyle/>
-                    <a:p>
-                      <a:r>
-                        <a:rPr lang="en-US" dirty="0"/>
-                        <a:t>15</a:t>
-                      </a:r>
-                    </a:p>
-                  </a:txBody>
-                  <a:tcPr marT="91440" anchor="ctr"/>
-                </a:tc>
-                <a:extLst>
-                  <a:ext uri="{0D108BD9-81ED-4DB2-BD59-A6C34878D82A}">
-                    <a16:rowId xmlns:a16="http://schemas.microsoft.com/office/drawing/2014/main" val="280048660"/>
-                  </a:ext>
-                </a:extLst>
-              </a:tr>
-              <a:tr h="795131">
-                <a:tc>
-                  <a:txBody>
-                    <a:bodyPr/>
-                    <a:lstStyle/>
-                    <a:p>
-                      <a:r>
-                        <a:rPr lang="en-US" dirty="0"/>
-                        <a:t>Positive feedback</a:t>
-                      </a:r>
-                    </a:p>
-                  </a:txBody>
-                  <a:tcPr marT="91440" anchor="ctr"/>
-                </a:tc>
-                <a:tc>
-                  <a:txBody>
-                    <a:bodyPr/>
-                    <a:lstStyle/>
-                    <a:p>
-                      <a:r>
-                        <a:rPr lang="en-US" dirty="0"/>
-                        <a:t>Percentage (%)</a:t>
-                      </a:r>
-                    </a:p>
-                  </a:txBody>
-                  <a:tcPr marT="91440" anchor="ctr"/>
-                </a:tc>
-                <a:tc>
-                  <a:txBody>
-                    <a:bodyPr/>
-                    <a:lstStyle/>
-                    <a:p>
-                      <a:r>
-                        <a:rPr lang="en-US" dirty="0"/>
-                        <a:t>90</a:t>
-                      </a:r>
-                    </a:p>
-                  </a:txBody>
-                  <a:tcPr marT="91440" anchor="ctr"/>
-                </a:tc>
-                <a:tc>
-                  <a:txBody>
-                    <a:bodyPr/>
-                    <a:lstStyle/>
-                    <a:p>
-                      <a:r>
-                        <a:rPr lang="en-US" dirty="0"/>
-                        <a:t>95</a:t>
-                      </a:r>
-                    </a:p>
-                  </a:txBody>
-                  <a:tcPr marT="91440" anchor="ctr"/>
-                </a:tc>
-                <a:extLst>
-                  <a:ext uri="{0D108BD9-81ED-4DB2-BD59-A6C34878D82A}">
-                    <a16:rowId xmlns:a16="http://schemas.microsoft.com/office/drawing/2014/main" val="3515855353"/>
-                  </a:ext>
-                </a:extLst>
-              </a:tr>
-            </a:tbl>
-          </a:graphicData>
-        </a:graphic>
-      </p:graphicFrame>
+              <a:t>Plot validation curves to monitor overfitting or underfitting under various hyperparameter configurations </a:t>
+            </a:r>
+          </a:p>
+          <a:p>
+            <a:pPr marL="342900" indent="-342900">
+              <a:buFont typeface="Arial" panose="020B0604020202020204" pitchFamily="34" charset="0"/>
+              <a:buChar char="•"/>
+            </a:pPr>
+            <a:r>
+              <a:rPr lang="en-US" dirty="0"/>
+              <a:t>Track performance across multiple metrics (RMSE, R², training time).</a:t>
+            </a:r>
+          </a:p>
+        </p:txBody>
+      </p:sp>
     </p:spTree>
     <p:extLst>
       <p:ext uri="{BB962C8B-B14F-4D97-AF65-F5344CB8AC3E}">
-        <p14:creationId xmlns:p14="http://schemas.microsoft.com/office/powerpoint/2010/main" val="2394014735"/>
+        <p14:creationId xmlns:p14="http://schemas.microsoft.com/office/powerpoint/2010/main" val="4217192003"/>
       </p:ext>
     </p:extLst>
   </p:cSld>
@@ -18656,15 +18397,6 @@
 </file>
 
 <file path=customXml/item1.xml><?xml version="1.0" encoding="utf-8"?>
-<?mso-contentType ?>
-<FormTemplates xmlns="http://schemas.microsoft.com/sharepoint/v3/contenttype/forms">
-  <Display>DocumentLibraryForm</Display>
-  <Edit>DocumentLibraryForm</Edit>
-  <New>DocumentLibraryForm</New>
-</FormTemplates>
-</file>
-
-<file path=customXml/item2.xml><?xml version="1.0" encoding="utf-8"?>
 <p:properties xmlns:p="http://schemas.microsoft.com/office/2006/metadata/properties" xmlns:xsi="http://www.w3.org/2001/XMLSchema-instance" xmlns:pc="http://schemas.microsoft.com/office/infopath/2007/PartnerControls">
   <documentManagement>
     <_ip_UnifiedCompliancePolicyUIAction xmlns="http://schemas.microsoft.com/sharepoint/v3" xsi:nil="true"/>
@@ -18682,6 +18414,15 @@
     <MediaServiceKeyPoints xmlns="71af3243-3dd4-4a8d-8c0d-dd76da1f02a5" xsi:nil="true"/>
   </documentManagement>
 </p:properties>
+</file>
+
+<file path=customXml/item2.xml><?xml version="1.0" encoding="utf-8"?>
+<?mso-contentType ?>
+<FormTemplates xmlns="http://schemas.microsoft.com/sharepoint/v3/contenttype/forms">
+  <Display>DocumentLibraryForm</Display>
+  <Edit>DocumentLibraryForm</Edit>
+  <New>DocumentLibraryForm</New>
+</FormTemplates>
 </file>
 
 <file path=customXml/item3.xml><?xml version="1.0" encoding="utf-8"?>
@@ -18997,14 +18738,6 @@
 </file>
 
 <file path=customXml/itemProps1.xml><?xml version="1.0" encoding="utf-8"?>
-<ds:datastoreItem xmlns:ds="http://schemas.openxmlformats.org/officeDocument/2006/customXml" ds:itemID="{6F36CB81-A037-44A8-88EB-C0C0F17FD4B1}">
-  <ds:schemaRefs>
-    <ds:schemaRef ds:uri="http://schemas.microsoft.com/sharepoint/v3/contenttype/forms"/>
-  </ds:schemaRefs>
-</ds:datastoreItem>
-</file>
-
-<file path=customXml/itemProps2.xml><?xml version="1.0" encoding="utf-8"?>
 <ds:datastoreItem xmlns:ds="http://schemas.openxmlformats.org/officeDocument/2006/customXml" ds:itemID="{57FF477C-132F-44F8-8C56-EBFF95FAF97B}">
   <ds:schemaRefs>
     <ds:schemaRef ds:uri="http://schemas.microsoft.com/office/2006/metadata/properties"/>
@@ -19012,6 +18745,14 @@
     <ds:schemaRef ds:uri="http://schemas.microsoft.com/sharepoint/v3"/>
     <ds:schemaRef ds:uri="71af3243-3dd4-4a8d-8c0d-dd76da1f02a5"/>
     <ds:schemaRef ds:uri="230e9df3-be65-4c73-a93b-d1236ebd677e"/>
+  </ds:schemaRefs>
+</ds:datastoreItem>
+</file>
+
+<file path=customXml/itemProps2.xml><?xml version="1.0" encoding="utf-8"?>
+<ds:datastoreItem xmlns:ds="http://schemas.openxmlformats.org/officeDocument/2006/customXml" ds:itemID="{6F36CB81-A037-44A8-88EB-C0C0F17FD4B1}">
+  <ds:schemaRefs>
+    <ds:schemaRef ds:uri="http://schemas.microsoft.com/sharepoint/v3/contenttype/forms"/>
   </ds:schemaRefs>
 </ds:datastoreItem>
 </file>

</xml_diff>

<commit_message>
fixed data rows numbers - Matt
</commit_message>
<xml_diff>
--- a/presentation.pptx
+++ b/presentation.pptx
@@ -257,7 +257,7 @@
           <a:p>
             <a:fld id="{367A1AC4-3AE8-4F87-AAED-904EC6054702}" type="datetimeFigureOut">
               <a:rPr lang="en-US" smtClean="0"/>
-              <a:t>4/26/2025</a:t>
+              <a:t>4/27/2025</a:t>
             </a:fld>
             <a:endParaRPr lang="en-US" dirty="0"/>
           </a:p>
@@ -434,7 +434,7 @@
           <a:p>
             <a:fld id="{C5556653-6123-4FE4-861F-5F9583BF59B0}" type="datetimeFigureOut">
               <a:rPr lang="en-US" smtClean="0"/>
-              <a:t>4/26/2025</a:t>
+              <a:t>4/27/2025</a:t>
             </a:fld>
             <a:endParaRPr lang="en-US" dirty="0"/>
           </a:p>
@@ -11062,7 +11062,7 @@
           <a:p>
             <a:fld id="{005CD215-1C45-48A0-8534-39FFE8A7C95A}" type="datetime1">
               <a:rPr lang="en-US" smtClean="0"/>
-              <a:t>4/26/2025</a:t>
+              <a:t>4/27/2025</a:t>
             </a:fld>
             <a:endParaRPr lang="en-US" dirty="0"/>
           </a:p>
@@ -15564,7 +15564,23 @@
             </a:pPr>
             <a:r>
               <a:rPr lang="en-US" dirty="0"/>
-              <a:t>Size: ~3 million rows before filtering; reduced to ~250,000 after cleaning</a:t>
+              <a:t>Size</a:t>
+            </a:r>
+            <a:r>
+              <a:rPr lang="en-US"/>
+              <a:t>: ~77,000 </a:t>
+            </a:r>
+            <a:r>
+              <a:rPr lang="en-US" dirty="0"/>
+              <a:t>rows before filtering; reduced </a:t>
+            </a:r>
+            <a:r>
+              <a:rPr lang="en-US"/>
+              <a:t>to ~63,000,000 </a:t>
+            </a:r>
+            <a:r>
+              <a:rPr lang="en-US" dirty="0"/>
+              <a:t>after cleaning</a:t>
             </a:r>
           </a:p>
           <a:p>
@@ -18397,6 +18413,15 @@
 </file>
 
 <file path=customXml/item1.xml><?xml version="1.0" encoding="utf-8"?>
+<?mso-contentType ?>
+<FormTemplates xmlns="http://schemas.microsoft.com/sharepoint/v3/contenttype/forms">
+  <Display>DocumentLibraryForm</Display>
+  <Edit>DocumentLibraryForm</Edit>
+  <New>DocumentLibraryForm</New>
+</FormTemplates>
+</file>
+
+<file path=customXml/item2.xml><?xml version="1.0" encoding="utf-8"?>
 <p:properties xmlns:p="http://schemas.microsoft.com/office/2006/metadata/properties" xmlns:xsi="http://www.w3.org/2001/XMLSchema-instance" xmlns:pc="http://schemas.microsoft.com/office/infopath/2007/PartnerControls">
   <documentManagement>
     <_ip_UnifiedCompliancePolicyUIAction xmlns="http://schemas.microsoft.com/sharepoint/v3" xsi:nil="true"/>
@@ -18414,15 +18439,6 @@
     <MediaServiceKeyPoints xmlns="71af3243-3dd4-4a8d-8c0d-dd76da1f02a5" xsi:nil="true"/>
   </documentManagement>
 </p:properties>
-</file>
-
-<file path=customXml/item2.xml><?xml version="1.0" encoding="utf-8"?>
-<?mso-contentType ?>
-<FormTemplates xmlns="http://schemas.microsoft.com/sharepoint/v3/contenttype/forms">
-  <Display>DocumentLibraryForm</Display>
-  <Edit>DocumentLibraryForm</Edit>
-  <New>DocumentLibraryForm</New>
-</FormTemplates>
 </file>
 
 <file path=customXml/item3.xml><?xml version="1.0" encoding="utf-8"?>
@@ -18738,6 +18754,14 @@
 </file>
 
 <file path=customXml/itemProps1.xml><?xml version="1.0" encoding="utf-8"?>
+<ds:datastoreItem xmlns:ds="http://schemas.openxmlformats.org/officeDocument/2006/customXml" ds:itemID="{6F36CB81-A037-44A8-88EB-C0C0F17FD4B1}">
+  <ds:schemaRefs>
+    <ds:schemaRef ds:uri="http://schemas.microsoft.com/sharepoint/v3/contenttype/forms"/>
+  </ds:schemaRefs>
+</ds:datastoreItem>
+</file>
+
+<file path=customXml/itemProps2.xml><?xml version="1.0" encoding="utf-8"?>
 <ds:datastoreItem xmlns:ds="http://schemas.openxmlformats.org/officeDocument/2006/customXml" ds:itemID="{57FF477C-132F-44F8-8C56-EBFF95FAF97B}">
   <ds:schemaRefs>
     <ds:schemaRef ds:uri="http://schemas.microsoft.com/office/2006/metadata/properties"/>
@@ -18745,14 +18769,6 @@
     <ds:schemaRef ds:uri="http://schemas.microsoft.com/sharepoint/v3"/>
     <ds:schemaRef ds:uri="71af3243-3dd4-4a8d-8c0d-dd76da1f02a5"/>
     <ds:schemaRef ds:uri="230e9df3-be65-4c73-a93b-d1236ebd677e"/>
-  </ds:schemaRefs>
-</ds:datastoreItem>
-</file>
-
-<file path=customXml/itemProps2.xml><?xml version="1.0" encoding="utf-8"?>
-<ds:datastoreItem xmlns:ds="http://schemas.openxmlformats.org/officeDocument/2006/customXml" ds:itemID="{6F36CB81-A037-44A8-88EB-C0C0F17FD4B1}">
-  <ds:schemaRefs>
-    <ds:schemaRef ds:uri="http://schemas.microsoft.com/sharepoint/v3/contenttype/forms"/>
   </ds:schemaRefs>
 </ds:datastoreItem>
 </file>

</xml_diff>